<commit_message>
snolab: cut the collection-efficiency talk down to the one figure and its logic
11 main slides instead of 14, one line of logic per slide; the deck stays on
one pulse (ADC / current / power) and follows it to the whole detector. Script
rewritten to match.

Co-Authored-By: Claude Fable 5.1 <noreply@anthropic.com>
Claude-Session: https://claude.ai/code/session_017642NhrahqPyV2kbDPpL5m
</commit_message>
<xml_diff>
--- a/snolab/collection_efficiency/presentation/SNOLAB_R4_collection_efficiency_20260910.pptx
+++ b/snolab/collection_efficiency/presentation/SNOLAB_R4_collection_efficiency_20260910.pptx
@@ -22,11 +22,6 @@
     <p:sldId id="270" r:id="rId22"/>
     <p:sldId id="271" r:id="rId23"/>
     <p:sldId id="272" r:id="rId24"/>
-    <p:sldId id="273" r:id="rId25"/>
-    <p:sldId id="274" r:id="rId26"/>
-    <p:sldId id="275" r:id="rId27"/>
-    <p:sldId id="276" r:id="rId28"/>
-    <p:sldId id="277" r:id="rId29"/>
   </p:sldIdLst>
   <p:sldSz cx="12191695" cy="6858000" type="screen4x3"/>
   <p:notesSz cx="6858000" cy="9144000"/>
@@ -593,7 +588,7 @@
           <a:lstStyle/>
           <a:p>
             <a:r>
-              <a:t>Red filled: fitted-pulse energy, peak 284.8 eV, sigma 42.4 eV (14.9%). Grey outline: official window on the raw trace, 284.2 eV. Dashed: Gaussian fit to the core only, so its centre is the peak, not the mean. Right tail to 600 eV: events near PBS1. 290 events dropped by the NRMSE cut.</a:t>
+              <a:t>Grey: ten channels that fit ≥ 95% of events, 1827 events, 3162 eV = 30.5%, width 7.5% — the position dependence cancels in the sum. PDS2 fits only 42% (the swing) and on those events the other ten channels are 4.8% low, so its share is a bracket: 31.5 to 32.9%. Red line 10.37 keV.</a:t>
             </a:r>
           </a:p>
         </p:txBody>
@@ -663,7 +658,7 @@
           <a:lstStyle/>
           <a:p>
             <a:r>
-              <a:t>PBS1 peak 285 sigma 15%; PFS1 the narrowest 6.8%; PES1 broad tail to 1.4 keV; PDS2 fits only 42% of events, left out of the sum. Right skew: peak below mean everywhere. Sum of the ten core-channel means = 3162 eV; sum of Gaussian peaks would be 21% low.</a:t>
+              <a:t>Chain: current -&gt; power -&gt; energy -&gt; sum -&gt; 32 ± 1%. R37 CUTE note: 26-41%. Open: Z7 only; HV bias unknown (0 V assumed); no dIdV, inductor term dropped; PDS2; 12.5% of events fit nowhere.</a:t>
             </a:r>
           </a:p>
         </p:txBody>
@@ -733,7 +728,7 @@
           <a:lstStyle/>
           <a:p>
             <a:r>
-              <a:t>Grey: ten core channels, 1827 events, mu 3162 eV = 30.5%, sigma 7.5%. Green: all eleven channels but only the 797 events where PDS2 fits, 3263 eV. Adding PDS2 gives a bracket 31.5 to 32.9 because that subsample is biased (its core sum is 4.8% low). Red line 10.37 keV.</a:t>
+              <a:t>Z7 summed PTOFamps, our rebuild with no cut; K line at 2e-6 A.</a:t>
             </a:r>
           </a:p>
         </p:txBody>
@@ -803,7 +798,7 @@
           <a:lstStyle/>
           <a:p>
             <a:r>
-              <a:t>Compare with the CDMS collection-efficiency note on the R37 CUTE tower: 26-41%. Caveats: Z7 only; HV bias of Z7 unknown, all numbers assume 0 V; no dIdV so loop gain and inductance unknown, inductor term dropped; PDS2 artefact; 276 events fit in no channel; official window agrees to 0.6% on the example event.</a:t>
+              <a:t>c2 = 2 Method 1 (used), 1 exact, -1 Method 2. Relative to exact: +0.58%, -1.15%.</a:t>
             </a:r>
           </a:p>
         </p:txBody>
@@ -873,7 +868,7 @@
           <a:lstStyle/>
           <a:p>
             <a:r>
-              <a:t>Chain: current -&gt; power (TES equations) -&gt; energy (closed-form integral of the fit) -&gt; sum over channels -&gt; 32 ± 1%. Next: other detectors, PDS2, HV bias, dIdV.</a:t>
+              <a:t>All 15 example events.</a:t>
             </a:r>
           </a:p>
         </p:txBody>
@@ -943,7 +938,7 @@
           <a:lstStyle/>
           <a:p>
             <a:r>
-              <a:t>c2 = 2 is Method 1 of the CDMS note, c2 = 1 the exact small-signal result, c2 = -1 Method 2. Relative to exact: method 1 +0.58%, method 2 -1.15% in energy on the example event.</a:t>
+              <a:t>Fit vs raw, 15 events.</a:t>
             </a:r>
           </a:p>
         </p:txBody>
@@ -1013,7 +1008,7 @@
           <a:lstStyle/>
           <a:p>
             <a:r>
-              <a:t>What the official quantity does, reverse engineered and matched to 0.2%.</a:t>
+              <a:t>Sum 3419 eV = 33.0%.</a:t>
             </a:r>
           </a:p>
         </p:txBody>
@@ -1083,147 +1078,7 @@
           <a:lstStyle/>
           <a:p>
             <a:r>
-              <a:t>The figure of slides 5 and 6 in one piece.</a:t>
-            </a:r>
-          </a:p>
-        </p:txBody>
-      </p:sp>
-      <p:sp>
-        <p:nvSpPr>
-          <p:cNvPr id="4" name="Slide Number Placeholder 3"/>
-          <p:cNvSpPr>
-            <a:spLocks noGrp="1"/>
-          </p:cNvSpPr>
-          <p:nvPr>
-            <p:ph type="sldNum" idx="5" sz="quarter"/>
-          </p:nvPr>
-        </p:nvSpPr>
-        <p:spPr/>
-      </p:sp>
-    </p:spTree>
-  </p:cSld>
-  <p:clrMapOvr>
-    <a:masterClrMapping/>
-  </p:clrMapOvr>
-</p:notes>
-</file>
-
-<file path=ppt/notesSlides/notesSlide18.xml><?xml version="1.0" encoding="utf-8"?>
-<p:notes xmlns:a="http://schemas.openxmlformats.org/drawingml/2006/main" xmlns:p="http://schemas.openxmlformats.org/presentationml/2006/main" xmlns:r="http://schemas.openxmlformats.org/officeDocument/2006/relationships">
-  <p:cSld>
-    <p:spTree>
-      <p:nvGrpSpPr>
-        <p:cNvPr id="1" name=""/>
-        <p:cNvGrpSpPr/>
-        <p:nvPr/>
-      </p:nvGrpSpPr>
-      <p:grpSpPr>
-        <a:xfrm>
-          <a:off x="0" y="0"/>
-          <a:ext cx="0" cy="0"/>
-          <a:chOff x="0" y="0"/>
-          <a:chExt cx="0" cy="0"/>
-        </a:xfrm>
-      </p:grpSpPr>
-      <p:sp>
-        <p:nvSpPr>
-          <p:cNvPr id="2" name="Slide Image Placeholder 1"/>
-          <p:cNvSpPr>
-            <a:spLocks noGrp="1"/>
-          </p:cNvSpPr>
-          <p:nvPr>
-            <p:ph type="sldImg" idx="2"/>
-          </p:nvPr>
-        </p:nvSpPr>
-        <p:spPr/>
-      </p:sp>
-      <p:sp>
-        <p:nvSpPr>
-          <p:cNvPr id="3" name="Notes Placeholder 2"/>
-          <p:cNvSpPr>
-            <a:spLocks noGrp="1"/>
-          </p:cNvSpPr>
-          <p:nvPr>
-            <p:ph type="body" idx="3" sz="quarter"/>
-          </p:nvPr>
-        </p:nvSpPr>
-        <p:spPr/>
-        <p:txBody>
-          <a:bodyPr/>
-          <a:lstStyle/>
-          <a:p>
-            <a:r>
-              <a:t>All 15 example events of series 24260617_063934.</a:t>
-            </a:r>
-          </a:p>
-        </p:txBody>
-      </p:sp>
-      <p:sp>
-        <p:nvSpPr>
-          <p:cNvPr id="4" name="Slide Number Placeholder 3"/>
-          <p:cNvSpPr>
-            <a:spLocks noGrp="1"/>
-          </p:cNvSpPr>
-          <p:nvPr>
-            <p:ph type="sldNum" idx="5" sz="quarter"/>
-          </p:nvPr>
-        </p:nvSpPr>
-        <p:spPr/>
-      </p:sp>
-    </p:spTree>
-  </p:cSld>
-  <p:clrMapOvr>
-    <a:masterClrMapping/>
-  </p:clrMapOvr>
-</p:notes>
-</file>
-
-<file path=ppt/notesSlides/notesSlide19.xml><?xml version="1.0" encoding="utf-8"?>
-<p:notes xmlns:a="http://schemas.openxmlformats.org/drawingml/2006/main" xmlns:p="http://schemas.openxmlformats.org/presentationml/2006/main" xmlns:r="http://schemas.openxmlformats.org/officeDocument/2006/relationships">
-  <p:cSld>
-    <p:spTree>
-      <p:nvGrpSpPr>
-        <p:cNvPr id="1" name=""/>
-        <p:cNvGrpSpPr/>
-        <p:nvPr/>
-      </p:nvGrpSpPr>
-      <p:grpSpPr>
-        <a:xfrm>
-          <a:off x="0" y="0"/>
-          <a:ext cx="0" cy="0"/>
-          <a:chOff x="0" y="0"/>
-          <a:chExt cx="0" cy="0"/>
-        </a:xfrm>
-      </p:grpSpPr>
-      <p:sp>
-        <p:nvSpPr>
-          <p:cNvPr id="2" name="Slide Image Placeholder 1"/>
-          <p:cNvSpPr>
-            <a:spLocks noGrp="1"/>
-          </p:cNvSpPr>
-          <p:nvPr>
-            <p:ph type="sldImg" idx="2"/>
-          </p:nvPr>
-        </p:nvSpPr>
-        <p:spPr/>
-      </p:sp>
-      <p:sp>
-        <p:nvSpPr>
-          <p:cNvPr id="3" name="Notes Placeholder 2"/>
-          <p:cNvSpPr>
-            <a:spLocks noGrp="1"/>
-          </p:cNvSpPr>
-          <p:nvPr>
-            <p:ph type="body" idx="3" sz="quarter"/>
-          </p:nvPr>
-        </p:nvSpPr>
-        <p:spPr/>
-        <p:txBody>
-          <a:bodyPr/>
-          <a:lstStyle/>
-          <a:p>
-            <a:r>
-              <a:t>Fit vs raw for all 15 example events.</a:t>
+              <a:t>Every channel is right-skewed; the peaks must not be added (21% low), the means add. PDS2 left out.</a:t>
             </a:r>
           </a:p>
         </p:txBody>
@@ -1293,217 +1148,7 @@
           <a:lstStyle/>
           <a:p>
             <a:r>
-              <a:t>Collection efficiency = energy absorbed by the TESs / 10.37 keV. The trace is a current; its integral is a charge, not an energy. So the current must be converted to power with the TES equations first.</a:t>
-            </a:r>
-          </a:p>
-        </p:txBody>
-      </p:sp>
-      <p:sp>
-        <p:nvSpPr>
-          <p:cNvPr id="4" name="Slide Number Placeholder 3"/>
-          <p:cNvSpPr>
-            <a:spLocks noGrp="1"/>
-          </p:cNvSpPr>
-          <p:nvPr>
-            <p:ph type="sldNum" idx="5" sz="quarter"/>
-          </p:nvPr>
-        </p:nvSpPr>
-        <p:spPr/>
-      </p:sp>
-    </p:spTree>
-  </p:cSld>
-  <p:clrMapOvr>
-    <a:masterClrMapping/>
-  </p:clrMapOvr>
-</p:notes>
-</file>
-
-<file path=ppt/notesSlides/notesSlide20.xml><?xml version="1.0" encoding="utf-8"?>
-<p:notes xmlns:a="http://schemas.openxmlformats.org/drawingml/2006/main" xmlns:p="http://schemas.openxmlformats.org/presentationml/2006/main" xmlns:r="http://schemas.openxmlformats.org/officeDocument/2006/relationships">
-  <p:cSld>
-    <p:spTree>
-      <p:nvGrpSpPr>
-        <p:cNvPr id="1" name=""/>
-        <p:cNvGrpSpPr/>
-        <p:nvPr/>
-      </p:nvGrpSpPr>
-      <p:grpSpPr>
-        <a:xfrm>
-          <a:off x="0" y="0"/>
-          <a:ext cx="0" cy="0"/>
-          <a:chOff x="0" y="0"/>
-          <a:chExt cx="0" cy="0"/>
-        </a:xfrm>
-      </p:grpSpPr>
-      <p:sp>
-        <p:nvSpPr>
-          <p:cNvPr id="2" name="Slide Image Placeholder 1"/>
-          <p:cNvSpPr>
-            <a:spLocks noGrp="1"/>
-          </p:cNvSpPr>
-          <p:nvPr>
-            <p:ph type="sldImg" idx="2"/>
-          </p:nvPr>
-        </p:nvSpPr>
-        <p:spPr/>
-      </p:sp>
-      <p:sp>
-        <p:nvSpPr>
-          <p:cNvPr id="3" name="Notes Placeholder 2"/>
-          <p:cNvSpPr>
-            <a:spLocks noGrp="1"/>
-          </p:cNvSpPr>
-          <p:nvPr>
-            <p:ph type="body" idx="3" sz="quarter"/>
-          </p:nvPr>
-        </p:nvSpPr>
-        <p:spPr/>
-        <p:txBody>
-          <a:bodyPr/>
-          <a:lstStyle/>
-          <a:p>
-            <a:r>
-              <a:t>All eleven channels; sum 3419 eV = 33.0%.</a:t>
-            </a:r>
-          </a:p>
-        </p:txBody>
-      </p:sp>
-      <p:sp>
-        <p:nvSpPr>
-          <p:cNvPr id="4" name="Slide Number Placeholder 3"/>
-          <p:cNvSpPr>
-            <a:spLocks noGrp="1"/>
-          </p:cNvSpPr>
-          <p:nvPr>
-            <p:ph type="sldNum" idx="5" sz="quarter"/>
-          </p:nvPr>
-        </p:nvSpPr>
-        <p:spPr/>
-      </p:sp>
-    </p:spTree>
-  </p:cSld>
-  <p:clrMapOvr>
-    <a:masterClrMapping/>
-  </p:clrMapOvr>
-</p:notes>
-</file>
-
-<file path=ppt/notesSlides/notesSlide21.xml><?xml version="1.0" encoding="utf-8"?>
-<p:notes xmlns:a="http://schemas.openxmlformats.org/drawingml/2006/main" xmlns:p="http://schemas.openxmlformats.org/presentationml/2006/main" xmlns:r="http://schemas.openxmlformats.org/officeDocument/2006/relationships">
-  <p:cSld>
-    <p:spTree>
-      <p:nvGrpSpPr>
-        <p:cNvPr id="1" name=""/>
-        <p:cNvGrpSpPr/>
-        <p:nvPr/>
-      </p:nvGrpSpPr>
-      <p:grpSpPr>
-        <a:xfrm>
-          <a:off x="0" y="0"/>
-          <a:ext cx="0" cy="0"/>
-          <a:chOff x="0" y="0"/>
-          <a:chExt cx="0" cy="0"/>
-        </a:xfrm>
-      </p:grpSpPr>
-      <p:sp>
-        <p:nvSpPr>
-          <p:cNvPr id="2" name="Slide Image Placeholder 1"/>
-          <p:cNvSpPr>
-            <a:spLocks noGrp="1"/>
-          </p:cNvSpPr>
-          <p:nvPr>
-            <p:ph type="sldImg" idx="2"/>
-          </p:nvPr>
-        </p:nvSpPr>
-        <p:spPr/>
-      </p:sp>
-      <p:sp>
-        <p:nvSpPr>
-          <p:cNvPr id="3" name="Notes Placeholder 2"/>
-          <p:cNvSpPr>
-            <a:spLocks noGrp="1"/>
-          </p:cNvSpPr>
-          <p:nvPr>
-            <p:ph type="body" idx="3" sz="quarter"/>
-          </p:nvPr>
-        </p:nvSpPr>
-        <p:spPr/>
-        <p:txBody>
-          <a:bodyPr/>
-          <a:lstStyle/>
-          <a:p>
-            <a:r>
-              <a:t>Fit vs raw for every channel; PDS2 swings by ±300 eV.</a:t>
-            </a:r>
-          </a:p>
-        </p:txBody>
-      </p:sp>
-      <p:sp>
-        <p:nvSpPr>
-          <p:cNvPr id="4" name="Slide Number Placeholder 3"/>
-          <p:cNvSpPr>
-            <a:spLocks noGrp="1"/>
-          </p:cNvSpPr>
-          <p:nvPr>
-            <p:ph type="sldNum" idx="5" sz="quarter"/>
-          </p:nvPr>
-        </p:nvSpPr>
-        <p:spPr/>
-      </p:sp>
-    </p:spTree>
-  </p:cSld>
-  <p:clrMapOvr>
-    <a:masterClrMapping/>
-  </p:clrMapOvr>
-</p:notes>
-</file>
-
-<file path=ppt/notesSlides/notesSlide22.xml><?xml version="1.0" encoding="utf-8"?>
-<p:notes xmlns:a="http://schemas.openxmlformats.org/drawingml/2006/main" xmlns:p="http://schemas.openxmlformats.org/presentationml/2006/main" xmlns:r="http://schemas.openxmlformats.org/officeDocument/2006/relationships">
-  <p:cSld>
-    <p:spTree>
-      <p:nvGrpSpPr>
-        <p:cNvPr id="1" name=""/>
-        <p:cNvGrpSpPr/>
-        <p:nvPr/>
-      </p:nvGrpSpPr>
-      <p:grpSpPr>
-        <a:xfrm>
-          <a:off x="0" y="0"/>
-          <a:ext cx="0" cy="0"/>
-          <a:chOff x="0" y="0"/>
-          <a:chExt cx="0" cy="0"/>
-        </a:xfrm>
-      </p:grpSpPr>
-      <p:sp>
-        <p:nvSpPr>
-          <p:cNvPr id="2" name="Slide Image Placeholder 1"/>
-          <p:cNvSpPr>
-            <a:spLocks noGrp="1"/>
-          </p:cNvSpPr>
-          <p:nvPr>
-            <p:ph type="sldImg" idx="2"/>
-          </p:nvPr>
-        </p:nvSpPr>
-        <p:spPr/>
-      </p:sp>
-      <p:sp>
-        <p:nvSpPr>
-          <p:cNvPr id="3" name="Notes Placeholder 2"/>
-          <p:cNvSpPr>
-            <a:spLocks noGrp="1"/>
-          </p:cNvSpPr>
-          <p:nvPr>
-            <p:ph type="body" idx="3" sz="quarter"/>
-          </p:nvPr>
-        </p:nvSpPr>
-        <p:spPr/>
-        <p:txBody>
-          <a:bodyPr/>
-          <a:lstStyle/>
-          <a:p>
-            <a:r>
-              <a:t>All eleven panels; PDS2 marked as left out of the sum.</a:t>
+              <a:t>Efficiency = energy in the TES films / 10.37 keV. The trace is a current; its area is a charge, not an energy. Z7, K-line events of the Ge activation, 2207 events over 30 series, raw traces of all 11 channels saved.</a:t>
             </a:r>
           </a:p>
         </p:txBody>
@@ -1573,7 +1218,7 @@
           <a:lstStyle/>
           <a:p>
             <a:r>
-              <a:t>Z7 summed PTOFamps over 27 series, our own rebuild with no cut; the K line sits at 2e-6 A. K-line events: 2207 over 30 series; raw traces of all channels saved; the bias point of every channel read from detectorConfig.</a:t>
+              <a:t>TES small-signal result (Irwin &amp; Hilton), Method 1 of the CDMS note. Coefficients from the measured bias point of each channel. For a two-exponential pulse the integral is a formula in A, tau_f, tau_r: no window.</a:t>
             </a:r>
           </a:p>
         </p:txBody>
@@ -1643,7 +1288,7 @@
           <a:lstStyle/>
           <a:p>
             <a:r>
-              <a:t>Method 1 of the CDMS collection-efficiency note, from Irwin &amp; Hilton. Linear term dominates; quadratic term about 2%. Constants are measured per channel. ADC to ampere: 3.145728e9 ADC per A, i.e. 1 ADC = 0.318 nA.</a:t>
+              <a:t>Top: the pulse zoomed on its peak, three axes. Bottom: the power and its area. 1 ADC = 0.318 nA. The next two slides walk through the two panels.</a:t>
             </a:r>
           </a:p>
         </p:txBody>
@@ -1713,7 +1358,7 @@
           <a:lstStyle/>
           <a:p>
             <a:r>
-              <a:t>Grey dots raw samples, blue 100 kHz low pass (what the fit sees), green 20 kHz (official Eabs prefilter), red the two-exponential fit. 98 samples within 10% of the peak, so the largest raw sample is the largest noise excursion: 885 vs 717 ADC, 23% high. Filtering reduces the bias, the fit removes it.</a:t>
+              <a:t>Grey raw samples, blue 100 kHz low pass (what the fit sees), green 20 kHz (official prefilter), red the two-exponential fit, pink band fit ± 1 sigma (89 ADC). Yellow: 98 samples within 10% of the peak. Raw max 885 ADC vs fit 717: +23%. The maximum of 98 equal samples is the biggest upward noise. The fit averages every sample.</a:t>
             </a:r>
           </a:p>
         </p:txBody>
@@ -1783,7 +1428,7 @@
           <a:lstStyle/>
           <a:p>
             <a:r>
-              <a:t>Red: power from the fit = linear + quadratic. Quadratic drawn x20 to be visible: 1.91% of peak power, 1.30% of energy. Shaded area = 305.2 eV, 99% inside this window. Bias point printed at the bottom.</a:t>
+              <a:t>Red: power from the fitted current, two terms added. Blue dashed: linear term alone. Purple dotted: quadratic term x20. Peak 104.6 fW = 102.6 + 2.0: quadratic 1.9% of peak, 1.3% of energy. Shaded area 305.2 eV, 99% inside this window. Bottom line: the bias point that fixes the coefficients.</a:t>
             </a:r>
           </a:p>
         </p:txBody>
@@ -1853,7 +1498,7 @@
           <a:lstStyle/>
           <a:p>
             <a:r>
-              <a:t>Left axis current in uA, right axis power in fW tied by the linear coefficient. Dashed navy the fitted current, red the power from it, grey the raw trace for reference. Yellow band the official Eabs window. Energies of the 15 events range 198 to 448 eV in this one channel.</a:t>
+              <a:t>Red from the fit: zero, up within 1 ms, flat; the end equals the formula (green). Grey from the raw trace: drifts, 1 nA over 15 ms is 42 eV. Right: fit 277 eV, raw -169.</a:t>
             </a:r>
           </a:p>
         </p:txBody>
@@ -1923,7 +1568,7 @@
           <a:lstStyle/>
           <a:p>
             <a:r>
-              <a:t>Red: from the fitted pulse, flat before, rises within 1 ms, flat after; the end value equals the closed form (green dashed). Grey: from the raw trace, drifts; for event 210571 it ends at -169 eV against 277 eV from the fit. A 1 nA baseline drift over 15 ms is already 42 eV.</a:t>
+              <a:t>PES1 489 eV, PES2 195 eV: position. Sum over 11 channels 3419 eV = 33.0%. Official window on the raw traces: 3397 eV = 32.8%. PDS2: slow swing after 5 ms, a low-frequency artefact; residual 0.14, three times the others.</a:t>
             </a:r>
           </a:p>
         </p:txBody>
@@ -1993,7 +1638,7 @@
           <a:lstStyle/>
           <a:p>
             <a:r>
-              <a:t>PBS1 305, PES1 489 (largest), PES2 195 (smallest), PDS2 391 but NRMSE 0.14 and the low-frequency swing after 5 ms. Sum over 11 channels 3419 eV = 33.0%; official-window raw sum 3397 eV = 32.8%, 0.6% apart.</a:t>
+              <a:t>Red: fit. Grey outline: official window on the raw trace; same peak to 0.2%. Peak 285 eV, width 42 eV = 15%, for a fixed-energy line. Right tail to 600 eV: events near PBS1. The width is position, not noise.</a:t>
             </a:r>
           </a:p>
         </p:txBody>
@@ -5022,7 +4667,7 @@
           <a:lstStyle/>
           <a:p>
             <a:r>
-              <a:rPr sz="1000">
+              <a:rPr sz="1000" b="0" i="0">
                 <a:solidFill>
                   <a:srgbClr val="666666"/>
                 </a:solidFill>
@@ -5041,8 +4686,8 @@
         </p:nvSpPr>
         <p:spPr>
           <a:xfrm>
-            <a:off x="822960" y="2011680"/>
-            <a:ext cx="10515600" cy="1463040"/>
+            <a:off x="822960" y="2103120"/>
+            <a:ext cx="10515600" cy="1645920"/>
           </a:xfrm>
           <a:prstGeom prst="rect">
             <a:avLst/>
@@ -5056,24 +4701,24 @@
           <a:lstStyle/>
           <a:p>
             <a:r>
-              <a:rPr sz="3400" b="1">
+              <a:rPr sz="4000" b="1" i="0">
                 <a:solidFill>
                   <a:srgbClr val="1F3864"/>
                 </a:solidFill>
                 <a:latin typeface="Arial"/>
               </a:rPr>
-              <a:t>Phonon collection efficiency of Z7 from the 10.37 keV K line</a:t>
-            </a:r>
-          </a:p>
-          <a:p>
-            <a:r>
-              <a:rPr sz="1800">
+              <a:t>Phonon collection efficiency of Z7</a:t>
+            </a:r>
+          </a:p>
+          <a:p>
+            <a:r>
+              <a:rPr sz="1800" b="0" i="0">
                 <a:solidFill>
                   <a:srgbClr val="666666"/>
                 </a:solidFill>
                 <a:latin typeface="Arial"/>
               </a:rPr>
-              <a:t>the energy a K-line event leaves in the TESs, from the fitted current pulse through the TES equations</a:t>
+              <a:t>how much of a 10.37 keV K-line event ends up in the TESs  —  read off one pulse, then followed to the whole detector</a:t>
             </a:r>
           </a:p>
         </p:txBody>
@@ -5086,7 +4731,7 @@
         </p:nvSpPr>
         <p:spPr>
           <a:xfrm>
-            <a:off x="822960" y="4206240"/>
+            <a:off x="822960" y="4297680"/>
             <a:ext cx="10515600" cy="1097280"/>
           </a:xfrm>
           <a:prstGeom prst="rect">
@@ -5101,7 +4746,7 @@
           <a:lstStyle/>
           <a:p>
             <a:r>
-              <a:rPr sz="1600">
+              <a:rPr sz="1600" b="0" i="0">
                 <a:solidFill>
                   <a:srgbClr val="333333"/>
                 </a:solidFill>
@@ -5112,7 +4757,7 @@
           </a:p>
           <a:p>
             <a:r>
-              <a:rPr sz="1300">
+              <a:rPr sz="1300" b="0" i="0">
                 <a:solidFill>
                   <a:srgbClr val="666666"/>
                 </a:solidFill>
@@ -5164,24 +4809,24 @@
           <a:lstStyle/>
           <a:p>
             <a:r>
-              <a:rPr sz="2600" b="1">
+              <a:rPr sz="2700" b="1" i="0">
                 <a:solidFill>
                   <a:srgbClr val="1F3864"/>
                 </a:solidFill>
                 <a:latin typeface="Arial"/>
               </a:rPr>
-              <a:t>Every K-line event, one channel: the energy distribution of PBS1</a:t>
-            </a:r>
-          </a:p>
-          <a:p>
-            <a:r>
-              <a:rPr sz="1400">
+              <a:t>Summed over the channels: 32 ± 1 %</a:t>
+            </a:r>
+          </a:p>
+          <a:p>
+            <a:r>
+              <a:rPr sz="1400" b="0" i="0">
                 <a:solidFill>
                   <a:srgbClr val="666666"/>
                 </a:solidFill>
                 <a:latin typeface="Arial"/>
               </a:rPr>
-              <a:t>1917 events over 30 series; one entry = one event = one fit integrated</a:t>
+              <a:t>the total energy the TESs absorbed per K-line event</a:t>
             </a:r>
           </a:p>
         </p:txBody>
@@ -5252,7 +4897,7 @@
           <a:lstStyle/>
           <a:p>
             <a:r>
-              <a:rPr sz="1000">
+              <a:rPr sz="1000" b="0" i="0">
                 <a:solidFill>
                   <a:srgbClr val="666666"/>
                 </a:solidFill>
@@ -5265,7 +4910,7 @@
       </p:sp>
       <p:pic>
         <p:nvPicPr>
-          <p:cNvPr id="5" name="Picture 4" descr="hist_PBS1.png"/>
+          <p:cNvPr id="5" name="Picture 4" descr="hist_sum.png"/>
           <p:cNvPicPr>
             <a:picLocks noChangeAspect="1"/>
           </p:cNvPicPr>
@@ -5279,8 +4924,8 @@
         </p:blipFill>
         <p:spPr>
           <a:xfrm>
-            <a:off x="502920" y="1426464"/>
-            <a:ext cx="7589520" cy="4553712"/>
+            <a:off x="502920" y="1412748"/>
+            <a:ext cx="7863840" cy="4718304"/>
           </a:xfrm>
           <a:prstGeom prst="rect">
             <a:avLst/>
@@ -5295,8 +4940,8 @@
         </p:nvSpPr>
         <p:spPr>
           <a:xfrm>
-            <a:off x="8229600" y="1143000"/>
-            <a:ext cx="3566160" cy="5212080"/>
+            <a:off x="8549640" y="1463040"/>
+            <a:ext cx="3291840" cy="4572000"/>
           </a:xfrm>
           <a:prstGeom prst="rect">
             <a:avLst/>
@@ -5311,113 +4956,65 @@
           <a:p>
             <a:pPr>
               <a:spcAft>
-                <a:spcPts val="600"/>
+                <a:spcPts val="800"/>
               </a:spcAft>
             </a:pPr>
             <a:r>
-              <a:rPr sz="1200" b="0">
-                <a:solidFill>
-                  <a:srgbClr val="333333"/>
+              <a:rPr sz="1500" b="1" i="0">
+                <a:solidFill>
+                  <a:srgbClr val="C0392B"/>
                 </a:solidFill>
                 <a:latin typeface="Arial"/>
               </a:rPr>
-              <a:t>• Horizontal: energy absorbed in PBS1, 10 eV per bin. Vertical: number of events</a:t>
+              <a:t>Ten channels summed, 1827 events: 3162 eV = 30.5 %, and the width drops to 7.5 % — the position effect cancels.</a:t>
             </a:r>
           </a:p>
           <a:p>
             <a:pPr>
               <a:spcAft>
-                <a:spcPts val="600"/>
+                <a:spcPts val="800"/>
               </a:spcAft>
             </a:pPr>
             <a:r>
-              <a:rPr sz="1200" b="0">
+              <a:rPr sz="1500" b="0" i="0">
                 <a:solidFill>
                   <a:srgbClr val="333333"/>
                 </a:solidFill>
                 <a:latin typeface="Arial"/>
               </a:rPr>
-              <a:t>• Red: from the fitted pulse. Grey outline: the official window on the raw trace. Same peak to 0.2 %</a:t>
+              <a:t>PDS2 fits only 42 % of the events (that slow swing), and those events are not typical; its share can only be bracketed.</a:t>
             </a:r>
           </a:p>
           <a:p>
             <a:pPr>
               <a:spcAft>
-                <a:spcPts val="600"/>
+                <a:spcPts val="800"/>
               </a:spcAft>
             </a:pPr>
             <a:r>
-              <a:rPr sz="1200" b="1">
+              <a:rPr sz="1500" b="1" i="0">
                 <a:solidFill>
                   <a:srgbClr val="C0392B"/>
                 </a:solidFill>
                 <a:latin typeface="Arial"/>
               </a:rPr>
-              <a:t>• Peak 285 eV, width 42 eV = 15 % — for a line whose energy is fixed</a:t>
+              <a:t>Full efficiency 31.5–32.9 %:  32 ± 1 %.</a:t>
             </a:r>
           </a:p>
           <a:p>
             <a:pPr>
               <a:spcAft>
-                <a:spcPts val="600"/>
+                <a:spcPts val="800"/>
               </a:spcAft>
             </a:pPr>
             <a:r>
-              <a:rPr sz="1200" b="0">
+              <a:rPr sz="1500" b="0" i="0">
                 <a:solidFill>
                   <a:srgbClr val="333333"/>
                 </a:solidFill>
                 <a:latin typeface="Arial"/>
               </a:rPr>
-              <a:t>• The dashed curve is a Gaussian fitted to the core only, so μ is the peak position, not the mean</a:t>
-            </a:r>
-          </a:p>
-          <a:p>
-            <a:pPr>
-              <a:spcAft>
-                <a:spcPts val="600"/>
-              </a:spcAft>
-            </a:pPr>
-            <a:r>
-              <a:rPr sz="1200" b="0">
-                <a:solidFill>
-                  <a:srgbClr val="333333"/>
-                </a:solidFill>
-                <a:latin typeface="Arial"/>
-              </a:rPr>
-              <a:t>• The distribution is right-skewed: the tail to 600 eV is events that happened near this channel</a:t>
-            </a:r>
-          </a:p>
-          <a:p>
-            <a:pPr>
-              <a:spcAft>
-                <a:spcPts val="600"/>
-              </a:spcAft>
-            </a:pPr>
-            <a:r>
-              <a:rPr sz="1200" b="0">
-                <a:solidFill>
-                  <a:srgbClr val="333333"/>
-                </a:solidFill>
-                <a:latin typeface="Arial"/>
-              </a:rPr>
-              <a:t>• So one channel's width is mostly event position, not noise — the noise floor of a single fit is a few percent</a:t>
-            </a:r>
-          </a:p>
-          <a:p>
-            <a:pPr>
-              <a:spcAft>
-                <a:spcPts val="600"/>
-              </a:spcAft>
-            </a:pPr>
-            <a:r>
-              <a:rPr sz="1200" b="0">
-                <a:solidFill>
-                  <a:srgbClr val="333333"/>
-                </a:solidFill>
-                <a:latin typeface="Arial"/>
-              </a:rPr>
-              <a:t>• 290 of the 2207 events fail the fit-quality cut in this channel</a:t>
+              <a:t>Red line: 10.37 keV — two thirds of the energy never reaches the TESs.</a:t>
             </a:r>
           </a:p>
         </p:txBody>
@@ -5463,24 +5060,13 @@
           <a:lstStyle/>
           <a:p>
             <a:r>
-              <a:rPr sz="2600" b="1">
+              <a:rPr sz="2700" b="1" i="0">
                 <a:solidFill>
                   <a:srgbClr val="1F3864"/>
                 </a:solidFill>
                 <a:latin typeface="Arial"/>
               </a:rPr>
-              <a:t>Every channel: each is skewed, and the peaks must not be added</a:t>
-            </a:r>
-          </a:p>
-          <a:p>
-            <a:r>
-              <a:rPr sz="1400">
-                <a:solidFill>
-                  <a:srgbClr val="666666"/>
-                </a:solidFill>
-                <a:latin typeface="Arial"/>
-              </a:rPr>
-              <a:t>four of the eleven panels; all eleven in the backup</a:t>
+              <a:t>Summary, and what is still open</a:t>
             </a:r>
           </a:p>
         </p:txBody>
@@ -5551,7 +5137,7 @@
           <a:lstStyle/>
           <a:p>
             <a:r>
-              <a:rPr sz="1000">
+              <a:rPr sz="1000" b="0" i="0">
                 <a:solidFill>
                   <a:srgbClr val="666666"/>
                 </a:solidFill>
@@ -5562,112 +5148,16 @@
           </a:p>
         </p:txBody>
       </p:sp>
-      <p:pic>
-        <p:nvPicPr>
-          <p:cNvPr id="5" name="Picture 4" descr="hist_PBS1_panel.png"/>
-          <p:cNvPicPr>
-            <a:picLocks noChangeAspect="1"/>
-          </p:cNvPicPr>
-          <p:nvPr/>
-        </p:nvPicPr>
-        <p:blipFill>
-          <a:blip r:embed="rId3"/>
-          <a:stretch>
-            <a:fillRect/>
-          </a:stretch>
-        </p:blipFill>
-        <p:spPr>
-          <a:xfrm>
-            <a:off x="502920" y="1231403"/>
-            <a:ext cx="3977639" cy="2337794"/>
-          </a:xfrm>
-          <a:prstGeom prst="rect">
-            <a:avLst/>
-          </a:prstGeom>
-        </p:spPr>
-      </p:pic>
-      <p:pic>
-        <p:nvPicPr>
-          <p:cNvPr id="6" name="Picture 5" descr="hist_PFS1_panel.png"/>
-          <p:cNvPicPr>
-            <a:picLocks noChangeAspect="1"/>
-          </p:cNvPicPr>
-          <p:nvPr/>
-        </p:nvPicPr>
-        <p:blipFill>
-          <a:blip r:embed="rId4"/>
-          <a:stretch>
-            <a:fillRect/>
-          </a:stretch>
-        </p:blipFill>
-        <p:spPr>
-          <a:xfrm>
-            <a:off x="4572000" y="1231403"/>
-            <a:ext cx="3977639" cy="2337794"/>
-          </a:xfrm>
-          <a:prstGeom prst="rect">
-            <a:avLst/>
-          </a:prstGeom>
-        </p:spPr>
-      </p:pic>
-      <p:pic>
-        <p:nvPicPr>
-          <p:cNvPr id="7" name="Picture 6" descr="hist_PES1_panel.png"/>
-          <p:cNvPicPr>
-            <a:picLocks noChangeAspect="1"/>
-          </p:cNvPicPr>
-          <p:nvPr/>
-        </p:nvPicPr>
-        <p:blipFill>
-          <a:blip r:embed="rId5"/>
-          <a:stretch>
-            <a:fillRect/>
-          </a:stretch>
-        </p:blipFill>
-        <p:spPr>
-          <a:xfrm>
-            <a:off x="502920" y="3974545"/>
-            <a:ext cx="3977639" cy="2063587"/>
-          </a:xfrm>
-          <a:prstGeom prst="rect">
-            <a:avLst/>
-          </a:prstGeom>
-        </p:spPr>
-      </p:pic>
-      <p:pic>
-        <p:nvPicPr>
-          <p:cNvPr id="8" name="Picture 7" descr="hist_PDS2_panel.png"/>
-          <p:cNvPicPr>
-            <a:picLocks noChangeAspect="1"/>
-          </p:cNvPicPr>
-          <p:nvPr/>
-        </p:nvPicPr>
-        <p:blipFill>
-          <a:blip r:embed="rId6"/>
-          <a:stretch>
-            <a:fillRect/>
-          </a:stretch>
-        </p:blipFill>
-        <p:spPr>
-          <a:xfrm>
-            <a:off x="4572000" y="3769680"/>
-            <a:ext cx="3977639" cy="2473318"/>
-          </a:xfrm>
-          <a:prstGeom prst="rect">
-            <a:avLst/>
-          </a:prstGeom>
-        </p:spPr>
-      </p:pic>
-      <p:sp>
-        <p:nvSpPr>
-          <p:cNvPr id="9" name="TextBox 8"/>
+      <p:sp>
+        <p:nvSpPr>
+          <p:cNvPr id="5" name="TextBox 4"/>
           <p:cNvSpPr txBox="1"/>
           <p:nvPr/>
         </p:nvSpPr>
         <p:spPr>
           <a:xfrm>
-            <a:off x="8732520" y="1143000"/>
-            <a:ext cx="3108960" cy="5212080"/>
+            <a:off x="502920" y="1325880"/>
+            <a:ext cx="11247120" cy="5029200"/>
           </a:xfrm>
           <a:prstGeom prst="rect">
             <a:avLst/>
@@ -5682,65 +5172,81 @@
           <a:p>
             <a:pPr>
               <a:spcAft>
-                <a:spcPts val="600"/>
+                <a:spcPts val="800"/>
               </a:spcAft>
             </a:pPr>
             <a:r>
-              <a:rPr sz="1150" b="0">
+              <a:rPr sz="1700" b="0" i="0">
                 <a:solidFill>
                   <a:srgbClr val="333333"/>
                 </a:solidFill>
                 <a:latin typeface="Arial"/>
               </a:rPr>
-              <a:t>• Every channel is right-skewed, so its Gaussian peak sits below its mean: PBS1 285 vs 311 eV, PES1 256 vs 358 eV</a:t>
+              <a:t>A current pulse becomes a power pulse through the TES equations; the area under the power is the energy. The quadratic term is 2 %.</a:t>
             </a:r>
           </a:p>
           <a:p>
             <a:pPr>
               <a:spcAft>
-                <a:spcPts val="600"/>
+                <a:spcPts val="800"/>
               </a:spcAft>
             </a:pPr>
             <a:r>
-              <a:rPr sz="1150" b="1">
-                <a:solidFill>
-                  <a:srgbClr val="C0392B"/>
+              <a:rPr sz="1700" b="0" i="0">
+                <a:solidFill>
+                  <a:srgbClr val="333333"/>
                 </a:solidFill>
                 <a:latin typeface="Arial"/>
               </a:rPr>
-              <a:t>• Peaks of skewed distributions do not add — the sum of the eleven peaks is 21 % low. Means do add. The per-event sum on the next slide is the honest quantity</a:t>
+              <a:t>The energy comes from the fitted pulse: no bias from the noisy maximum, no drift, no integration window.</a:t>
             </a:r>
           </a:p>
           <a:p>
             <a:pPr>
               <a:spcAft>
-                <a:spcPts val="600"/>
+                <a:spcPts val="800"/>
               </a:spcAft>
             </a:pPr>
             <a:r>
-              <a:rPr sz="1150" b="0">
+              <a:rPr sz="1700" b="0" i="0">
                 <a:solidFill>
                   <a:srgbClr val="333333"/>
                 </a:solidFill>
                 <a:latin typeface="Arial"/>
               </a:rPr>
-              <a:t>• Widths range from 6.8 % (PFS1) to 27 % (PDS1, PES2): the channels differ in how much of the position spread they see</a:t>
+              <a:t>One channel: 15 % wide and lopsided (position). Ten channels summed: 7.5 % and symmetric.</a:t>
             </a:r>
           </a:p>
           <a:p>
             <a:pPr>
               <a:spcAft>
-                <a:spcPts val="600"/>
+                <a:spcPts val="800"/>
               </a:spcAft>
             </a:pPr>
             <a:r>
-              <a:rPr sz="1150" b="1">
+              <a:rPr sz="1700" b="1" i="0">
                 <a:solidFill>
                   <a:srgbClr val="C0392B"/>
                 </a:solidFill>
                 <a:latin typeface="Arial"/>
               </a:rPr>
-              <a:t>• PDS2 fits only 42 % of the events (the low-frequency artefact fails the residual cut) and is left out of the core sum; ten channels remain, each fitting ≥ 95 % of events</a:t>
+              <a:t>Z7 absorbs 32 ± 1 % of a 10.37 keV event in its TESs. The CDMS note on the R37 CUTE tower reports 26–41 %.</a:t>
+            </a:r>
+          </a:p>
+          <a:p>
+            <a:pPr>
+              <a:spcAft>
+                <a:spcPts val="800"/>
+              </a:spcAft>
+            </a:pPr>
+            <a:r>
+              <a:rPr sz="1700" b="0" i="0">
+                <a:solidFill>
+                  <a:srgbClr val="333333"/>
+                </a:solidFill>
+                <a:latin typeface="Arial"/>
+              </a:rPr>
+              <a:t>Open: Z7 only · the HV bias of Z7 is not established (0 V assumed) · no dI/dV, so the inductor term is dropped · PDS2 is the ± 1 % · 12.5 % of events fit in no channel and are not in the histograms.</a:t>
             </a:r>
           </a:p>
         </p:txBody>
@@ -5786,24 +5292,13 @@
           <a:lstStyle/>
           <a:p>
             <a:r>
-              <a:rPr sz="2600" b="1">
+              <a:rPr sz="2700" b="1" i="0">
                 <a:solidFill>
                   <a:srgbClr val="1F3864"/>
                 </a:solidFill>
                 <a:latin typeface="Arial"/>
               </a:rPr>
-              <a:t>Summed over channels: collection efficiency 32 ± 1 %</a:t>
-            </a:r>
-          </a:p>
-          <a:p>
-            <a:r>
-              <a:rPr sz="1400">
-                <a:solidFill>
-                  <a:srgbClr val="666666"/>
-                </a:solidFill>
-                <a:latin typeface="Arial"/>
-              </a:rPr>
-              <a:t>the total energy the TESs absorbed per K-line event</a:t>
+              <a:t>Backup — the events</a:t>
             </a:r>
           </a:p>
         </p:txBody>
@@ -5874,7 +5369,7 @@
           <a:lstStyle/>
           <a:p>
             <a:r>
-              <a:rPr sz="1000">
+              <a:rPr sz="1000" b="0" i="0">
                 <a:solidFill>
                   <a:srgbClr val="666666"/>
                 </a:solidFill>
@@ -5887,7 +5382,7 @@
       </p:sp>
       <p:pic>
         <p:nvPicPr>
-          <p:cNvPr id="5" name="Picture 4" descr="hist_sum.png"/>
+          <p:cNvPr id="5" name="Picture 4" descr="spectrum_zip7.png"/>
           <p:cNvPicPr>
             <a:picLocks noChangeAspect="1"/>
           </p:cNvPicPr>
@@ -5901,149 +5396,14 @@
         </p:blipFill>
         <p:spPr>
           <a:xfrm>
-            <a:off x="502920" y="1426464"/>
-            <a:ext cx="7589520" cy="4553712"/>
+            <a:off x="991910" y="1143000"/>
+            <a:ext cx="10269140" cy="5257800"/>
           </a:xfrm>
           <a:prstGeom prst="rect">
             <a:avLst/>
           </a:prstGeom>
         </p:spPr>
       </p:pic>
-      <p:sp>
-        <p:nvSpPr>
-          <p:cNvPr id="6" name="TextBox 5"/>
-          <p:cNvSpPr txBox="1"/>
-          <p:nvPr/>
-        </p:nvSpPr>
-        <p:spPr>
-          <a:xfrm>
-            <a:off x="8229600" y="1143000"/>
-            <a:ext cx="3566160" cy="5212080"/>
-          </a:xfrm>
-          <a:prstGeom prst="rect">
-            <a:avLst/>
-          </a:prstGeom>
-          <a:noFill/>
-        </p:spPr>
-        <p:txBody>
-          <a:bodyPr wrap="square">
-            <a:spAutoFit/>
-          </a:bodyPr>
-          <a:lstStyle/>
-          <a:p>
-            <a:pPr>
-              <a:spcAft>
-                <a:spcPts val="600"/>
-              </a:spcAft>
-            </a:pPr>
-            <a:r>
-              <a:rPr sz="1200" b="0">
-                <a:solidFill>
-                  <a:srgbClr val="333333"/>
-                </a:solidFill>
-                <a:latin typeface="Arial"/>
-              </a:rPr>
-              <a:t>• Bottom axis: the summed energy of one event; top axis: the same number as a fraction of 10.37 keV</a:t>
-            </a:r>
-          </a:p>
-          <a:p>
-            <a:pPr>
-              <a:spcAft>
-                <a:spcPts val="600"/>
-              </a:spcAft>
-            </a:pPr>
-            <a:r>
-              <a:rPr sz="1200" b="1">
-                <a:solidFill>
-                  <a:srgbClr val="C0392B"/>
-                </a:solidFill>
-                <a:latin typeface="Arial"/>
-              </a:rPr>
-              <a:t>• Grey: the ten core channels, 1827 events — peak 3162 eV = 30.5 %, width 7.5 %</a:t>
-            </a:r>
-          </a:p>
-          <a:p>
-            <a:pPr>
-              <a:spcAft>
-                <a:spcPts val="600"/>
-              </a:spcAft>
-            </a:pPr>
-            <a:r>
-              <a:rPr sz="1200" b="0">
-                <a:solidFill>
-                  <a:srgbClr val="333333"/>
-                </a:solidFill>
-                <a:latin typeface="Arial"/>
-              </a:rPr>
-              <a:t>• Summing over channels turns the skewed 15–27 % single-channel distributions into a symmetric 7.5 % one: the position dependence cancels</a:t>
-            </a:r>
-          </a:p>
-          <a:p>
-            <a:pPr>
-              <a:spcAft>
-                <a:spcPts val="600"/>
-              </a:spcAft>
-            </a:pPr>
-            <a:r>
-              <a:rPr sz="1200" b="0">
-                <a:solidFill>
-                  <a:srgbClr val="333333"/>
-                </a:solidFill>
-                <a:latin typeface="Arial"/>
-              </a:rPr>
-              <a:t>• Green: all eleven channels, but only the 797 events where PDS2 fits, 3263 eV. That subsample is biased — its ten-channel sum is 4.8 % low — so PDS2's share can only be bracketed</a:t>
-            </a:r>
-          </a:p>
-          <a:p>
-            <a:pPr>
-              <a:spcAft>
-                <a:spcPts val="600"/>
-              </a:spcAft>
-            </a:pPr>
-            <a:r>
-              <a:rPr sz="1200" b="1">
-                <a:solidFill>
-                  <a:srgbClr val="C0392B"/>
-                </a:solidFill>
-                <a:latin typeface="Arial"/>
-              </a:rPr>
-              <a:t>• Full efficiency between 31.5 % and 32.9 %: 32 ± 1 %</a:t>
-            </a:r>
-          </a:p>
-          <a:p>
-            <a:pPr>
-              <a:spcAft>
-                <a:spcPts val="600"/>
-              </a:spcAft>
-            </a:pPr>
-            <a:r>
-              <a:rPr sz="1200" b="0">
-                <a:solidFill>
-                  <a:srgbClr val="333333"/>
-                </a:solidFill>
-                <a:latin typeface="Arial"/>
-              </a:rPr>
-              <a:t>• The way to shrink the bracket is to make PDS2 fittable, not more statistics</a:t>
-            </a:r>
-          </a:p>
-          <a:p>
-            <a:pPr>
-              <a:spcAft>
-                <a:spcPts val="600"/>
-              </a:spcAft>
-            </a:pPr>
-            <a:r>
-              <a:rPr sz="1200" b="0">
-                <a:solidFill>
-                  <a:srgbClr val="333333"/>
-                </a:solidFill>
-                <a:latin typeface="Arial"/>
-              </a:rPr>
-              <a:t>• Red line: 10.37 keV — about two thirds of the energy never reaches the TESs</a:t>
-            </a:r>
-          </a:p>
-        </p:txBody>
-      </p:sp>
     </p:spTree>
   </p:cSld>
   <p:clrMapOvr>
@@ -6085,13 +5445,13 @@
           <a:lstStyle/>
           <a:p>
             <a:r>
-              <a:rPr sz="2600" b="1">
+              <a:rPr sz="2700" b="1" i="0">
                 <a:solidFill>
                   <a:srgbClr val="1F3864"/>
                 </a:solidFill>
                 <a:latin typeface="Arial"/>
               </a:rPr>
-              <a:t>Where 32 % sits, and what is not yet nailed down</a:t>
+              <a:t>Backup — the three versions of the power formula</a:t>
             </a:r>
           </a:p>
         </p:txBody>
@@ -6162,7 +5522,7 @@
           <a:lstStyle/>
           <a:p>
             <a:r>
-              <a:rPr sz="1000">
+              <a:rPr sz="1000" b="0" i="0">
                 <a:solidFill>
                   <a:srgbClr val="666666"/>
                 </a:solidFill>
@@ -6181,8 +5541,8 @@
         </p:nvSpPr>
         <p:spPr>
           <a:xfrm>
-            <a:off x="502920" y="1143000"/>
-            <a:ext cx="11247120" cy="5212080"/>
+            <a:off x="502920" y="1325880"/>
+            <a:ext cx="11247120" cy="5029200"/>
           </a:xfrm>
           <a:prstGeom prst="rect">
             <a:avLst/>
@@ -6197,113 +5557,65 @@
           <a:p>
             <a:pPr>
               <a:spcAft>
-                <a:spcPts val="600"/>
+                <a:spcPts val="800"/>
               </a:spcAft>
             </a:pPr>
             <a:r>
-              <a:rPr sz="1400" b="0">
+              <a:rPr sz="1700" b="0" i="0">
                 <a:solidFill>
                   <a:srgbClr val="333333"/>
                 </a:solidFill>
                 <a:latin typeface="Arial"/>
               </a:rPr>
-              <a:t>• The CDMS collection-efficiency note (R37, CUTE tower) reports Z1 26.2 % / 29.2 % (0 V / 50 V), Z3 40.9 % / 41.2 %, Z6 26.3 % — our 32 % for Z7 falls inside that range</a:t>
+              <a:t>P = I₀(R_L − R₀)·δI + c₂·R_L·(δI)²     with c₂ = 2 (Method 1, used here), 1 (exact small-signal), −1 (Method 2)</a:t>
             </a:r>
           </a:p>
           <a:p>
             <a:pPr>
               <a:spcAft>
-                <a:spcPts val="600"/>
+                <a:spcPts val="800"/>
               </a:spcAft>
             </a:pPr>
             <a:r>
-              <a:rPr sz="1400" b="0">
+              <a:rPr sz="1700" b="0" i="0">
                 <a:solidFill>
                   <a:srgbClr val="333333"/>
                 </a:solidFill>
                 <a:latin typeface="Arial"/>
               </a:rPr>
-              <a:t>• Their method integrates the raw pulse until it has decayed by 90 %; ours integrates the fitted pulse in closed form. On the example event the official window and the fit agree to 0.6 %</a:t>
+              <a:t>Relative to the exact form: Method 1 +0.58 %, Method 2 −1.15 % in energy — far below the 15 % single-channel width and the PDS2 bracket.</a:t>
             </a:r>
           </a:p>
           <a:p>
             <a:pPr>
               <a:spcAft>
-                <a:spcPts val="600"/>
+                <a:spcPts val="800"/>
               </a:spcAft>
             </a:pPr>
             <a:r>
-              <a:rPr sz="1400" b="1">
-                <a:solidFill>
-                  <a:srgbClr val="C0392B"/>
+              <a:rPr sz="1700" b="0" i="0">
+                <a:solidFill>
+                  <a:srgbClr val="333333"/>
                 </a:solidFill>
                 <a:latin typeface="Arial"/>
               </a:rPr>
-              <a:t>• Only Z7 so far. Every other detector needs its own bias points and its own fits — the scripts take the detector number</a:t>
+              <a:t>The inductor term of the full equations needs L and the loop gain from dI/dV, which do not exist for these series on MSI; it is neglected.</a:t>
             </a:r>
           </a:p>
           <a:p>
             <a:pPr>
               <a:spcAft>
-                <a:spcPts val="600"/>
+                <a:spcPts val="800"/>
               </a:spcAft>
             </a:pPr>
             <a:r>
-              <a:rPr sz="1400" b="1">
-                <a:solidFill>
-                  <a:srgbClr val="C0392B"/>
+              <a:rPr sz="1700" b="0" i="0">
+                <a:solidFill>
+                  <a:srgbClr val="333333"/>
                 </a:solidFill>
                 <a:latin typeface="Arial"/>
               </a:rPr>
-              <a:t>• The HV bias of Z7 during these series is not established; all numbers assume 0 V. With a bias, Luke phonons would enlarge the deposited energy and the denominator changes</a:t>
-            </a:r>
-          </a:p>
-          <a:p>
-            <a:pPr>
-              <a:spcAft>
-                <a:spcPts val="600"/>
-              </a:spcAft>
-            </a:pPr>
-            <a:r>
-              <a:rPr sz="1400" b="1">
-                <a:solidFill>
-                  <a:srgbClr val="C0392B"/>
-                </a:solidFill>
-                <a:latin typeface="Arial"/>
-              </a:rPr>
-              <a:t>• No dI/dV data on MSI, so loop gain and inductance are unknown; the small-signal formula drops the inductor term (a fast, small correction) — it could not be checked</a:t>
-            </a:r>
-          </a:p>
-          <a:p>
-            <a:pPr>
-              <a:spcAft>
-                <a:spcPts val="600"/>
-              </a:spcAft>
-            </a:pPr>
-            <a:r>
-              <a:rPr sz="1400" b="0">
-                <a:solidFill>
-                  <a:srgbClr val="333333"/>
-                </a:solidFill>
-                <a:latin typeface="Arial"/>
-              </a:rPr>
-              <a:t>• PDS2's low-frequency artefact is the ±1 %: fixing it collapses the bracket to one number</a:t>
-            </a:r>
-          </a:p>
-          <a:p>
-            <a:pPr>
-              <a:spcAft>
-                <a:spcPts val="600"/>
-              </a:spcAft>
-            </a:pPr>
-            <a:r>
-              <a:rPr sz="1400" b="0">
-                <a:solidFill>
-                  <a:srgbClr val="333333"/>
-                </a:solidFill>
-                <a:latin typeface="Arial"/>
-              </a:rPr>
-              <a:t>• 276 of the 2207 events (12.5 %) fit in no channel at all and are not in the histograms; whether they carry a different energy has not been checked</a:t>
+              <a:t>The official Eabs (trigger bin 16383, baseline bins 93..15758, 5-pole 20 kHz prefilter, window −0.5/+1 ms, same formula) is reproduced to 0.2 %; the grey outlines on the histogram slides are it.</a:t>
             </a:r>
           </a:p>
         </p:txBody>
@@ -6349,13 +5661,13 @@
           <a:lstStyle/>
           <a:p>
             <a:r>
-              <a:rPr sz="2600" b="1">
+              <a:rPr sz="2700" b="1" i="0">
                 <a:solidFill>
                   <a:srgbClr val="1F3864"/>
                 </a:solidFill>
                 <a:latin typeface="Arial"/>
               </a:rPr>
-              <a:t>Summary</a:t>
+              <a:t>Backup — 15 events, fitted current and power (PBS1)</a:t>
             </a:r>
           </a:p>
         </p:txBody>
@@ -6426,7 +5738,7 @@
           <a:lstStyle/>
           <a:p>
             <a:r>
-              <a:rPr sz="1000">
+              <a:rPr sz="1000" b="0" i="0">
                 <a:solidFill>
                   <a:srgbClr val="666666"/>
                 </a:solidFill>
@@ -6437,125 +5749,30 @@
           </a:p>
         </p:txBody>
       </p:sp>
-      <p:sp>
-        <p:nvSpPr>
-          <p:cNvPr id="5" name="TextBox 4"/>
-          <p:cNvSpPr txBox="1"/>
+      <p:pic>
+        <p:nvPicPr>
+          <p:cNvPr id="5" name="Picture 4" descr="pulse_15events.png"/>
+          <p:cNvPicPr>
+            <a:picLocks noChangeAspect="1"/>
+          </p:cNvPicPr>
           <p:nvPr/>
-        </p:nvSpPr>
-        <p:spPr>
-          <a:xfrm>
-            <a:off x="502920" y="1143000"/>
-            <a:ext cx="11247120" cy="5212080"/>
-          </a:xfrm>
-          <a:prstGeom prst="rect">
-            <a:avLst/>
-          </a:prstGeom>
-          <a:noFill/>
-        </p:spPr>
-        <p:txBody>
-          <a:bodyPr wrap="square">
-            <a:spAutoFit/>
-          </a:bodyPr>
-          <a:lstStyle/>
-          <a:p>
-            <a:pPr>
-              <a:spcAft>
-                <a:spcPts val="600"/>
-              </a:spcAft>
-            </a:pPr>
-            <a:r>
-              <a:rPr sz="1500" b="0">
-                <a:solidFill>
-                  <a:srgbClr val="333333"/>
-                </a:solidFill>
-                <a:latin typeface="Arial"/>
-              </a:rPr>
-              <a:t>• The trace is a current. Turned into power with the TES equations (measured bias point per channel), its integral is the absorbed energy; the quadratic term is 2 %</a:t>
-            </a:r>
-          </a:p>
-          <a:p>
-            <a:pPr>
-              <a:spcAft>
-                <a:spcPts val="600"/>
-              </a:spcAft>
-            </a:pPr>
-            <a:r>
-              <a:rPr sz="1500" b="0">
-                <a:solidFill>
-                  <a:srgbClr val="333333"/>
-                </a:solidFill>
-                <a:latin typeface="Arial"/>
-              </a:rPr>
-              <a:t>• The energy is taken from the fitted pulse, not the data: no bias from the noisy maximum, no drift from the baseline, no integration window</a:t>
-            </a:r>
-          </a:p>
-          <a:p>
-            <a:pPr>
-              <a:spcAft>
-                <a:spcPts val="600"/>
-              </a:spcAft>
-            </a:pPr>
-            <a:r>
-              <a:rPr sz="1500" b="0">
-                <a:solidFill>
-                  <a:srgbClr val="333333"/>
-                </a:solidFill>
-                <a:latin typeface="Arial"/>
-              </a:rPr>
-              <a:t>• One channel: a 15 % wide, right-skewed distribution — event position. Summed over ten channels: symmetric, 7.5 % wide</a:t>
-            </a:r>
-          </a:p>
-          <a:p>
-            <a:pPr>
-              <a:spcAft>
-                <a:spcPts val="600"/>
-              </a:spcAft>
-            </a:pPr>
-            <a:r>
-              <a:rPr sz="1500" b="1">
-                <a:solidFill>
-                  <a:srgbClr val="C0392B"/>
-                </a:solidFill>
-                <a:latin typeface="Arial"/>
-              </a:rPr>
-              <a:t>• Z7 absorbs 32 ± 1 % of a 10.37 keV event in its TESs; the ±1 % is PDS2</a:t>
-            </a:r>
-          </a:p>
-          <a:p>
-            <a:pPr>
-              <a:spcAft>
-                <a:spcPts val="600"/>
-              </a:spcAft>
-            </a:pPr>
-            <a:r>
-              <a:rPr sz="1500" b="0">
-                <a:solidFill>
-                  <a:srgbClr val="333333"/>
-                </a:solidFill>
-                <a:latin typeface="Arial"/>
-              </a:rPr>
-              <a:t>• Next: the other twelve detectors; make PDS2 fittable; settle the HV bias; get dI/dV for the loop gain and the inductor term; look at the 12.5 % of events that fit nowhere</a:t>
-            </a:r>
-          </a:p>
-          <a:p>
-            <a:pPr>
-              <a:spcAft>
-                <a:spcPts val="600"/>
-              </a:spcAft>
-            </a:pPr>
-            <a:r>
-              <a:rPr sz="1500" b="0">
-                <a:solidFill>
-                  <a:srgbClr val="333333"/>
-                </a:solidFill>
-                <a:latin typeface="Arial"/>
-              </a:rPr>
-              <a:t>• Code and figures: snolab/collection_efficiency/ (scripts, fit cache, NOTES.md with the derivation)</a:t>
-            </a:r>
-          </a:p>
-        </p:txBody>
-      </p:sp>
+        </p:nvPicPr>
+        <p:blipFill>
+          <a:blip r:embed="rId3"/>
+          <a:stretch>
+            <a:fillRect/>
+          </a:stretch>
+        </p:blipFill>
+        <p:spPr>
+          <a:xfrm>
+            <a:off x="2671354" y="1143000"/>
+            <a:ext cx="6910251" cy="5257800"/>
+          </a:xfrm>
+          <a:prstGeom prst="rect">
+            <a:avLst/>
+          </a:prstGeom>
+        </p:spPr>
+      </p:pic>
     </p:spTree>
   </p:cSld>
   <p:clrMapOvr>
@@ -6597,13 +5814,13 @@
           <a:lstStyle/>
           <a:p>
             <a:r>
-              <a:rPr sz="2600" b="1">
+              <a:rPr sz="2700" b="1" i="0">
                 <a:solidFill>
                   <a:srgbClr val="1F3864"/>
                 </a:solidFill>
                 <a:latin typeface="Arial"/>
               </a:rPr>
-              <a:t>Backup — the three versions of the power formula</a:t>
+              <a:t>Backup — 15 events, cumulative energy (PBS1)</a:t>
             </a:r>
           </a:p>
         </p:txBody>
@@ -6674,7 +5891,7 @@
           <a:lstStyle/>
           <a:p>
             <a:r>
-              <a:rPr sz="1000">
+              <a:rPr sz="1000" b="0" i="0">
                 <a:solidFill>
                   <a:srgbClr val="666666"/>
                 </a:solidFill>
@@ -6685,141 +5902,30 @@
           </a:p>
         </p:txBody>
       </p:sp>
-      <p:sp>
-        <p:nvSpPr>
-          <p:cNvPr id="5" name="TextBox 4"/>
-          <p:cNvSpPr txBox="1"/>
+      <p:pic>
+        <p:nvPicPr>
+          <p:cNvPr id="5" name="Picture 4" descr="cum_15events.png"/>
+          <p:cNvPicPr>
+            <a:picLocks noChangeAspect="1"/>
+          </p:cNvPicPr>
           <p:nvPr/>
-        </p:nvSpPr>
-        <p:spPr>
-          <a:xfrm>
-            <a:off x="502920" y="1143000"/>
-            <a:ext cx="11247120" cy="5212080"/>
-          </a:xfrm>
-          <a:prstGeom prst="rect">
-            <a:avLst/>
-          </a:prstGeom>
-          <a:noFill/>
-        </p:spPr>
-        <p:txBody>
-          <a:bodyPr wrap="square">
-            <a:spAutoFit/>
-          </a:bodyPr>
-          <a:lstStyle/>
-          <a:p>
-            <a:pPr>
-              <a:spcAft>
-                <a:spcPts val="600"/>
-              </a:spcAft>
-            </a:pPr>
-            <a:r>
-              <a:rPr sz="1500" b="0">
-                <a:solidFill>
-                  <a:srgbClr val="333333"/>
-                </a:solidFill>
-                <a:latin typeface="Arial"/>
-              </a:rPr>
-              <a:t>• P = I₀(R_L − R₀)·δI + c₂·R_L·(δI)²</a:t>
-            </a:r>
-          </a:p>
-          <a:p>
-            <a:pPr>
-              <a:spcAft>
-                <a:spcPts val="600"/>
-              </a:spcAft>
-            </a:pPr>
-            <a:r>
-              <a:rPr sz="1300" b="0">
-                <a:solidFill>
-                  <a:srgbClr val="666666"/>
-                </a:solidFill>
-                <a:latin typeface="Arial"/>
-              </a:rPr>
-              <a:t>    – c₂ = 2: Method 1 of the CDMS collection-efficiency note — used throughout this talk</a:t>
-            </a:r>
-          </a:p>
-          <a:p>
-            <a:pPr>
-              <a:spcAft>
-                <a:spcPts val="600"/>
-              </a:spcAft>
-            </a:pPr>
-            <a:r>
-              <a:rPr sz="1300" b="0">
-                <a:solidFill>
-                  <a:srgbClr val="666666"/>
-                </a:solidFill>
-                <a:latin typeface="Arial"/>
-              </a:rPr>
-              <a:t>    – c₂ = 1: the exact small-signal expression from the two TES equations</a:t>
-            </a:r>
-          </a:p>
-          <a:p>
-            <a:pPr>
-              <a:spcAft>
-                <a:spcPts val="600"/>
-              </a:spcAft>
-            </a:pPr>
-            <a:r>
-              <a:rPr sz="1300" b="0">
-                <a:solidFill>
-                  <a:srgbClr val="666666"/>
-                </a:solidFill>
-                <a:latin typeface="Arial"/>
-              </a:rPr>
-              <a:t>    – c₂ = −1: Method 2 of the same note</a:t>
-            </a:r>
-          </a:p>
-          <a:p>
-            <a:pPr>
-              <a:spcAft>
-                <a:spcPts val="600"/>
-              </a:spcAft>
-            </a:pPr>
-            <a:r>
-              <a:rPr sz="1500" b="0">
-                <a:solidFill>
-                  <a:srgbClr val="333333"/>
-                </a:solidFill>
-                <a:latin typeface="Arial"/>
-              </a:rPr>
-              <a:t>• Because the quadratic term is 1.3 % of the energy, the three differ little: relative to the exact form, Method 1 is +0.58 % and Method 2 is −1.15 % on the example event</a:t>
-            </a:r>
-          </a:p>
-          <a:p>
-            <a:pPr>
-              <a:spcAft>
-                <a:spcPts val="600"/>
-              </a:spcAft>
-            </a:pPr>
-            <a:r>
-              <a:rPr sz="1500" b="0">
-                <a:solidFill>
-                  <a:srgbClr val="333333"/>
-                </a:solidFill>
-                <a:latin typeface="Arial"/>
-              </a:rPr>
-              <a:t>• The 15 % single-channel width and the PDS2 bracket are both far larger, so the formula choice is not the limiting uncertainty</a:t>
-            </a:r>
-          </a:p>
-          <a:p>
-            <a:pPr>
-              <a:spcAft>
-                <a:spcPts val="600"/>
-              </a:spcAft>
-            </a:pPr>
-            <a:r>
-              <a:rPr sz="1500" b="0">
-                <a:solidFill>
-                  <a:srgbClr val="333333"/>
-                </a:solidFill>
-                <a:latin typeface="Arial"/>
-              </a:rPr>
-              <a:t>• The inductor term of the full equations is neglected: it needs L and the loop gain from dI/dV, which do not exist for these series on MSI</a:t>
-            </a:r>
-          </a:p>
-        </p:txBody>
-      </p:sp>
+        </p:nvPicPr>
+        <p:blipFill>
+          <a:blip r:embed="rId3"/>
+          <a:stretch>
+            <a:fillRect/>
+          </a:stretch>
+        </p:blipFill>
+        <p:spPr>
+          <a:xfrm>
+            <a:off x="2671354" y="1143000"/>
+            <a:ext cx="6910251" cy="5257800"/>
+          </a:xfrm>
+          <a:prstGeom prst="rect">
+            <a:avLst/>
+          </a:prstGeom>
+        </p:spPr>
+      </p:pic>
     </p:spTree>
   </p:cSld>
   <p:clrMapOvr>
@@ -6861,13 +5967,13 @@
           <a:lstStyle/>
           <a:p>
             <a:r>
-              <a:rPr sz="2600" b="1">
+              <a:rPr sz="2700" b="1" i="0">
                 <a:solidFill>
                   <a:srgbClr val="1F3864"/>
                 </a:solidFill>
                 <a:latin typeface="Arial"/>
               </a:rPr>
-              <a:t>Backup — the official Eabs, reproduced to 0.2 %</a:t>
+              <a:t>Backup — event 30646, all channels</a:t>
             </a:r>
           </a:p>
         </p:txBody>
@@ -6938,7 +6044,7 @@
           <a:lstStyle/>
           <a:p>
             <a:r>
-              <a:rPr sz="1000">
+              <a:rPr sz="1000" b="0" i="0">
                 <a:solidFill>
                   <a:srgbClr val="666666"/>
                 </a:solidFill>
@@ -6949,141 +6055,30 @@
           </a:p>
         </p:txBody>
       </p:sp>
-      <p:sp>
-        <p:nvSpPr>
-          <p:cNvPr id="5" name="TextBox 4"/>
-          <p:cNvSpPr txBox="1"/>
+      <p:pic>
+        <p:nvPicPr>
+          <p:cNvPr id="5" name="Picture 4" descr="allchan_pulses.png"/>
+          <p:cNvPicPr>
+            <a:picLocks noChangeAspect="1"/>
+          </p:cNvPicPr>
           <p:nvPr/>
-        </p:nvSpPr>
-        <p:spPr>
-          <a:xfrm>
-            <a:off x="502920" y="1143000"/>
-            <a:ext cx="11247120" cy="5212080"/>
-          </a:xfrm>
-          <a:prstGeom prst="rect">
-            <a:avLst/>
-          </a:prstGeom>
-          <a:noFill/>
-        </p:spPr>
-        <p:txBody>
-          <a:bodyPr wrap="square">
-            <a:spAutoFit/>
-          </a:bodyPr>
-          <a:lstStyle/>
-          <a:p>
-            <a:pPr>
-              <a:spcAft>
-                <a:spcPts val="600"/>
-              </a:spcAft>
-            </a:pPr>
-            <a:r>
-              <a:rPr sz="1500" b="0">
-                <a:solidFill>
-                  <a:srgbClr val="333333"/>
-                </a:solidFill>
-                <a:latin typeface="Arial"/>
-              </a:rPr>
-              <a:t>• Trigger at bin 16383 of 32768; sample spacing 1.6 µs (52.43 ms per trace)</a:t>
-            </a:r>
-          </a:p>
-          <a:p>
-            <a:pPr>
-              <a:spcAft>
-                <a:spcPts val="600"/>
-              </a:spcAft>
-            </a:pPr>
-            <a:r>
-              <a:rPr sz="1500" b="0">
-                <a:solidFill>
-                  <a:srgbClr val="333333"/>
-                </a:solidFill>
-                <a:latin typeface="Arial"/>
-              </a:rPr>
-              <a:t>• Baseline = mean of bins 93 .. 15758, subtracted</a:t>
-            </a:r>
-          </a:p>
-          <a:p>
-            <a:pPr>
-              <a:spcAft>
-                <a:spcPts val="600"/>
-              </a:spcAft>
-            </a:pPr>
-            <a:r>
-              <a:rPr sz="1500" b="0">
-                <a:solidFill>
-                  <a:srgbClr val="333333"/>
-                </a:solidFill>
-                <a:latin typeface="Arial"/>
-              </a:rPr>
-              <a:t>• Prefilter: 5-pole 20 kHz Butterworth</a:t>
-            </a:r>
-          </a:p>
-          <a:p>
-            <a:pPr>
-              <a:spcAft>
-                <a:spcPts val="600"/>
-              </a:spcAft>
-            </a:pPr>
-            <a:r>
-              <a:rPr sz="1500" b="0">
-                <a:solidFill>
-                  <a:srgbClr val="333333"/>
-                </a:solidFill>
-                <a:latin typeface="Arial"/>
-              </a:rPr>
-              <a:t>• Window: −500 µs to +1000 µs around the trigger (bins 16071 .. 17008)</a:t>
-            </a:r>
-          </a:p>
-          <a:p>
-            <a:pPr>
-              <a:spcAft>
-                <a:spcPts val="600"/>
-              </a:spcAft>
-            </a:pPr>
-            <a:r>
-              <a:rPr sz="1500" b="0">
-                <a:solidFill>
-                  <a:srgbClr val="333333"/>
-                </a:solidFill>
-                <a:latin typeface="Arial"/>
-              </a:rPr>
-              <a:t>• Power from the same Method-1 formula, summed over the window × 1.6 µs</a:t>
-            </a:r>
-          </a:p>
-          <a:p>
-            <a:pPr>
-              <a:spcAft>
-                <a:spcPts val="600"/>
-              </a:spcAft>
-            </a:pPr>
-            <a:r>
-              <a:rPr sz="1500" b="0">
-                <a:solidFill>
-                  <a:srgbClr val="333333"/>
-                </a:solidFill>
-                <a:latin typeface="Arial"/>
-              </a:rPr>
-              <a:t>• Our reproduction matches the official Eabs to 0.2 %; the grey outlines on the histogram slides are this quantity</a:t>
-            </a:r>
-          </a:p>
-          <a:p>
-            <a:pPr>
-              <a:spcAft>
-                <a:spcPts val="600"/>
-              </a:spcAft>
-            </a:pPr>
-            <a:r>
-              <a:rPr sz="1500" b="0">
-                <a:solidFill>
-                  <a:srgbClr val="333333"/>
-                </a:solidFill>
-                <a:latin typeface="Arial"/>
-              </a:rPr>
-              <a:t>• The fitted pulse puts 98–99 % of its energy inside that window on PBS1 (84–99 % over all channels, median 98.8 %) — the window is fine for the fit; what hurts the raw trace is the drift, not the tail</a:t>
-            </a:r>
-          </a:p>
-        </p:txBody>
-      </p:sp>
+        </p:nvPicPr>
+        <p:blipFill>
+          <a:blip r:embed="rId3"/>
+          <a:stretch>
+            <a:fillRect/>
+          </a:stretch>
+        </p:blipFill>
+        <p:spPr>
+          <a:xfrm>
+            <a:off x="502920" y="1758921"/>
+            <a:ext cx="11247120" cy="4025957"/>
+          </a:xfrm>
+          <a:prstGeom prst="rect">
+            <a:avLst/>
+          </a:prstGeom>
+        </p:spPr>
+      </p:pic>
     </p:spTree>
   </p:cSld>
   <p:clrMapOvr>
@@ -7125,13 +6120,13 @@
           <a:lstStyle/>
           <a:p>
             <a:r>
-              <a:rPr sz="2600" b="1">
+              <a:rPr sz="2700" b="1" i="0">
                 <a:solidFill>
                   <a:srgbClr val="1F3864"/>
                 </a:solidFill>
                 <a:latin typeface="Arial"/>
               </a:rPr>
-              <a:t>Backup — the full peak figure</a:t>
+              <a:t>Backup — energy distribution of every channel</a:t>
             </a:r>
           </a:p>
         </p:txBody>
@@ -7202,7 +6197,7 @@
           <a:lstStyle/>
           <a:p>
             <a:r>
-              <a:rPr sz="1000">
+              <a:rPr sz="1000" b="0" i="0">
                 <a:solidFill>
                   <a:srgbClr val="666666"/>
                 </a:solidFill>
@@ -7213,43 +6208,9 @@
           </a:p>
         </p:txBody>
       </p:sp>
-      <p:sp>
-        <p:nvSpPr>
-          <p:cNvPr id="5" name="TextBox 4"/>
-          <p:cNvSpPr txBox="1"/>
-          <p:nvPr/>
-        </p:nvSpPr>
-        <p:spPr>
-          <a:xfrm>
-            <a:off x="502920" y="6446520"/>
-            <a:ext cx="10241280" cy="320040"/>
-          </a:xfrm>
-          <a:prstGeom prst="rect">
-            <a:avLst/>
-          </a:prstGeom>
-          <a:noFill/>
-        </p:spPr>
-        <p:txBody>
-          <a:bodyPr wrap="square">
-            <a:spAutoFit/>
-          </a:bodyPr>
-          <a:lstStyle/>
-          <a:p>
-            <a:r>
-              <a:rPr sz="900">
-                <a:solidFill>
-                  <a:srgbClr val="666666"/>
-                </a:solidFill>
-                <a:latin typeface="Arial"/>
-              </a:rPr>
-              <a:t>collection_efficiency/results/plots/current_power_overlay/</a:t>
-            </a:r>
-          </a:p>
-        </p:txBody>
-      </p:sp>
       <p:pic>
         <p:nvPicPr>
-          <p:cNvPr id="6" name="Picture 5" descr="peak_full.png"/>
+          <p:cNvPr id="5" name="Picture 4" descr="hist_allchan.png"/>
           <p:cNvPicPr>
             <a:picLocks noChangeAspect="1"/>
           </p:cNvPicPr>
@@ -7263,382 +6224,8 @@
         </p:blipFill>
         <p:spPr>
           <a:xfrm>
-            <a:off x="2713966" y="1143000"/>
-            <a:ext cx="6825028" cy="5257800"/>
-          </a:xfrm>
-          <a:prstGeom prst="rect">
-            <a:avLst/>
-          </a:prstGeom>
-        </p:spPr>
-      </p:pic>
-    </p:spTree>
-  </p:cSld>
-  <p:clrMapOvr>
-    <a:masterClrMapping/>
-  </p:clrMapOvr>
-</p:sld>
-</file>
-
-<file path=ppt/slides/slide18.xml><?xml version="1.0" encoding="utf-8"?>
-<p:sld xmlns:a="http://schemas.openxmlformats.org/drawingml/2006/main" xmlns:p="http://schemas.openxmlformats.org/presentationml/2006/main" xmlns:r="http://schemas.openxmlformats.org/officeDocument/2006/relationships">
-  <p:cSld>
-    <p:spTree>
-      <p:nvGrpSpPr>
-        <p:cNvPr id="1" name=""/>
-        <p:cNvGrpSpPr/>
-        <p:nvPr/>
-      </p:nvGrpSpPr>
-      <p:grpSpPr/>
-      <p:sp>
-        <p:nvSpPr>
-          <p:cNvPr id="2" name="TextBox 1"/>
-          <p:cNvSpPr txBox="1"/>
-          <p:nvPr/>
-        </p:nvSpPr>
-        <p:spPr>
-          <a:xfrm>
-            <a:off x="502920" y="228600"/>
-            <a:ext cx="11247120" cy="731520"/>
-          </a:xfrm>
-          <a:prstGeom prst="rect">
-            <a:avLst/>
-          </a:prstGeom>
-          <a:noFill/>
-        </p:spPr>
-        <p:txBody>
-          <a:bodyPr wrap="square">
-            <a:spAutoFit/>
-          </a:bodyPr>
-          <a:lstStyle/>
-          <a:p>
-            <a:r>
-              <a:rPr sz="2600" b="1">
-                <a:solidFill>
-                  <a:srgbClr val="1F3864"/>
-                </a:solidFill>
-                <a:latin typeface="Arial"/>
-              </a:rPr>
-              <a:t>Backup — 15 events, fitted current and power (PBS1)</a:t>
-            </a:r>
-          </a:p>
-        </p:txBody>
-      </p:sp>
-      <p:sp>
-        <p:nvSpPr>
-          <p:cNvPr id="3" name="Rectangle 2"/>
-          <p:cNvSpPr/>
-          <p:nvPr/>
-        </p:nvSpPr>
-        <p:spPr>
-          <a:xfrm>
-            <a:off x="502920" y="969264"/>
-            <a:ext cx="11247120" cy="18000"/>
-          </a:xfrm>
-          <a:prstGeom prst="rect">
-            <a:avLst/>
-          </a:prstGeom>
-          <a:solidFill>
-            <a:srgbClr val="1F3864"/>
-          </a:solidFill>
-          <a:ln>
-            <a:noFill/>
-          </a:ln>
-        </p:spPr>
-        <p:style>
-          <a:lnRef idx="1">
-            <a:schemeClr val="accent1"/>
-          </a:lnRef>
-          <a:fillRef idx="3">
-            <a:schemeClr val="accent1"/>
-          </a:fillRef>
-          <a:effectRef idx="2">
-            <a:schemeClr val="accent1"/>
-          </a:effectRef>
-          <a:fontRef idx="minor">
-            <a:schemeClr val="lt1"/>
-          </a:fontRef>
-        </p:style>
-        <p:txBody>
-          <a:bodyPr rtlCol="0" anchor="ctr"/>
-          <a:lstStyle/>
-          <a:p>
-            <a:pPr algn="ctr"/>
-          </a:p>
-        </p:txBody>
-      </p:sp>
-      <p:sp>
-        <p:nvSpPr>
-          <p:cNvPr id="4" name="TextBox 3"/>
-          <p:cNvSpPr txBox="1"/>
-          <p:nvPr/>
-        </p:nvSpPr>
-        <p:spPr>
-          <a:xfrm>
-            <a:off x="11430000" y="6446520"/>
-            <a:ext cx="548640" cy="320040"/>
-          </a:xfrm>
-          <a:prstGeom prst="rect">
-            <a:avLst/>
-          </a:prstGeom>
-          <a:noFill/>
-        </p:spPr>
-        <p:txBody>
-          <a:bodyPr wrap="square">
-            <a:spAutoFit/>
-          </a:bodyPr>
-          <a:lstStyle/>
-          <a:p>
-            <a:r>
-              <a:rPr sz="1000">
-                <a:solidFill>
-                  <a:srgbClr val="666666"/>
-                </a:solidFill>
-                <a:latin typeface="Arial"/>
-              </a:rPr>
-              <a:t>18</a:t>
-            </a:r>
-          </a:p>
-        </p:txBody>
-      </p:sp>
-      <p:sp>
-        <p:nvSpPr>
-          <p:cNvPr id="5" name="TextBox 4"/>
-          <p:cNvSpPr txBox="1"/>
-          <p:nvPr/>
-        </p:nvSpPr>
-        <p:spPr>
-          <a:xfrm>
-            <a:off x="502920" y="6446520"/>
-            <a:ext cx="10241280" cy="320040"/>
-          </a:xfrm>
-          <a:prstGeom prst="rect">
-            <a:avLst/>
-          </a:prstGeom>
-          <a:noFill/>
-        </p:spPr>
-        <p:txBody>
-          <a:bodyPr wrap="square">
-            <a:spAutoFit/>
-          </a:bodyPr>
-          <a:lstStyle/>
-          <a:p>
-            <a:r>
-              <a:rPr sz="900">
-                <a:solidFill>
-                  <a:srgbClr val="666666"/>
-                </a:solidFill>
-                <a:latin typeface="Arial"/>
-              </a:rPr>
-              <a:t>collection_efficiency/results/plots/current_power_overlay/</a:t>
-            </a:r>
-          </a:p>
-        </p:txBody>
-      </p:sp>
-      <p:pic>
-        <p:nvPicPr>
-          <p:cNvPr id="6" name="Picture 5" descr="pulse_15events.png"/>
-          <p:cNvPicPr>
-            <a:picLocks noChangeAspect="1"/>
-          </p:cNvPicPr>
-          <p:nvPr/>
-        </p:nvPicPr>
-        <p:blipFill>
-          <a:blip r:embed="rId3"/>
-          <a:stretch>
-            <a:fillRect/>
-          </a:stretch>
-        </p:blipFill>
-        <p:spPr>
-          <a:xfrm>
-            <a:off x="2671354" y="1143000"/>
-            <a:ext cx="6910251" cy="5257800"/>
-          </a:xfrm>
-          <a:prstGeom prst="rect">
-            <a:avLst/>
-          </a:prstGeom>
-        </p:spPr>
-      </p:pic>
-    </p:spTree>
-  </p:cSld>
-  <p:clrMapOvr>
-    <a:masterClrMapping/>
-  </p:clrMapOvr>
-</p:sld>
-</file>
-
-<file path=ppt/slides/slide19.xml><?xml version="1.0" encoding="utf-8"?>
-<p:sld xmlns:a="http://schemas.openxmlformats.org/drawingml/2006/main" xmlns:p="http://schemas.openxmlformats.org/presentationml/2006/main" xmlns:r="http://schemas.openxmlformats.org/officeDocument/2006/relationships">
-  <p:cSld>
-    <p:spTree>
-      <p:nvGrpSpPr>
-        <p:cNvPr id="1" name=""/>
-        <p:cNvGrpSpPr/>
-        <p:nvPr/>
-      </p:nvGrpSpPr>
-      <p:grpSpPr/>
-      <p:sp>
-        <p:nvSpPr>
-          <p:cNvPr id="2" name="TextBox 1"/>
-          <p:cNvSpPr txBox="1"/>
-          <p:nvPr/>
-        </p:nvSpPr>
-        <p:spPr>
-          <a:xfrm>
-            <a:off x="502920" y="228600"/>
-            <a:ext cx="11247120" cy="731520"/>
-          </a:xfrm>
-          <a:prstGeom prst="rect">
-            <a:avLst/>
-          </a:prstGeom>
-          <a:noFill/>
-        </p:spPr>
-        <p:txBody>
-          <a:bodyPr wrap="square">
-            <a:spAutoFit/>
-          </a:bodyPr>
-          <a:lstStyle/>
-          <a:p>
-            <a:r>
-              <a:rPr sz="2600" b="1">
-                <a:solidFill>
-                  <a:srgbClr val="1F3864"/>
-                </a:solidFill>
-                <a:latin typeface="Arial"/>
-              </a:rPr>
-              <a:t>Backup — 15 events, cumulative energy (PBS1)</a:t>
-            </a:r>
-          </a:p>
-        </p:txBody>
-      </p:sp>
-      <p:sp>
-        <p:nvSpPr>
-          <p:cNvPr id="3" name="Rectangle 2"/>
-          <p:cNvSpPr/>
-          <p:nvPr/>
-        </p:nvSpPr>
-        <p:spPr>
-          <a:xfrm>
-            <a:off x="502920" y="969264"/>
-            <a:ext cx="11247120" cy="18000"/>
-          </a:xfrm>
-          <a:prstGeom prst="rect">
-            <a:avLst/>
-          </a:prstGeom>
-          <a:solidFill>
-            <a:srgbClr val="1F3864"/>
-          </a:solidFill>
-          <a:ln>
-            <a:noFill/>
-          </a:ln>
-        </p:spPr>
-        <p:style>
-          <a:lnRef idx="1">
-            <a:schemeClr val="accent1"/>
-          </a:lnRef>
-          <a:fillRef idx="3">
-            <a:schemeClr val="accent1"/>
-          </a:fillRef>
-          <a:effectRef idx="2">
-            <a:schemeClr val="accent1"/>
-          </a:effectRef>
-          <a:fontRef idx="minor">
-            <a:schemeClr val="lt1"/>
-          </a:fontRef>
-        </p:style>
-        <p:txBody>
-          <a:bodyPr rtlCol="0" anchor="ctr"/>
-          <a:lstStyle/>
-          <a:p>
-            <a:pPr algn="ctr"/>
-          </a:p>
-        </p:txBody>
-      </p:sp>
-      <p:sp>
-        <p:nvSpPr>
-          <p:cNvPr id="4" name="TextBox 3"/>
-          <p:cNvSpPr txBox="1"/>
-          <p:nvPr/>
-        </p:nvSpPr>
-        <p:spPr>
-          <a:xfrm>
-            <a:off x="11430000" y="6446520"/>
-            <a:ext cx="548640" cy="320040"/>
-          </a:xfrm>
-          <a:prstGeom prst="rect">
-            <a:avLst/>
-          </a:prstGeom>
-          <a:noFill/>
-        </p:spPr>
-        <p:txBody>
-          <a:bodyPr wrap="square">
-            <a:spAutoFit/>
-          </a:bodyPr>
-          <a:lstStyle/>
-          <a:p>
-            <a:r>
-              <a:rPr sz="1000">
-                <a:solidFill>
-                  <a:srgbClr val="666666"/>
-                </a:solidFill>
-                <a:latin typeface="Arial"/>
-              </a:rPr>
-              <a:t>19</a:t>
-            </a:r>
-          </a:p>
-        </p:txBody>
-      </p:sp>
-      <p:sp>
-        <p:nvSpPr>
-          <p:cNvPr id="5" name="TextBox 4"/>
-          <p:cNvSpPr txBox="1"/>
-          <p:nvPr/>
-        </p:nvSpPr>
-        <p:spPr>
-          <a:xfrm>
-            <a:off x="502920" y="6446520"/>
-            <a:ext cx="10241280" cy="320040"/>
-          </a:xfrm>
-          <a:prstGeom prst="rect">
-            <a:avLst/>
-          </a:prstGeom>
-          <a:noFill/>
-        </p:spPr>
-        <p:txBody>
-          <a:bodyPr wrap="square">
-            <a:spAutoFit/>
-          </a:bodyPr>
-          <a:lstStyle/>
-          <a:p>
-            <a:r>
-              <a:rPr sz="900">
-                <a:solidFill>
-                  <a:srgbClr val="666666"/>
-                </a:solidFill>
-                <a:latin typeface="Arial"/>
-              </a:rPr>
-              <a:t>collection_efficiency/results/plots/current_power_overlay/</a:t>
-            </a:r>
-          </a:p>
-        </p:txBody>
-      </p:sp>
-      <p:pic>
-        <p:nvPicPr>
-          <p:cNvPr id="6" name="Picture 5" descr="cum_15events.png"/>
-          <p:cNvPicPr>
-            <a:picLocks noChangeAspect="1"/>
-          </p:cNvPicPr>
-          <p:nvPr/>
-        </p:nvPicPr>
-        <p:blipFill>
-          <a:blip r:embed="rId3"/>
-          <a:stretch>
-            <a:fillRect/>
-          </a:stretch>
-        </p:blipFill>
-        <p:spPr>
-          <a:xfrm>
-            <a:off x="2671354" y="1143000"/>
-            <a:ext cx="6910251" cy="5257800"/>
+            <a:off x="929114" y="1143000"/>
+            <a:ext cx="10394731" cy="5257800"/>
           </a:xfrm>
           <a:prstGeom prst="rect">
             <a:avLst/>
@@ -7686,13 +6273,13 @@
           <a:lstStyle/>
           <a:p>
             <a:r>
-              <a:rPr sz="2600" b="1">
+              <a:rPr sz="2700" b="1" i="0">
                 <a:solidFill>
                   <a:srgbClr val="1F3864"/>
                 </a:solidFill>
                 <a:latin typeface="Arial"/>
               </a:rPr>
-              <a:t>The question, and why the trace alone does not answer it</a:t>
+              <a:t>The question</a:t>
             </a:r>
           </a:p>
         </p:txBody>
@@ -7763,7 +6350,7 @@
           <a:lstStyle/>
           <a:p>
             <a:r>
-              <a:rPr sz="1000">
+              <a:rPr sz="1000" b="0" i="0">
                 <a:solidFill>
                   <a:srgbClr val="666666"/>
                 </a:solidFill>
@@ -7790,8 +6377,8 @@
         </p:blipFill>
         <p:spPr>
           <a:xfrm>
-            <a:off x="851095" y="1143000"/>
-            <a:ext cx="10550769" cy="2286000"/>
+            <a:off x="640080" y="1280160"/>
+            <a:ext cx="10972800" cy="2377440"/>
           </a:xfrm>
           <a:prstGeom prst="rect">
             <a:avLst/>
@@ -7806,8 +6393,8 @@
         </p:nvSpPr>
         <p:spPr>
           <a:xfrm>
-            <a:off x="502920" y="3611880"/>
-            <a:ext cx="11247120" cy="2743200"/>
+            <a:off x="502920" y="3931920"/>
+            <a:ext cx="11247120" cy="2468880"/>
           </a:xfrm>
           <a:prstGeom prst="rect">
             <a:avLst/>
@@ -7822,646 +6409,69 @@
           <a:p>
             <a:pPr>
               <a:spcAft>
-                <a:spcPts val="600"/>
+                <a:spcPts val="800"/>
               </a:spcAft>
             </a:pPr>
             <a:r>
-              <a:rPr sz="1600" b="0">
+              <a:rPr sz="1800" b="0" i="0">
                 <a:solidFill>
                   <a:srgbClr val="333333"/>
                 </a:solidFill>
                 <a:latin typeface="Arial"/>
               </a:rPr>
-              <a:t>• Collection efficiency = the energy that ends up in the TES films ÷ the 10.37 keV the event deposited</a:t>
+              <a:t>Collection efficiency  =  energy that reaches the TES films  ÷  the 10.37 keV of the event</a:t>
             </a:r>
           </a:p>
           <a:p>
             <a:pPr>
               <a:spcAft>
-                <a:spcPts val="600"/>
+                <a:spcPts val="800"/>
               </a:spcAft>
             </a:pPr>
             <a:r>
-              <a:rPr sz="1600" b="0">
+              <a:rPr sz="1800" b="0" i="0">
                 <a:solidFill>
                   <a:srgbClr val="333333"/>
                 </a:solidFill>
                 <a:latin typeface="Arial"/>
               </a:rPr>
-              <a:t>• What we record is a current: the TES current changes by δI(t) when phonons heat the film</a:t>
+              <a:t>What we record is a current pulse.</a:t>
             </a:r>
           </a:p>
           <a:p>
             <a:pPr>
               <a:spcAft>
-                <a:spcPts val="600"/>
+                <a:spcPts val="800"/>
               </a:spcAft>
             </a:pPr>
             <a:r>
-              <a:rPr sz="1600" b="1">
+              <a:rPr sz="1800" b="1" i="0">
                 <a:solidFill>
                   <a:srgbClr val="C0392B"/>
                 </a:solidFill>
                 <a:latin typeface="Arial"/>
               </a:rPr>
-              <a:t>• The area under the current trace is a charge, not an energy — it cannot be compared with 10.37 keV</a:t>
+              <a:t>The area under a current is a charge, not an energy — so the pulse must be turned into power first.</a:t>
             </a:r>
           </a:p>
           <a:p>
             <a:pPr>
               <a:spcAft>
-                <a:spcPts val="600"/>
+                <a:spcPts val="800"/>
               </a:spcAft>
             </a:pPr>
             <a:r>
-              <a:rPr sz="1600" b="0">
+              <a:rPr sz="1800" b="0" i="0">
                 <a:solidFill>
                   <a:srgbClr val="333333"/>
                 </a:solidFill>
                 <a:latin typeface="Arial"/>
               </a:rPr>
-              <a:t>• So the current pulse has to be turned into a power pulse first, using the TES equations; the area under the power pulse is the energy</a:t>
-            </a:r>
-          </a:p>
-          <a:p>
-            <a:pPr>
-              <a:spcAft>
-                <a:spcPts val="600"/>
-              </a:spcAft>
-            </a:pPr>
-            <a:r>
-              <a:rPr sz="1600" b="0">
-                <a:solidFill>
-                  <a:srgbClr val="333333"/>
-                </a:solidFill>
-                <a:latin typeface="Arial"/>
-              </a:rPr>
-              <a:t>• Everything today is one detector, Z7 (the quietest one), and the K-line events of the Ge activation run</a:t>
-            </a:r>
-          </a:p>
-        </p:txBody>
-      </p:sp>
-    </p:spTree>
-  </p:cSld>
-  <p:clrMapOvr>
-    <a:masterClrMapping/>
-  </p:clrMapOvr>
-</p:sld>
-</file>
-
-<file path=ppt/slides/slide20.xml><?xml version="1.0" encoding="utf-8"?>
-<p:sld xmlns:a="http://schemas.openxmlformats.org/drawingml/2006/main" xmlns:p="http://schemas.openxmlformats.org/presentationml/2006/main" xmlns:r="http://schemas.openxmlformats.org/officeDocument/2006/relationships">
-  <p:cSld>
-    <p:spTree>
-      <p:nvGrpSpPr>
-        <p:cNvPr id="1" name=""/>
-        <p:cNvGrpSpPr/>
-        <p:nvPr/>
-      </p:nvGrpSpPr>
-      <p:grpSpPr/>
-      <p:sp>
-        <p:nvSpPr>
-          <p:cNvPr id="2" name="TextBox 1"/>
-          <p:cNvSpPr txBox="1"/>
-          <p:nvPr/>
-        </p:nvSpPr>
-        <p:spPr>
-          <a:xfrm>
-            <a:off x="502920" y="228600"/>
-            <a:ext cx="11247120" cy="731520"/>
-          </a:xfrm>
-          <a:prstGeom prst="rect">
-            <a:avLst/>
-          </a:prstGeom>
-          <a:noFill/>
-        </p:spPr>
-        <p:txBody>
-          <a:bodyPr wrap="square">
-            <a:spAutoFit/>
-          </a:bodyPr>
-          <a:lstStyle/>
-          <a:p>
-            <a:r>
-              <a:rPr sz="2600" b="1">
-                <a:solidFill>
-                  <a:srgbClr val="1F3864"/>
-                </a:solidFill>
-                <a:latin typeface="Arial"/>
-              </a:rPr>
-              <a:t>Backup — event 30646, all channels, current and power</a:t>
-            </a:r>
-          </a:p>
-        </p:txBody>
-      </p:sp>
-      <p:sp>
-        <p:nvSpPr>
-          <p:cNvPr id="3" name="Rectangle 2"/>
-          <p:cNvSpPr/>
-          <p:nvPr/>
-        </p:nvSpPr>
-        <p:spPr>
-          <a:xfrm>
-            <a:off x="502920" y="969264"/>
-            <a:ext cx="11247120" cy="18000"/>
-          </a:xfrm>
-          <a:prstGeom prst="rect">
-            <a:avLst/>
-          </a:prstGeom>
-          <a:solidFill>
-            <a:srgbClr val="1F3864"/>
-          </a:solidFill>
-          <a:ln>
-            <a:noFill/>
-          </a:ln>
-        </p:spPr>
-        <p:style>
-          <a:lnRef idx="1">
-            <a:schemeClr val="accent1"/>
-          </a:lnRef>
-          <a:fillRef idx="3">
-            <a:schemeClr val="accent1"/>
-          </a:fillRef>
-          <a:effectRef idx="2">
-            <a:schemeClr val="accent1"/>
-          </a:effectRef>
-          <a:fontRef idx="minor">
-            <a:schemeClr val="lt1"/>
-          </a:fontRef>
-        </p:style>
-        <p:txBody>
-          <a:bodyPr rtlCol="0" anchor="ctr"/>
-          <a:lstStyle/>
-          <a:p>
-            <a:pPr algn="ctr"/>
-          </a:p>
-        </p:txBody>
-      </p:sp>
-      <p:sp>
-        <p:nvSpPr>
-          <p:cNvPr id="4" name="TextBox 3"/>
-          <p:cNvSpPr txBox="1"/>
-          <p:nvPr/>
-        </p:nvSpPr>
-        <p:spPr>
-          <a:xfrm>
-            <a:off x="11430000" y="6446520"/>
-            <a:ext cx="548640" cy="320040"/>
-          </a:xfrm>
-          <a:prstGeom prst="rect">
-            <a:avLst/>
-          </a:prstGeom>
-          <a:noFill/>
-        </p:spPr>
-        <p:txBody>
-          <a:bodyPr wrap="square">
-            <a:spAutoFit/>
-          </a:bodyPr>
-          <a:lstStyle/>
-          <a:p>
-            <a:r>
-              <a:rPr sz="1000">
-                <a:solidFill>
-                  <a:srgbClr val="666666"/>
-                </a:solidFill>
-                <a:latin typeface="Arial"/>
-              </a:rPr>
-              <a:t>20</a:t>
-            </a:r>
-          </a:p>
-        </p:txBody>
-      </p:sp>
-      <p:sp>
-        <p:nvSpPr>
-          <p:cNvPr id="5" name="TextBox 4"/>
-          <p:cNvSpPr txBox="1"/>
-          <p:nvPr/>
-        </p:nvSpPr>
-        <p:spPr>
-          <a:xfrm>
-            <a:off x="502920" y="6446520"/>
-            <a:ext cx="10241280" cy="320040"/>
-          </a:xfrm>
-          <a:prstGeom prst="rect">
-            <a:avLst/>
-          </a:prstGeom>
-          <a:noFill/>
-        </p:spPr>
-        <p:txBody>
-          <a:bodyPr wrap="square">
-            <a:spAutoFit/>
-          </a:bodyPr>
-          <a:lstStyle/>
-          <a:p>
-            <a:r>
-              <a:rPr sz="900">
-                <a:solidFill>
-                  <a:srgbClr val="666666"/>
-                </a:solidFill>
-                <a:latin typeface="Arial"/>
-              </a:rPr>
-              <a:t>collection_efficiency/results/plots/current_power_overlay/</a:t>
-            </a:r>
-          </a:p>
-        </p:txBody>
-      </p:sp>
-      <p:pic>
-        <p:nvPicPr>
-          <p:cNvPr id="6" name="Picture 5" descr="allchan_pulses.png"/>
-          <p:cNvPicPr>
-            <a:picLocks noChangeAspect="1"/>
-          </p:cNvPicPr>
-          <p:nvPr/>
-        </p:nvPicPr>
-        <p:blipFill>
-          <a:blip r:embed="rId3"/>
-          <a:stretch>
-            <a:fillRect/>
-          </a:stretch>
-        </p:blipFill>
-        <p:spPr>
-          <a:xfrm>
-            <a:off x="502920" y="1758921"/>
-            <a:ext cx="11247120" cy="4025957"/>
-          </a:xfrm>
-          <a:prstGeom prst="rect">
-            <a:avLst/>
-          </a:prstGeom>
-        </p:spPr>
-      </p:pic>
-    </p:spTree>
-  </p:cSld>
-  <p:clrMapOvr>
-    <a:masterClrMapping/>
-  </p:clrMapOvr>
-</p:sld>
-</file>
-
-<file path=ppt/slides/slide21.xml><?xml version="1.0" encoding="utf-8"?>
-<p:sld xmlns:a="http://schemas.openxmlformats.org/drawingml/2006/main" xmlns:p="http://schemas.openxmlformats.org/presentationml/2006/main" xmlns:r="http://schemas.openxmlformats.org/officeDocument/2006/relationships">
-  <p:cSld>
-    <p:spTree>
-      <p:nvGrpSpPr>
-        <p:cNvPr id="1" name=""/>
-        <p:cNvGrpSpPr/>
-        <p:nvPr/>
-      </p:nvGrpSpPr>
-      <p:grpSpPr/>
-      <p:sp>
-        <p:nvSpPr>
-          <p:cNvPr id="2" name="TextBox 1"/>
-          <p:cNvSpPr txBox="1"/>
-          <p:nvPr/>
-        </p:nvSpPr>
-        <p:spPr>
-          <a:xfrm>
-            <a:off x="502920" y="228600"/>
-            <a:ext cx="11247120" cy="731520"/>
-          </a:xfrm>
-          <a:prstGeom prst="rect">
-            <a:avLst/>
-          </a:prstGeom>
-          <a:noFill/>
-        </p:spPr>
-        <p:txBody>
-          <a:bodyPr wrap="square">
-            <a:spAutoFit/>
-          </a:bodyPr>
-          <a:lstStyle/>
-          <a:p>
-            <a:r>
-              <a:rPr sz="2600" b="1">
-                <a:solidFill>
-                  <a:srgbClr val="1F3864"/>
-                </a:solidFill>
-                <a:latin typeface="Arial"/>
-              </a:rPr>
-              <a:t>Backup — event 30646, all channels, cumulative energy</a:t>
-            </a:r>
-          </a:p>
-        </p:txBody>
-      </p:sp>
-      <p:sp>
-        <p:nvSpPr>
-          <p:cNvPr id="3" name="Rectangle 2"/>
-          <p:cNvSpPr/>
-          <p:nvPr/>
-        </p:nvSpPr>
-        <p:spPr>
-          <a:xfrm>
-            <a:off x="502920" y="969264"/>
-            <a:ext cx="11247120" cy="18000"/>
-          </a:xfrm>
-          <a:prstGeom prst="rect">
-            <a:avLst/>
-          </a:prstGeom>
-          <a:solidFill>
-            <a:srgbClr val="1F3864"/>
-          </a:solidFill>
-          <a:ln>
-            <a:noFill/>
-          </a:ln>
-        </p:spPr>
-        <p:style>
-          <a:lnRef idx="1">
-            <a:schemeClr val="accent1"/>
-          </a:lnRef>
-          <a:fillRef idx="3">
-            <a:schemeClr val="accent1"/>
-          </a:fillRef>
-          <a:effectRef idx="2">
-            <a:schemeClr val="accent1"/>
-          </a:effectRef>
-          <a:fontRef idx="minor">
-            <a:schemeClr val="lt1"/>
-          </a:fontRef>
-        </p:style>
-        <p:txBody>
-          <a:bodyPr rtlCol="0" anchor="ctr"/>
-          <a:lstStyle/>
-          <a:p>
-            <a:pPr algn="ctr"/>
-          </a:p>
-        </p:txBody>
-      </p:sp>
-      <p:sp>
-        <p:nvSpPr>
-          <p:cNvPr id="4" name="TextBox 3"/>
-          <p:cNvSpPr txBox="1"/>
-          <p:nvPr/>
-        </p:nvSpPr>
-        <p:spPr>
-          <a:xfrm>
-            <a:off x="11430000" y="6446520"/>
-            <a:ext cx="548640" cy="320040"/>
-          </a:xfrm>
-          <a:prstGeom prst="rect">
-            <a:avLst/>
-          </a:prstGeom>
-          <a:noFill/>
-        </p:spPr>
-        <p:txBody>
-          <a:bodyPr wrap="square">
-            <a:spAutoFit/>
-          </a:bodyPr>
-          <a:lstStyle/>
-          <a:p>
-            <a:r>
-              <a:rPr sz="1000">
-                <a:solidFill>
-                  <a:srgbClr val="666666"/>
-                </a:solidFill>
-                <a:latin typeface="Arial"/>
-              </a:rPr>
-              <a:t>21</a:t>
-            </a:r>
-          </a:p>
-        </p:txBody>
-      </p:sp>
-      <p:sp>
-        <p:nvSpPr>
-          <p:cNvPr id="5" name="TextBox 4"/>
-          <p:cNvSpPr txBox="1"/>
-          <p:nvPr/>
-        </p:nvSpPr>
-        <p:spPr>
-          <a:xfrm>
-            <a:off x="502920" y="6446520"/>
-            <a:ext cx="10241280" cy="320040"/>
-          </a:xfrm>
-          <a:prstGeom prst="rect">
-            <a:avLst/>
-          </a:prstGeom>
-          <a:noFill/>
-        </p:spPr>
-        <p:txBody>
-          <a:bodyPr wrap="square">
-            <a:spAutoFit/>
-          </a:bodyPr>
-          <a:lstStyle/>
-          <a:p>
-            <a:r>
-              <a:rPr sz="900">
-                <a:solidFill>
-                  <a:srgbClr val="666666"/>
-                </a:solidFill>
-                <a:latin typeface="Arial"/>
-              </a:rPr>
-              <a:t>collection_efficiency/results/plots/current_power_overlay/</a:t>
-            </a:r>
-          </a:p>
-        </p:txBody>
-      </p:sp>
-      <p:pic>
-        <p:nvPicPr>
-          <p:cNvPr id="6" name="Picture 5" descr="allchan_cum.png"/>
-          <p:cNvPicPr>
-            <a:picLocks noChangeAspect="1"/>
-          </p:cNvPicPr>
-          <p:nvPr/>
-        </p:nvPicPr>
-        <p:blipFill>
-          <a:blip r:embed="rId3"/>
-          <a:stretch>
-            <a:fillRect/>
-          </a:stretch>
-        </p:blipFill>
-        <p:spPr>
-          <a:xfrm>
-            <a:off x="502920" y="1758921"/>
-            <a:ext cx="11247120" cy="4025957"/>
-          </a:xfrm>
-          <a:prstGeom prst="rect">
-            <a:avLst/>
-          </a:prstGeom>
-        </p:spPr>
-      </p:pic>
-    </p:spTree>
-  </p:cSld>
-  <p:clrMapOvr>
-    <a:masterClrMapping/>
-  </p:clrMapOvr>
-</p:sld>
-</file>
-
-<file path=ppt/slides/slide22.xml><?xml version="1.0" encoding="utf-8"?>
-<p:sld xmlns:a="http://schemas.openxmlformats.org/drawingml/2006/main" xmlns:p="http://schemas.openxmlformats.org/presentationml/2006/main" xmlns:r="http://schemas.openxmlformats.org/officeDocument/2006/relationships">
-  <p:cSld>
-    <p:spTree>
-      <p:nvGrpSpPr>
-        <p:cNvPr id="1" name=""/>
-        <p:cNvGrpSpPr/>
-        <p:nvPr/>
-      </p:nvGrpSpPr>
-      <p:grpSpPr/>
-      <p:sp>
-        <p:nvSpPr>
-          <p:cNvPr id="2" name="TextBox 1"/>
-          <p:cNvSpPr txBox="1"/>
-          <p:nvPr/>
-        </p:nvSpPr>
-        <p:spPr>
-          <a:xfrm>
-            <a:off x="502920" y="228600"/>
-            <a:ext cx="11247120" cy="731520"/>
-          </a:xfrm>
-          <a:prstGeom prst="rect">
-            <a:avLst/>
-          </a:prstGeom>
-          <a:noFill/>
-        </p:spPr>
-        <p:txBody>
-          <a:bodyPr wrap="square">
-            <a:spAutoFit/>
-          </a:bodyPr>
-          <a:lstStyle/>
-          <a:p>
-            <a:r>
-              <a:rPr sz="2600" b="1">
-                <a:solidFill>
-                  <a:srgbClr val="1F3864"/>
-                </a:solidFill>
-                <a:latin typeface="Arial"/>
-              </a:rPr>
-              <a:t>Backup — energy distribution of every channel</a:t>
-            </a:r>
-          </a:p>
-        </p:txBody>
-      </p:sp>
-      <p:sp>
-        <p:nvSpPr>
-          <p:cNvPr id="3" name="Rectangle 2"/>
-          <p:cNvSpPr/>
-          <p:nvPr/>
-        </p:nvSpPr>
-        <p:spPr>
-          <a:xfrm>
-            <a:off x="502920" y="969264"/>
-            <a:ext cx="11247120" cy="18000"/>
-          </a:xfrm>
-          <a:prstGeom prst="rect">
-            <a:avLst/>
-          </a:prstGeom>
-          <a:solidFill>
-            <a:srgbClr val="1F3864"/>
-          </a:solidFill>
-          <a:ln>
-            <a:noFill/>
-          </a:ln>
-        </p:spPr>
-        <p:style>
-          <a:lnRef idx="1">
-            <a:schemeClr val="accent1"/>
-          </a:lnRef>
-          <a:fillRef idx="3">
-            <a:schemeClr val="accent1"/>
-          </a:fillRef>
-          <a:effectRef idx="2">
-            <a:schemeClr val="accent1"/>
-          </a:effectRef>
-          <a:fontRef idx="minor">
-            <a:schemeClr val="lt1"/>
-          </a:fontRef>
-        </p:style>
-        <p:txBody>
-          <a:bodyPr rtlCol="0" anchor="ctr"/>
-          <a:lstStyle/>
-          <a:p>
-            <a:pPr algn="ctr"/>
-          </a:p>
-        </p:txBody>
-      </p:sp>
-      <p:sp>
-        <p:nvSpPr>
-          <p:cNvPr id="4" name="TextBox 3"/>
-          <p:cNvSpPr txBox="1"/>
-          <p:nvPr/>
-        </p:nvSpPr>
-        <p:spPr>
-          <a:xfrm>
-            <a:off x="11430000" y="6446520"/>
-            <a:ext cx="548640" cy="320040"/>
-          </a:xfrm>
-          <a:prstGeom prst="rect">
-            <a:avLst/>
-          </a:prstGeom>
-          <a:noFill/>
-        </p:spPr>
-        <p:txBody>
-          <a:bodyPr wrap="square">
-            <a:spAutoFit/>
-          </a:bodyPr>
-          <a:lstStyle/>
-          <a:p>
-            <a:r>
-              <a:rPr sz="1000">
-                <a:solidFill>
-                  <a:srgbClr val="666666"/>
-                </a:solidFill>
-                <a:latin typeface="Arial"/>
-              </a:rPr>
-              <a:t>22</a:t>
-            </a:r>
-          </a:p>
-        </p:txBody>
-      </p:sp>
-      <p:sp>
-        <p:nvSpPr>
-          <p:cNvPr id="5" name="TextBox 4"/>
-          <p:cNvSpPr txBox="1"/>
-          <p:nvPr/>
-        </p:nvSpPr>
-        <p:spPr>
-          <a:xfrm>
-            <a:off x="502920" y="6446520"/>
-            <a:ext cx="10241280" cy="320040"/>
-          </a:xfrm>
-          <a:prstGeom prst="rect">
-            <a:avLst/>
-          </a:prstGeom>
-          <a:noFill/>
-        </p:spPr>
-        <p:txBody>
-          <a:bodyPr wrap="square">
-            <a:spAutoFit/>
-          </a:bodyPr>
-          <a:lstStyle/>
-          <a:p>
-            <a:r>
-              <a:rPr sz="900">
-                <a:solidFill>
-                  <a:srgbClr val="666666"/>
-                </a:solidFill>
-                <a:latin typeface="Arial"/>
-              </a:rPr>
-              <a:t>collection_efficiency/results/plots/current_power_overlay/</a:t>
-            </a:r>
-          </a:p>
-        </p:txBody>
-      </p:sp>
-      <p:pic>
-        <p:nvPicPr>
-          <p:cNvPr id="6" name="Picture 5" descr="hist_allchan.png"/>
-          <p:cNvPicPr>
-            <a:picLocks noChangeAspect="1"/>
-          </p:cNvPicPr>
-          <p:nvPr/>
-        </p:nvPicPr>
-        <p:blipFill>
-          <a:blip r:embed="rId3"/>
-          <a:stretch>
-            <a:fillRect/>
-          </a:stretch>
-        </p:blipFill>
-        <p:spPr>
-          <a:xfrm>
-            <a:off x="929114" y="1143000"/>
-            <a:ext cx="10394731" cy="5257800"/>
-          </a:xfrm>
-          <a:prstGeom prst="rect">
-            <a:avLst/>
-          </a:prstGeom>
-        </p:spPr>
-      </p:pic>
+              <a:t>Sample: Z7, the K-line events of the Ge activation run (2207 events, 30 series, all 11 channels saved raw).</a:t>
+            </a:r>
+          </a:p>
+        </p:txBody>
+      </p:sp>
     </p:spTree>
   </p:cSld>
   <p:clrMapOvr>
@@ -8503,13 +6513,13 @@
           <a:lstStyle/>
           <a:p>
             <a:r>
-              <a:rPr sz="2600" b="1">
+              <a:rPr sz="2700" b="1" i="0">
                 <a:solidFill>
                   <a:srgbClr val="1F3864"/>
                 </a:solidFill>
                 <a:latin typeface="Arial"/>
               </a:rPr>
-              <a:t>The events: the 10.37 keV K line of the Ge activation run, on Z7</a:t>
+              <a:t>From current to power, from power to energy</a:t>
             </a:r>
           </a:p>
         </p:txBody>
@@ -8580,7 +6590,7 @@
           <a:lstStyle/>
           <a:p>
             <a:r>
-              <a:rPr sz="1000">
+              <a:rPr sz="1000" b="0" i="0">
                 <a:solidFill>
                   <a:srgbClr val="666666"/>
                 </a:solidFill>
@@ -8593,7 +6603,7 @@
       </p:sp>
       <p:pic>
         <p:nvPicPr>
-          <p:cNvPr id="5" name="Picture 4" descr="spectrum_zip7.png"/>
+          <p:cNvPr id="5" name="Picture 4" descr="formula.png"/>
           <p:cNvPicPr>
             <a:picLocks noChangeAspect="1"/>
           </p:cNvPicPr>
@@ -8607,8 +6617,8 @@
         </p:blipFill>
         <p:spPr>
           <a:xfrm>
-            <a:off x="502920" y="1259677"/>
-            <a:ext cx="7223760" cy="3698565"/>
+            <a:off x="997889" y="1143000"/>
+            <a:ext cx="10257182" cy="3931920"/>
           </a:xfrm>
           <a:prstGeom prst="rect">
             <a:avLst/>
@@ -8623,8 +6633,8 @@
         </p:nvSpPr>
         <p:spPr>
           <a:xfrm>
-            <a:off x="7909560" y="1143000"/>
-            <a:ext cx="3840480" cy="4572000"/>
+            <a:off x="502920" y="5166360"/>
+            <a:ext cx="11247120" cy="1371600"/>
           </a:xfrm>
           <a:prstGeom prst="rect">
             <a:avLst/>
@@ -8639,115 +6649,49 @@
           <a:p>
             <a:pPr>
               <a:spcAft>
-                <a:spcPts val="600"/>
+                <a:spcPts val="800"/>
               </a:spcAft>
             </a:pPr>
             <a:r>
-              <a:rPr sz="1300" b="0">
+              <a:rPr sz="1600" b="0" i="0">
                 <a:solidFill>
                   <a:srgbClr val="333333"/>
                 </a:solidFill>
                 <a:latin typeface="Arial"/>
               </a:rPr>
-              <a:t>• After the Cf activation every detector produces mono-energetic 10.37 keV events (71Ge electron capture)</a:t>
+              <a:t>Power = the change of Joule heating when the current moves by δI: a linear term and a small quadratic term.</a:t>
             </a:r>
           </a:p>
           <a:p>
             <a:pPr>
               <a:spcAft>
-                <a:spcPts val="600"/>
+                <a:spcPts val="800"/>
               </a:spcAft>
             </a:pPr>
             <a:r>
-              <a:rPr sz="1300" b="0">
+              <a:rPr sz="1600" b="0" i="0">
                 <a:solidFill>
                   <a:srgbClr val="333333"/>
                 </a:solidFill>
                 <a:latin typeface="Arial"/>
               </a:rPr>
-              <a:t>• On Z7 the K line is well separated from the noise triggers: a clean sample of identical events</a:t>
+              <a:t>Both coefficients are the measured bias point of the channel — nothing is fitted or tuned.</a:t>
             </a:r>
           </a:p>
           <a:p>
             <a:pPr>
               <a:spcAft>
-                <a:spcPts val="600"/>
+                <a:spcPts val="800"/>
               </a:spcAft>
             </a:pPr>
             <a:r>
-              <a:rPr sz="1300" b="0">
-                <a:solidFill>
-                  <a:srgbClr val="333333"/>
+              <a:rPr sz="1600" b="1" i="0">
+                <a:solidFill>
+                  <a:srgbClr val="C0392B"/>
                 </a:solidFill>
                 <a:latin typeface="Arial"/>
               </a:rPr>
-              <a:t>• 2207 K-line events over 30 series; for each one the raw trace of every phonon channel was saved (11 channels read out on Z7)</a:t>
-            </a:r>
-          </a:p>
-          <a:p>
-            <a:pPr>
-              <a:spcAft>
-                <a:spcPts val="600"/>
-              </a:spcAft>
-            </a:pPr>
-            <a:r>
-              <a:rPr sz="1300" b="0">
-                <a:solidFill>
-                  <a:srgbClr val="333333"/>
-                </a:solidFill>
-                <a:latin typeface="Arial"/>
-              </a:rPr>
-              <a:t>• For each channel the bias point (I₀, R₀, R_p, R_sh) is read from the processing's detectorConfig</a:t>
-            </a:r>
-          </a:p>
-          <a:p>
-            <a:pPr>
-              <a:spcAft>
-                <a:spcPts val="600"/>
-              </a:spcAft>
-            </a:pPr>
-            <a:r>
-              <a:rPr sz="1300" b="0">
-                <a:solidFill>
-                  <a:srgbClr val="333333"/>
-                </a:solidFill>
-                <a:latin typeface="Arial"/>
-              </a:rPr>
-              <a:t>• Same sample as the pulse-template work — nothing new was selected</a:t>
-            </a:r>
-          </a:p>
-        </p:txBody>
-      </p:sp>
-      <p:sp>
-        <p:nvSpPr>
-          <p:cNvPr id="7" name="TextBox 6"/>
-          <p:cNvSpPr txBox="1"/>
-          <p:nvPr/>
-        </p:nvSpPr>
-        <p:spPr>
-          <a:xfrm>
-            <a:off x="502920" y="5120640"/>
-            <a:ext cx="7223760" cy="365760"/>
-          </a:xfrm>
-          <a:prstGeom prst="rect">
-            <a:avLst/>
-          </a:prstGeom>
-          <a:noFill/>
-        </p:spPr>
-        <p:txBody>
-          <a:bodyPr wrap="square">
-            <a:spAutoFit/>
-          </a:bodyPr>
-          <a:lstStyle/>
-          <a:p>
-            <a:r>
-              <a:rPr sz="1000" i="1">
-                <a:solidFill>
-                  <a:srgbClr val="666666"/>
-                </a:solidFill>
-                <a:latin typeface="Arial"/>
-              </a:rPr>
-              <a:t>Summed PTOFamps of Z7 rebuilt from the Prompt processing (purple); black: the ops note's histogram, which rejects SumPF/PT &lt; 0.1; red line: the K line.</a:t>
+              <a:t>If the pulse is a two-exponential, the energy is a formula in A, τ_f, τ_r — no integration window.</a:t>
             </a:r>
           </a:p>
         </p:txBody>
@@ -8793,13 +6737,24 @@
           <a:lstStyle/>
           <a:p>
             <a:r>
-              <a:rPr sz="2600" b="1">
+              <a:rPr sz="2700" b="1" i="0">
                 <a:solidFill>
                   <a:srgbClr val="1F3864"/>
                 </a:solidFill>
                 <a:latin typeface="Arial"/>
               </a:rPr>
-              <a:t>From current to power: the TES equations, small-signal</a:t>
+              <a:t>One pulse, read three ways</a:t>
+            </a:r>
+          </a:p>
+          <a:p>
+            <a:r>
+              <a:rPr sz="1400" b="0" i="0">
+                <a:solidFill>
+                  <a:srgbClr val="666666"/>
+                </a:solidFill>
+                <a:latin typeface="Arial"/>
+              </a:rPr>
+              <a:t>Z7 PBS1, event 30646: the same trace as ADC counts, as current, as power</a:t>
             </a:r>
           </a:p>
         </p:txBody>
@@ -8870,7 +6825,7 @@
           <a:lstStyle/>
           <a:p>
             <a:r>
-              <a:rPr sz="1000">
+              <a:rPr sz="1000" b="0" i="0">
                 <a:solidFill>
                   <a:srgbClr val="666666"/>
                 </a:solidFill>
@@ -8883,7 +6838,7 @@
       </p:sp>
       <p:pic>
         <p:nvPicPr>
-          <p:cNvPr id="5" name="Picture 4" descr="formula.png"/>
+          <p:cNvPr id="5" name="Picture 4" descr="peak_full.png"/>
           <p:cNvPicPr>
             <a:picLocks noChangeAspect="1"/>
           </p:cNvPicPr>
@@ -8897,101 +6852,14 @@
         </p:blipFill>
         <p:spPr>
           <a:xfrm>
-            <a:off x="1117158" y="1143000"/>
-            <a:ext cx="10018643" cy="3840480"/>
+            <a:off x="2713966" y="1143000"/>
+            <a:ext cx="6825028" cy="5257800"/>
           </a:xfrm>
           <a:prstGeom prst="rect">
             <a:avLst/>
           </a:prstGeom>
         </p:spPr>
       </p:pic>
-      <p:sp>
-        <p:nvSpPr>
-          <p:cNvPr id="6" name="TextBox 5"/>
-          <p:cNvSpPr txBox="1"/>
-          <p:nvPr/>
-        </p:nvSpPr>
-        <p:spPr>
-          <a:xfrm>
-            <a:off x="502920" y="5029200"/>
-            <a:ext cx="11247120" cy="1463040"/>
-          </a:xfrm>
-          <a:prstGeom prst="rect">
-            <a:avLst/>
-          </a:prstGeom>
-          <a:noFill/>
-        </p:spPr>
-        <p:txBody>
-          <a:bodyPr wrap="square">
-            <a:spAutoFit/>
-          </a:bodyPr>
-          <a:lstStyle/>
-          <a:p>
-            <a:pPr>
-              <a:spcAft>
-                <a:spcPts val="600"/>
-              </a:spcAft>
-            </a:pPr>
-            <a:r>
-              <a:rPr sz="1300" b="0">
-                <a:solidFill>
-                  <a:srgbClr val="333333"/>
-                </a:solidFill>
-                <a:latin typeface="Arial"/>
-              </a:rPr>
-              <a:t>• The power absorbed by the film is the change of Joule heating when the current moves by δI: a linear term plus a quadratic term (Irwin &amp; Hilton; Method 1 of the CDMS collection-efficiency note)</a:t>
-            </a:r>
-          </a:p>
-          <a:p>
-            <a:pPr>
-              <a:spcAft>
-                <a:spcPts val="600"/>
-              </a:spcAft>
-            </a:pPr>
-            <a:r>
-              <a:rPr sz="1300" b="0">
-                <a:solidFill>
-                  <a:srgbClr val="333333"/>
-                </a:solidFill>
-                <a:latin typeface="Arial"/>
-              </a:rPr>
-              <a:t>• Both coefficients come from the measured bias point of that channel — nothing is fitted or tuned</a:t>
-            </a:r>
-          </a:p>
-          <a:p>
-            <a:pPr>
-              <a:spcAft>
-                <a:spcPts val="600"/>
-              </a:spcAft>
-            </a:pPr>
-            <a:r>
-              <a:rPr sz="1300" b="0">
-                <a:solidFill>
-                  <a:srgbClr val="333333"/>
-                </a:solidFill>
-                <a:latin typeface="Arial"/>
-              </a:rPr>
-              <a:t>• The trace is in ADC counts: 3 145 728 000 ADC = 1 A, so 1 ADC = 0.318 nA. Only the change above the baseline is used</a:t>
-            </a:r>
-          </a:p>
-          <a:p>
-            <a:pPr>
-              <a:spcAft>
-                <a:spcPts val="600"/>
-              </a:spcAft>
-            </a:pPr>
-            <a:r>
-              <a:rPr sz="1300" b="0">
-                <a:solidFill>
-                  <a:srgbClr val="333333"/>
-                </a:solidFill>
-                <a:latin typeface="Arial"/>
-              </a:rPr>
-              <a:t>• Three variants of the formula exist (c₂ = 2, 1, −1); they differ by under 1.2 % in energy, so the choice is not the main uncertainty (backup)</a:t>
-            </a:r>
-          </a:p>
-        </p:txBody>
-      </p:sp>
     </p:spTree>
   </p:cSld>
   <p:clrMapOvr>
@@ -9033,24 +6901,13 @@
           <a:lstStyle/>
           <a:p>
             <a:r>
-              <a:rPr sz="2600" b="1">
+              <a:rPr sz="2700" b="1" i="0">
                 <a:solidFill>
                   <a:srgbClr val="1F3864"/>
                 </a:solidFill>
                 <a:latin typeface="Arial"/>
               </a:rPr>
-              <a:t>One pulse read three ways: ADC, current, power  —  the height</a:t>
-            </a:r>
-          </a:p>
-          <a:p>
-            <a:r>
-              <a:rPr sz="1400">
-                <a:solidFill>
-                  <a:srgbClr val="666666"/>
-                </a:solidFill>
-                <a:latin typeface="Arial"/>
-              </a:rPr>
-              <a:t>Z7 PBS1, event 30646, zoomed on the peak; every curve is the same trace</a:t>
+              <a:t>The height: take it from the fit, not from the largest sample</a:t>
             </a:r>
           </a:p>
         </p:txBody>
@@ -9121,7 +6978,7 @@
           <a:lstStyle/>
           <a:p>
             <a:r>
-              <a:rPr sz="1000">
+              <a:rPr sz="1000" b="0" i="0">
                 <a:solidFill>
                   <a:srgbClr val="666666"/>
                 </a:solidFill>
@@ -9148,8 +7005,8 @@
         </p:blipFill>
         <p:spPr>
           <a:xfrm>
-            <a:off x="502920" y="1157605"/>
-            <a:ext cx="11247120" cy="4634230"/>
+            <a:off x="1077759" y="1143000"/>
+            <a:ext cx="10097441" cy="4160520"/>
           </a:xfrm>
           <a:prstGeom prst="rect">
             <a:avLst/>
@@ -9164,8 +7021,8 @@
         </p:nvSpPr>
         <p:spPr>
           <a:xfrm>
-            <a:off x="502920" y="5852160"/>
-            <a:ext cx="11247120" cy="365760"/>
+            <a:off x="502920" y="5394960"/>
+            <a:ext cx="11247120" cy="1097280"/>
           </a:xfrm>
           <a:prstGeom prst="rect">
             <a:avLst/>
@@ -9178,14 +7035,35 @@
           </a:bodyPr>
           <a:lstStyle/>
           <a:p>
-            <a:r>
-              <a:rPr sz="1100" i="1">
-                <a:solidFill>
-                  <a:srgbClr val="666666"/>
+            <a:pPr>
+              <a:spcAft>
+                <a:spcPts val="800"/>
+              </a:spcAft>
+            </a:pPr>
+            <a:r>
+              <a:rPr sz="1600" b="0" i="0">
+                <a:solidFill>
+                  <a:srgbClr val="333333"/>
                 </a:solidFill>
                 <a:latin typeface="Arial"/>
               </a:rPr>
-              <a:t>Grey: raw samples.  Blue: 100 kHz low pass (what the fit sees).  Green: 20 kHz (the official Eabs prefilter).  Red: the two-exponential fit; pink band = fit ± 1σ noise.  Yellow: the flat top, 98 samples within 10 % of the peak.  Largest raw sample 885 ADC against 717 from the fit: +23 %.</a:t>
+              <a:t>Yellow band: 98 samples sit within 10 % of the peak. The largest of them is the largest noise excursion.</a:t>
+            </a:r>
+          </a:p>
+          <a:p>
+            <a:pPr>
+              <a:spcAft>
+                <a:spcPts val="800"/>
+              </a:spcAft>
+            </a:pPr>
+            <a:r>
+              <a:rPr sz="1600" b="1" i="0">
+                <a:solidFill>
+                  <a:srgbClr val="C0392B"/>
+                </a:solidFill>
+                <a:latin typeface="Arial"/>
+              </a:rPr>
+              <a:t>Largest raw sample 885 ADC, fit 717 ADC: the maximum reads 23 % high. Filtering helps; the fit removes it.</a:t>
             </a:r>
           </a:p>
         </p:txBody>
@@ -9231,24 +7109,13 @@
           <a:lstStyle/>
           <a:p>
             <a:r>
-              <a:rPr sz="2600" b="1">
+              <a:rPr sz="2700" b="1" i="0">
                 <a:solidFill>
                   <a:srgbClr val="1F3864"/>
                 </a:solidFill>
                 <a:latin typeface="Arial"/>
               </a:rPr>
-              <a:t>One pulse read three ways  —  the power, and its area</a:t>
-            </a:r>
-          </a:p>
-          <a:p>
-            <a:r>
-              <a:rPr sz="1400">
-                <a:solidFill>
-                  <a:srgbClr val="666666"/>
-                </a:solidFill>
-                <a:latin typeface="Arial"/>
-              </a:rPr>
-              <a:t>same event; the fitted current put through the formula</a:t>
+              <a:t>The power pulse, and its area is the energy</a:t>
             </a:r>
           </a:p>
         </p:txBody>
@@ -9319,7 +7186,7 @@
           <a:lstStyle/>
           <a:p>
             <a:r>
-              <a:rPr sz="1000">
+              <a:rPr sz="1000" b="0" i="0">
                 <a:solidFill>
                   <a:srgbClr val="666666"/>
                 </a:solidFill>
@@ -9346,7 +7213,7 @@
         </p:blipFill>
         <p:spPr>
           <a:xfrm>
-            <a:off x="502920" y="1167765"/>
+            <a:off x="502920" y="1213485"/>
             <a:ext cx="11247120" cy="2967990"/>
           </a:xfrm>
           <a:prstGeom prst="rect">
@@ -9362,8 +7229,8 @@
         </p:nvSpPr>
         <p:spPr>
           <a:xfrm>
-            <a:off x="502920" y="4297680"/>
-            <a:ext cx="11247120" cy="2194560"/>
+            <a:off x="502920" y="4389120"/>
+            <a:ext cx="11247120" cy="2011680"/>
           </a:xfrm>
           <a:prstGeom prst="rect">
             <a:avLst/>
@@ -9378,65 +7245,49 @@
           <a:p>
             <a:pPr>
               <a:spcAft>
-                <a:spcPts val="600"/>
+                <a:spcPts val="800"/>
               </a:spcAft>
             </a:pPr>
             <a:r>
-              <a:rPr sz="1300" b="0">
+              <a:rPr sz="1600" b="0" i="0">
                 <a:solidFill>
                   <a:srgbClr val="333333"/>
                 </a:solidFill>
                 <a:latin typeface="Arial"/>
               </a:rPr>
-              <a:t>• Red: the power pulse from the fitted current — the two terms added. Blue dashed: the linear term alone, almost the whole thing. Purple dotted: the quadratic term alone, drawn ×20 so it can be seen</a:t>
+              <a:t>Red: the fitted current put through the formula. Blue dashed: the linear term alone. Purple: the quadratic term, ×20.</a:t>
             </a:r>
           </a:p>
           <a:p>
             <a:pPr>
               <a:spcAft>
-                <a:spcPts val="600"/>
+                <a:spcPts val="800"/>
               </a:spcAft>
             </a:pPr>
             <a:r>
-              <a:rPr sz="1300" b="1">
+              <a:rPr sz="1600" b="1" i="0">
                 <a:solidFill>
                   <a:srgbClr val="C0392B"/>
                 </a:solidFill>
                 <a:latin typeface="Arial"/>
               </a:rPr>
-              <a:t>• Peak 104.6 fW = 102.6 (linear) + 2.0 (quadratic): the quadratic term is 1.9 % of the peak power and 1.3 % of the energy — the power pulse has the shape of the current pulse</a:t>
+              <a:t>The quadratic term is 1.9 % of the peak — the power pulse has the shape of the current pulse.</a:t>
             </a:r>
           </a:p>
           <a:p>
             <a:pPr>
               <a:spcAft>
-                <a:spcPts val="600"/>
+                <a:spcPts val="800"/>
               </a:spcAft>
             </a:pPr>
             <a:r>
-              <a:rPr sz="1300" b="1">
+              <a:rPr sz="1600" b="1" i="0">
                 <a:solidFill>
                   <a:srgbClr val="C0392B"/>
                 </a:solidFill>
                 <a:latin typeface="Arial"/>
               </a:rPr>
-              <a:t>• The shaded area is the energy this channel absorbed: 305.2 eV; 99 % of it lies inside this 1.3 ms window</a:t>
-            </a:r>
-          </a:p>
-          <a:p>
-            <a:pPr>
-              <a:spcAft>
-                <a:spcPts val="600"/>
-              </a:spcAft>
-            </a:pPr>
-            <a:r>
-              <a:rPr sz="1300" b="0">
-                <a:solidFill>
-                  <a:srgbClr val="333333"/>
-                </a:solidFill>
-                <a:latin typeface="Arial"/>
-              </a:rPr>
-              <a:t>• Grey dots and green: the same formula applied to the raw and 20 kHz traces, for comparison only. Bottom line: the measured bias point that fixes the two coefficients</a:t>
+              <a:t>The shaded area is the energy this channel absorbed: 305 eV.</a:t>
             </a:r>
           </a:p>
         </p:txBody>
@@ -9482,24 +7333,24 @@
           <a:lstStyle/>
           <a:p>
             <a:r>
-              <a:rPr sz="2600" b="1">
+              <a:rPr sz="2700" b="1" i="0">
                 <a:solidFill>
                   <a:srgbClr val="1F3864"/>
                 </a:solidFill>
                 <a:latin typeface="Arial"/>
               </a:rPr>
-              <a:t>Every event gets the same treatment: fit the current, convert to power</a:t>
-            </a:r>
-          </a:p>
-          <a:p>
-            <a:r>
-              <a:rPr sz="1400">
+              <a:t>Why the fitted pulse is integrated, and not the data</a:t>
+            </a:r>
+          </a:p>
+          <a:p>
+            <a:r>
+              <a:rPr sz="1400" b="0" i="0">
                 <a:solidFill>
                   <a:srgbClr val="666666"/>
                 </a:solidFill>
                 <a:latin typeface="Arial"/>
               </a:rPr>
-              <a:t>Z7 PBS1, two of the 15 example events of series 24260617_063934</a:t>
+              <a:t>energy accumulated from the start of the 52 ms trace; trigger at the dotted line</a:t>
             </a:r>
           </a:p>
         </p:txBody>
@@ -9570,7 +7421,7 @@
           <a:lstStyle/>
           <a:p>
             <a:r>
-              <a:rPr sz="1000">
+              <a:rPr sz="1000" b="0" i="0">
                 <a:solidFill>
                   <a:srgbClr val="666666"/>
                 </a:solidFill>
@@ -9583,7 +7434,7 @@
       </p:sp>
       <p:pic>
         <p:nvPicPr>
-          <p:cNvPr id="5" name="Picture 4" descr="pulse_ev30646.png"/>
+          <p:cNvPr id="5" name="Picture 4" descr="cum_ev30646.png"/>
           <p:cNvPicPr>
             <a:picLocks noChangeAspect="1"/>
           </p:cNvPicPr>
@@ -9597,8 +7448,8 @@
         </p:blipFill>
         <p:spPr>
           <a:xfrm>
-            <a:off x="502920" y="1315734"/>
-            <a:ext cx="5532120" cy="1849092"/>
+            <a:off x="502920" y="1304367"/>
+            <a:ext cx="5532120" cy="1871826"/>
           </a:xfrm>
           <a:prstGeom prst="rect">
             <a:avLst/>
@@ -9607,7 +7458,7 @@
       </p:pic>
       <p:pic>
         <p:nvPicPr>
-          <p:cNvPr id="6" name="Picture 5" descr="pulse_ev100231.png"/>
+          <p:cNvPr id="6" name="Picture 5" descr="cum_ev210571.png"/>
           <p:cNvPicPr>
             <a:picLocks noChangeAspect="1"/>
           </p:cNvPicPr>
@@ -9621,8 +7472,8 @@
         </p:blipFill>
         <p:spPr>
           <a:xfrm>
-            <a:off x="6217920" y="1313470"/>
-            <a:ext cx="5532120" cy="1853619"/>
+            <a:off x="6217920" y="1185226"/>
+            <a:ext cx="5532120" cy="2110108"/>
           </a:xfrm>
           <a:prstGeom prst="rect">
             <a:avLst/>
@@ -9631,7 +7482,7 @@
       </p:pic>
       <p:pic>
         <p:nvPicPr>
-          <p:cNvPr id="7" name="Picture 6" descr="pulse_legend.png"/>
+          <p:cNvPr id="7" name="Picture 6" descr="cum_legend.png"/>
           <p:cNvPicPr>
             <a:picLocks noChangeAspect="1"/>
           </p:cNvPicPr>
@@ -9645,8 +7496,8 @@
         </p:blipFill>
         <p:spPr>
           <a:xfrm>
-            <a:off x="1828800" y="3407505"/>
-            <a:ext cx="8503920" cy="317310"/>
+            <a:off x="3017520" y="3406616"/>
+            <a:ext cx="6126480" cy="319087"/>
           </a:xfrm>
           <a:prstGeom prst="rect">
             <a:avLst/>
@@ -9661,8 +7512,8 @@
         </p:nvSpPr>
         <p:spPr>
           <a:xfrm>
-            <a:off x="502920" y="3840480"/>
-            <a:ext cx="11247120" cy="2651760"/>
+            <a:off x="502920" y="4023360"/>
+            <a:ext cx="11247120" cy="2194560"/>
           </a:xfrm>
           <a:prstGeom prst="rect">
             <a:avLst/>
@@ -9677,81 +7528,33 @@
           <a:p>
             <a:pPr>
               <a:spcAft>
-                <a:spcPts val="600"/>
+                <a:spcPts val="800"/>
               </a:spcAft>
             </a:pPr>
             <a:r>
-              <a:rPr sz="1300" b="0">
+              <a:rPr sz="1600" b="0" i="0">
                 <a:solidFill>
                   <a:srgbClr val="333333"/>
                 </a:solidFill>
                 <a:latin typeface="Arial"/>
               </a:rPr>
-              <a:t>• Each trace is fitted with A·[e^(−t/τ_f) − e^(−t/τ_r)] directly in current units, with the pulse start left free (±4.8 ms around the trigger)</a:t>
+              <a:t>Red, from the fit: nothing before the pulse, up within 1 ms, then flat — and the end value is exactly the formula.</a:t>
             </a:r>
           </a:p>
           <a:p>
             <a:pPr>
               <a:spcAft>
-                <a:spcPts val="600"/>
+                <a:spcPts val="800"/>
               </a:spcAft>
             </a:pPr>
             <a:r>
-              <a:rPr sz="1300" b="0">
-                <a:solidFill>
-                  <a:srgbClr val="333333"/>
+              <a:rPr sz="1600" b="1" i="0">
+                <a:solidFill>
+                  <a:srgbClr val="C0392B"/>
                 </a:solidFill>
                 <a:latin typeface="Arial"/>
               </a:rPr>
-              <a:t>• Left axis: fitted current δI in µA (navy dashed). Right axis: the power it implies in fW (red). The raw trace (grey) is only drawn for reference</a:t>
-            </a:r>
-          </a:p>
-          <a:p>
-            <a:pPr>
-              <a:spcAft>
-                <a:spcPts val="600"/>
-              </a:spcAft>
-            </a:pPr>
-            <a:r>
-              <a:rPr sz="1300" b="0">
-                <a:solidFill>
-                  <a:srgbClr val="333333"/>
-                </a:solidFill>
-                <a:latin typeface="Arial"/>
-              </a:rPr>
-              <a:t>• The two curves lie on top of each other because the quadratic term is only 2 % — the right axis is just the left axis times 4.5×10⁻⁷ V</a:t>
-            </a:r>
-          </a:p>
-          <a:p>
-            <a:pPr>
-              <a:spcAft>
-                <a:spcPts val="600"/>
-              </a:spcAft>
-            </a:pPr>
-            <a:r>
-              <a:rPr sz="1300" b="0">
-                <a:solidFill>
-                  <a:srgbClr val="333333"/>
-                </a:solidFill>
-                <a:latin typeface="Arial"/>
-              </a:rPr>
-              <a:t>• Yellow band: the official Eabs integration window (−0.5 to +1 ms). The fit needs no window</a:t>
-            </a:r>
-          </a:p>
-          <a:p>
-            <a:pPr>
-              <a:spcAft>
-                <a:spcPts val="600"/>
-              </a:spcAft>
-            </a:pPr>
-            <a:r>
-              <a:rPr sz="1300" b="0">
-                <a:solidFill>
-                  <a:srgbClr val="333333"/>
-                </a:solidFill>
-                <a:latin typeface="Arial"/>
-              </a:rPr>
-              <a:t>• Fits are kept if the residual is under 20 % of the pulse height (NRMSE ≤ 0.2; typical values 0.03–0.07). Same channel, 15 events: energies from 198 to 448 eV</a:t>
+              <a:t>Grey, from the raw trace: it drifts. A 1 nA baseline offset over 15 ms is already 42 eV. Right: fit 277 eV, raw −169 eV.</a:t>
             </a:r>
           </a:p>
         </p:txBody>
@@ -9797,24 +7600,24 @@
           <a:lstStyle/>
           <a:p>
             <a:r>
-              <a:rPr sz="2600" b="1">
+              <a:rPr sz="2700" b="1" i="0">
                 <a:solidFill>
                   <a:srgbClr val="1F3864"/>
                 </a:solidFill>
                 <a:latin typeface="Arial"/>
               </a:rPr>
-              <a:t>Why the fit is integrated and not the raw trace</a:t>
-            </a:r>
-          </a:p>
-          <a:p>
-            <a:r>
-              <a:rPr sz="1400">
+              <a:t>The same event in its other channels: they add up to 33 %</a:t>
+            </a:r>
+          </a:p>
+          <a:p>
+            <a:r>
+              <a:rPr sz="1400" b="0" i="0">
                 <a:solidFill>
                   <a:srgbClr val="666666"/>
                 </a:solidFill>
                 <a:latin typeface="Arial"/>
               </a:rPr>
-              <a:t>cumulative energy ∫₀ᵗ P dt over the whole 52 ms trace, Z7 PBS1</a:t>
+              <a:t>Z7 event 30646; four of the eleven channels</a:t>
             </a:r>
           </a:p>
         </p:txBody>
@@ -9885,7 +7688,7 @@
           <a:lstStyle/>
           <a:p>
             <a:r>
-              <a:rPr sz="1000">
+              <a:rPr sz="1000" b="0" i="0">
                 <a:solidFill>
                   <a:srgbClr val="666666"/>
                 </a:solidFill>
@@ -9898,7 +7701,7 @@
       </p:sp>
       <p:pic>
         <p:nvPicPr>
-          <p:cNvPr id="5" name="Picture 4" descr="cum_ev30646.png"/>
+          <p:cNvPr id="5" name="Picture 4" descr="allchan_PBS1.png"/>
           <p:cNvPicPr>
             <a:picLocks noChangeAspect="1"/>
           </p:cNvPicPr>
@@ -9912,8 +7715,8 @@
         </p:blipFill>
         <p:spPr>
           <a:xfrm>
-            <a:off x="502920" y="1304367"/>
-            <a:ext cx="5532120" cy="1871826"/>
+            <a:off x="502920" y="1154757"/>
+            <a:ext cx="5532120" cy="1896726"/>
           </a:xfrm>
           <a:prstGeom prst="rect">
             <a:avLst/>
@@ -9922,7 +7725,7 @@
       </p:pic>
       <p:pic>
         <p:nvPicPr>
-          <p:cNvPr id="6" name="Picture 5" descr="cum_ev210571.png"/>
+          <p:cNvPr id="6" name="Picture 5" descr="allchan_PES1.png"/>
           <p:cNvPicPr>
             <a:picLocks noChangeAspect="1"/>
           </p:cNvPicPr>
@@ -9936,8 +7739,8 @@
         </p:blipFill>
         <p:spPr>
           <a:xfrm>
-            <a:off x="6217920" y="1185226"/>
-            <a:ext cx="5532120" cy="2110108"/>
+            <a:off x="6217920" y="1154757"/>
+            <a:ext cx="5532120" cy="1896726"/>
           </a:xfrm>
           <a:prstGeom prst="rect">
             <a:avLst/>
@@ -9946,7 +7749,7 @@
       </p:pic>
       <p:pic>
         <p:nvPicPr>
-          <p:cNvPr id="7" name="Picture 6" descr="cum_legend.png"/>
+          <p:cNvPr id="7" name="Picture 6" descr="allchan_PES2.png"/>
           <p:cNvPicPr>
             <a:picLocks noChangeAspect="1"/>
           </p:cNvPicPr>
@@ -9960,24 +7763,48 @@
         </p:blipFill>
         <p:spPr>
           <a:xfrm>
-            <a:off x="3017520" y="3406616"/>
-            <a:ext cx="6126480" cy="319087"/>
+            <a:off x="502920" y="3166437"/>
+            <a:ext cx="5532120" cy="1896726"/>
           </a:xfrm>
           <a:prstGeom prst="rect">
             <a:avLst/>
           </a:prstGeom>
         </p:spPr>
       </p:pic>
-      <p:sp>
-        <p:nvSpPr>
-          <p:cNvPr id="8" name="TextBox 7"/>
+      <p:pic>
+        <p:nvPicPr>
+          <p:cNvPr id="8" name="Picture 7" descr="allchan_PDS2.png"/>
+          <p:cNvPicPr>
+            <a:picLocks noChangeAspect="1"/>
+          </p:cNvPicPr>
+          <p:nvPr/>
+        </p:nvPicPr>
+        <p:blipFill>
+          <a:blip r:embed="rId6"/>
+          <a:stretch>
+            <a:fillRect/>
+          </a:stretch>
+        </p:blipFill>
+        <p:spPr>
+          <a:xfrm>
+            <a:off x="6217920" y="3166437"/>
+            <a:ext cx="5532120" cy="1896726"/>
+          </a:xfrm>
+          <a:prstGeom prst="rect">
+            <a:avLst/>
+          </a:prstGeom>
+        </p:spPr>
+      </p:pic>
+      <p:sp>
+        <p:nvSpPr>
+          <p:cNvPr id="9" name="TextBox 8"/>
           <p:cNvSpPr txBox="1"/>
           <p:nvPr/>
         </p:nvSpPr>
         <p:spPr>
           <a:xfrm>
-            <a:off x="502920" y="3840480"/>
-            <a:ext cx="11247120" cy="2651760"/>
+            <a:off x="502920" y="5257800"/>
+            <a:ext cx="11247120" cy="1188720"/>
           </a:xfrm>
           <a:prstGeom prst="rect">
             <a:avLst/>
@@ -9992,65 +7819,33 @@
           <a:p>
             <a:pPr>
               <a:spcAft>
-                <a:spcPts val="600"/>
+                <a:spcPts val="800"/>
               </a:spcAft>
             </a:pPr>
             <a:r>
-              <a:rPr sz="1300" b="0">
+              <a:rPr sz="1500" b="0" i="0">
                 <a:solidFill>
                   <a:srgbClr val="333333"/>
                 </a:solidFill>
                 <a:latin typeface="Arial"/>
               </a:rPr>
-              <a:t>• Horizontal axis: the whole trace, 0 to 52.43 ms; the trigger is the dotted line at 26.2 ms. Vertical: energy accumulated so far</a:t>
+              <a:t>The channels share the energy unevenly (PES1 489 eV, PES2 195 eV): the event sat closer to one side.</a:t>
             </a:r>
           </a:p>
           <a:p>
             <a:pPr>
               <a:spcAft>
-                <a:spcPts val="600"/>
+                <a:spcPts val="800"/>
               </a:spcAft>
             </a:pPr>
             <a:r>
-              <a:rPr sz="1300" b="0">
-                <a:solidFill>
-                  <a:srgbClr val="333333"/>
+              <a:rPr sz="1500" b="1" i="0">
+                <a:solidFill>
+                  <a:srgbClr val="C0392B"/>
                 </a:solidFill>
                 <a:latin typeface="Arial"/>
               </a:rPr>
-              <a:t>• Red, from the fitted pulse: zero before the pulse, up within 1 ms, then flat. Its end value is exactly the closed-form integral (green dashed) — the energy does not depend on any window</a:t>
-            </a:r>
-          </a:p>
-          <a:p>
-            <a:pPr>
-              <a:spcAft>
-                <a:spcPts val="600"/>
-              </a:spcAft>
-            </a:pPr>
-            <a:r>
-              <a:rPr sz="1300" b="1">
-                <a:solidFill>
-                  <a:srgbClr val="C0392B"/>
-                </a:solidFill>
-                <a:latin typeface="Arial"/>
-              </a:rPr>
-              <a:t>• Grey, from the raw trace: it drifts. A baseline offset of 1 nA over 15 ms already adds 42 eV. For the right-hand event the raw integral ends at −169 eV against 277 eV from the fit</a:t>
-            </a:r>
-          </a:p>
-          <a:p>
-            <a:pPr>
-              <a:spcAft>
-                <a:spcPts val="600"/>
-              </a:spcAft>
-            </a:pPr>
-            <a:r>
-              <a:rPr sz="1300" b="0">
-                <a:solidFill>
-                  <a:srgbClr val="333333"/>
-                </a:solidFill>
-                <a:latin typeface="Arial"/>
-              </a:rPr>
-              <a:t>• This is the reason the energy is taken from the fitted pulse, as a formula in A, τ_r, τ_f, and not from a numerical integral of the data</a:t>
+              <a:t>Summed over the eleven channels: 3419 eV = 33.0 % of 10.37 keV.   PDS2 (bottom right) carries a slow swing — remember it.</a:t>
             </a:r>
           </a:p>
         </p:txBody>
@@ -10096,24 +7891,24 @@
           <a:lstStyle/>
           <a:p>
             <a:r>
-              <a:rPr sz="2600" b="1">
+              <a:rPr sz="2700" b="1" i="0">
                 <a:solidFill>
                   <a:srgbClr val="1F3864"/>
                 </a:solidFill>
                 <a:latin typeface="Arial"/>
               </a:rPr>
-              <a:t>One event, all channels: the energies add up to 33 % of 10.37 keV</a:t>
-            </a:r>
-          </a:p>
-          <a:p>
-            <a:r>
-              <a:rPr sz="1400">
+              <a:t>Now every event: one channel gives a wide, lopsided distribution</a:t>
+            </a:r>
+          </a:p>
+          <a:p>
+            <a:r>
+              <a:rPr sz="1400" b="0" i="0">
                 <a:solidFill>
                   <a:srgbClr val="666666"/>
                 </a:solidFill>
                 <a:latin typeface="Arial"/>
               </a:rPr>
-              <a:t>Z7 event 30646; four of the eleven channels shown, same axes as before</a:t>
+              <a:t>PBS1, 1917 K-line events, one fit and one integral each</a:t>
             </a:r>
           </a:p>
         </p:txBody>
@@ -10184,7 +7979,7 @@
           <a:lstStyle/>
           <a:p>
             <a:r>
-              <a:rPr sz="1000">
+              <a:rPr sz="1000" b="0" i="0">
                 <a:solidFill>
                   <a:srgbClr val="666666"/>
                 </a:solidFill>
@@ -10197,7 +7992,7 @@
       </p:sp>
       <p:pic>
         <p:nvPicPr>
-          <p:cNvPr id="5" name="Picture 4" descr="allchan_PBS1.png"/>
+          <p:cNvPr id="5" name="Picture 4" descr="hist_PBS1.png"/>
           <p:cNvPicPr>
             <a:picLocks noChangeAspect="1"/>
           </p:cNvPicPr>
@@ -10211,96 +8006,24 @@
         </p:blipFill>
         <p:spPr>
           <a:xfrm>
-            <a:off x="502920" y="1154757"/>
-            <a:ext cx="5532120" cy="1896726"/>
+            <a:off x="502920" y="1412748"/>
+            <a:ext cx="7863840" cy="4718304"/>
           </a:xfrm>
           <a:prstGeom prst="rect">
             <a:avLst/>
           </a:prstGeom>
         </p:spPr>
       </p:pic>
-      <p:pic>
-        <p:nvPicPr>
-          <p:cNvPr id="6" name="Picture 5" descr="allchan_PES1.png"/>
-          <p:cNvPicPr>
-            <a:picLocks noChangeAspect="1"/>
-          </p:cNvPicPr>
-          <p:nvPr/>
-        </p:nvPicPr>
-        <p:blipFill>
-          <a:blip r:embed="rId4"/>
-          <a:stretch>
-            <a:fillRect/>
-          </a:stretch>
-        </p:blipFill>
-        <p:spPr>
-          <a:xfrm>
-            <a:off x="6217920" y="1154757"/>
-            <a:ext cx="5532120" cy="1896726"/>
-          </a:xfrm>
-          <a:prstGeom prst="rect">
-            <a:avLst/>
-          </a:prstGeom>
-        </p:spPr>
-      </p:pic>
-      <p:pic>
-        <p:nvPicPr>
-          <p:cNvPr id="7" name="Picture 6" descr="allchan_PES2.png"/>
-          <p:cNvPicPr>
-            <a:picLocks noChangeAspect="1"/>
-          </p:cNvPicPr>
-          <p:nvPr/>
-        </p:nvPicPr>
-        <p:blipFill>
-          <a:blip r:embed="rId5"/>
-          <a:stretch>
-            <a:fillRect/>
-          </a:stretch>
-        </p:blipFill>
-        <p:spPr>
-          <a:xfrm>
-            <a:off x="502920" y="3120717"/>
-            <a:ext cx="5532120" cy="1896726"/>
-          </a:xfrm>
-          <a:prstGeom prst="rect">
-            <a:avLst/>
-          </a:prstGeom>
-        </p:spPr>
-      </p:pic>
-      <p:pic>
-        <p:nvPicPr>
-          <p:cNvPr id="8" name="Picture 7" descr="allchan_PDS2.png"/>
-          <p:cNvPicPr>
-            <a:picLocks noChangeAspect="1"/>
-          </p:cNvPicPr>
-          <p:nvPr/>
-        </p:nvPicPr>
-        <p:blipFill>
-          <a:blip r:embed="rId6"/>
-          <a:stretch>
-            <a:fillRect/>
-          </a:stretch>
-        </p:blipFill>
-        <p:spPr>
-          <a:xfrm>
-            <a:off x="6217920" y="3120717"/>
-            <a:ext cx="5532120" cy="1896726"/>
-          </a:xfrm>
-          <a:prstGeom prst="rect">
-            <a:avLst/>
-          </a:prstGeom>
-        </p:spPr>
-      </p:pic>
-      <p:sp>
-        <p:nvSpPr>
-          <p:cNvPr id="9" name="TextBox 8"/>
+      <p:sp>
+        <p:nvSpPr>
+          <p:cNvPr id="6" name="TextBox 5"/>
           <p:cNvSpPr txBox="1"/>
           <p:nvPr/>
         </p:nvSpPr>
         <p:spPr>
           <a:xfrm>
-            <a:off x="502920" y="5120640"/>
-            <a:ext cx="11247120" cy="1371600"/>
+            <a:off x="8549640" y="1463040"/>
+            <a:ext cx="3291840" cy="4572000"/>
           </a:xfrm>
           <a:prstGeom prst="rect">
             <a:avLst/>
@@ -10315,49 +8038,65 @@
           <a:p>
             <a:pPr>
               <a:spcAft>
-                <a:spcPts val="600"/>
+                <a:spcPts val="800"/>
               </a:spcAft>
             </a:pPr>
             <a:r>
-              <a:rPr sz="1250" b="0">
+              <a:rPr sz="1500" b="0" i="0">
                 <a:solidFill>
                   <a:srgbClr val="333333"/>
                 </a:solidFill>
                 <a:latin typeface="Arial"/>
               </a:rPr>
-              <a:t>• The channels see very different shares: PES1 489 eV, PES2 195 eV — the event happened closer to one side. Time constants also differ (τ_f 150–250 µs)</a:t>
+              <a:t>Red: from the fit. Grey: the official window on the raw trace. Same peak to 0.2 %.</a:t>
             </a:r>
           </a:p>
           <a:p>
             <a:pPr>
               <a:spcAft>
-                <a:spcPts val="600"/>
+                <a:spcPts val="800"/>
               </a:spcAft>
             </a:pPr>
             <a:r>
-              <a:rPr sz="1250" b="1">
+              <a:rPr sz="1500" b="1" i="0">
                 <a:solidFill>
                   <a:srgbClr val="C0392B"/>
                 </a:solidFill>
                 <a:latin typeface="Arial"/>
               </a:rPr>
-              <a:t>• Sum over the 11 channels: 3419 eV = 33.0 % of 10.37 keV. The official window applied to the raw traces gives 3397 eV = 32.8 %, 0.6 % apart</a:t>
+              <a:t>Peak 285 eV, width 15 % — for a line whose energy is fixed.</a:t>
             </a:r>
           </a:p>
           <a:p>
             <a:pPr>
               <a:spcAft>
-                <a:spcPts val="600"/>
+                <a:spcPts val="800"/>
               </a:spcAft>
             </a:pPr>
             <a:r>
-              <a:rPr sz="1250" b="0">
+              <a:rPr sz="1500" b="0" i="0">
                 <a:solidFill>
                   <a:srgbClr val="333333"/>
                 </a:solidFill>
                 <a:latin typeface="Arial"/>
               </a:rPr>
-              <a:t>• PDS2 (bottom right) carries a slow swing after 5 ms — a low-frequency artefact of that channel; its fit residual is 0.14, three times the others</a:t>
+              <a:t>The tail to the right is the events that happened near this channel.</a:t>
+            </a:r>
+          </a:p>
+          <a:p>
+            <a:pPr>
+              <a:spcAft>
+                <a:spcPts val="800"/>
+              </a:spcAft>
+            </a:pPr>
+            <a:r>
+              <a:rPr sz="1500" b="1" i="0">
+                <a:solidFill>
+                  <a:srgbClr val="C0392B"/>
+                </a:solidFill>
+                <a:latin typeface="Arial"/>
+              </a:rPr>
+              <a:t>One channel's width is event position, not noise.</a:t>
             </a:r>
           </a:p>
         </p:txBody>

</xml_diff>

<commit_message>
snolab: say 'integrate from -inf to +inf' instead of 'no window' on the formula slide
Co-Authored-By: Claude Fable 5.1 <noreply@anthropic.com>
Claude-Session: https://claude.ai/code/session_017642NhrahqPyV2kbDPpL5m
</commit_message>
<xml_diff>
--- a/snolab/collection_efficiency/presentation/SNOLAB_R4_collection_efficiency_20260910.pptx
+++ b/snolab/collection_efficiency/presentation/SNOLAB_R4_collection_efficiency_20260910.pptx
@@ -1218,7 +1218,7 @@
           <a:lstStyle/>
           <a:p>
             <a:r>
-              <a:t>TES small-signal result (Irwin &amp; Hilton), Method 1 of the CDMS note. Coefficients from the measured bias point of each channel. For a two-exponential pulse the integral is a formula in A, tau_f, tau_r: no window.</a:t>
+              <a:t>TES small-signal result (Irwin &amp; Hilton), Method 1 of the CDMS note. Coefficients from the measured bias point of each channel. For a two-exponential pulse the integral from -inf to +inf is a formula in A, tau_f, tau_r.</a:t>
             </a:r>
           </a:p>
         </p:txBody>
@@ -5198,7 +5198,7 @@
                 </a:solidFill>
                 <a:latin typeface="Arial"/>
               </a:rPr>
-              <a:t>The energy comes from the fitted pulse: no bias from the noisy maximum, no drift, no integration window.</a:t>
+              <a:t>The energy comes from the fitted pulse, integrated from −∞ to +∞: no bias from the noisy maximum, no drift.</a:t>
             </a:r>
           </a:p>
           <a:p>
@@ -6691,7 +6691,7 @@
                 </a:solidFill>
                 <a:latin typeface="Arial"/>
               </a:rPr>
-              <a:t>If the pulse is a two-exponential, the energy is a formula in A, τ_f, τ_r — no integration window.</a:t>
+              <a:t>Fit the two-exponential, integrate it from −∞ to +∞: the energy is a formula in A, τ_f, τ_r.</a:t>
             </a:r>
           </a:p>
         </p:txBody>

</xml_diff>

<commit_message>
snolab: redraw the slide 7 and 8 panels with full axes instead of cropping grids
The grid figures label only their outer rows and columns, so panels cut out of
them had no axis labels. plot_fitted_current_power.py now also writes slide
versions (two cumulative-energy panels, four channels of event 30646) with both
axis labels on every panel and one legend; numbers unchanged.

Co-Authored-By: Claude Opus 5 (1M context) <noreply@anthropic.com>
Claude-Session: https://claude.ai/code/session_017642NhrahqPyV2kbDPpL5m
</commit_message>
<xml_diff>
--- a/snolab/collection_efficiency/presentation/SNOLAB_R4_collection_efficiency_20260910.pptx
+++ b/snolab/collection_efficiency/presentation/SNOLAB_R4_collection_efficiency_20260910.pptx
@@ -7434,7 +7434,7 @@
       </p:sp>
       <p:pic>
         <p:nvPicPr>
-          <p:cNvPr id="5" name="Picture 4" descr="cum_ev30646.png"/>
+          <p:cNvPr id="5" name="Picture 4" descr="cum_slide.png"/>
           <p:cNvPicPr>
             <a:picLocks noChangeAspect="1"/>
           </p:cNvPicPr>
@@ -7448,72 +7448,24 @@
         </p:blipFill>
         <p:spPr>
           <a:xfrm>
-            <a:off x="502920" y="1304367"/>
-            <a:ext cx="5532120" cy="1871826"/>
+            <a:off x="502920" y="1413509"/>
+            <a:ext cx="11247120" cy="3436620"/>
           </a:xfrm>
           <a:prstGeom prst="rect">
             <a:avLst/>
           </a:prstGeom>
         </p:spPr>
       </p:pic>
-      <p:pic>
-        <p:nvPicPr>
-          <p:cNvPr id="6" name="Picture 5" descr="cum_ev210571.png"/>
-          <p:cNvPicPr>
-            <a:picLocks noChangeAspect="1"/>
-          </p:cNvPicPr>
-          <p:nvPr/>
-        </p:nvPicPr>
-        <p:blipFill>
-          <a:blip r:embed="rId4"/>
-          <a:stretch>
-            <a:fillRect/>
-          </a:stretch>
-        </p:blipFill>
-        <p:spPr>
-          <a:xfrm>
-            <a:off x="6217920" y="1185226"/>
-            <a:ext cx="5532120" cy="2110108"/>
-          </a:xfrm>
-          <a:prstGeom prst="rect">
-            <a:avLst/>
-          </a:prstGeom>
-        </p:spPr>
-      </p:pic>
-      <p:pic>
-        <p:nvPicPr>
-          <p:cNvPr id="7" name="Picture 6" descr="cum_legend.png"/>
-          <p:cNvPicPr>
-            <a:picLocks noChangeAspect="1"/>
-          </p:cNvPicPr>
-          <p:nvPr/>
-        </p:nvPicPr>
-        <p:blipFill>
-          <a:blip r:embed="rId5"/>
-          <a:stretch>
-            <a:fillRect/>
-          </a:stretch>
-        </p:blipFill>
-        <p:spPr>
-          <a:xfrm>
-            <a:off x="3017520" y="3406616"/>
-            <a:ext cx="6126480" cy="319087"/>
-          </a:xfrm>
-          <a:prstGeom prst="rect">
-            <a:avLst/>
-          </a:prstGeom>
-        </p:spPr>
-      </p:pic>
-      <p:sp>
-        <p:nvSpPr>
-          <p:cNvPr id="8" name="TextBox 7"/>
+      <p:sp>
+        <p:nvSpPr>
+          <p:cNvPr id="6" name="TextBox 5"/>
           <p:cNvSpPr txBox="1"/>
           <p:nvPr/>
         </p:nvSpPr>
         <p:spPr>
           <a:xfrm>
-            <a:off x="502920" y="4023360"/>
-            <a:ext cx="11247120" cy="2194560"/>
+            <a:off x="502920" y="5257800"/>
+            <a:ext cx="11247120" cy="1234440"/>
           </a:xfrm>
           <a:prstGeom prst="rect">
             <a:avLst/>
@@ -7532,7 +7484,7 @@
               </a:spcAft>
             </a:pPr>
             <a:r>
-              <a:rPr sz="1600" b="0" i="0">
+              <a:rPr sz="1500" b="0" i="0">
                 <a:solidFill>
                   <a:srgbClr val="333333"/>
                 </a:solidFill>
@@ -7548,7 +7500,7 @@
               </a:spcAft>
             </a:pPr>
             <a:r>
-              <a:rPr sz="1600" b="1" i="0">
+              <a:rPr sz="1500" b="1" i="0">
                 <a:solidFill>
                   <a:srgbClr val="C0392B"/>
                 </a:solidFill>
@@ -7701,7 +7653,7 @@
       </p:sp>
       <p:pic>
         <p:nvPicPr>
-          <p:cNvPr id="5" name="Picture 4" descr="allchan_PBS1.png"/>
+          <p:cNvPr id="5" name="Picture 4" descr="allchan_slide.png"/>
           <p:cNvPicPr>
             <a:picLocks noChangeAspect="1"/>
           </p:cNvPicPr>
@@ -7715,89 +7667,17 @@
         </p:blipFill>
         <p:spPr>
           <a:xfrm>
-            <a:off x="502920" y="1154757"/>
-            <a:ext cx="5532120" cy="1896726"/>
+            <a:off x="1941141" y="1143000"/>
+            <a:ext cx="8370678" cy="4069080"/>
           </a:xfrm>
           <a:prstGeom prst="rect">
             <a:avLst/>
           </a:prstGeom>
         </p:spPr>
       </p:pic>
-      <p:pic>
-        <p:nvPicPr>
-          <p:cNvPr id="6" name="Picture 5" descr="allchan_PES1.png"/>
-          <p:cNvPicPr>
-            <a:picLocks noChangeAspect="1"/>
-          </p:cNvPicPr>
-          <p:nvPr/>
-        </p:nvPicPr>
-        <p:blipFill>
-          <a:blip r:embed="rId4"/>
-          <a:stretch>
-            <a:fillRect/>
-          </a:stretch>
-        </p:blipFill>
-        <p:spPr>
-          <a:xfrm>
-            <a:off x="6217920" y="1154757"/>
-            <a:ext cx="5532120" cy="1896726"/>
-          </a:xfrm>
-          <a:prstGeom prst="rect">
-            <a:avLst/>
-          </a:prstGeom>
-        </p:spPr>
-      </p:pic>
-      <p:pic>
-        <p:nvPicPr>
-          <p:cNvPr id="7" name="Picture 6" descr="allchan_PES2.png"/>
-          <p:cNvPicPr>
-            <a:picLocks noChangeAspect="1"/>
-          </p:cNvPicPr>
-          <p:nvPr/>
-        </p:nvPicPr>
-        <p:blipFill>
-          <a:blip r:embed="rId5"/>
-          <a:stretch>
-            <a:fillRect/>
-          </a:stretch>
-        </p:blipFill>
-        <p:spPr>
-          <a:xfrm>
-            <a:off x="502920" y="3166437"/>
-            <a:ext cx="5532120" cy="1896726"/>
-          </a:xfrm>
-          <a:prstGeom prst="rect">
-            <a:avLst/>
-          </a:prstGeom>
-        </p:spPr>
-      </p:pic>
-      <p:pic>
-        <p:nvPicPr>
-          <p:cNvPr id="8" name="Picture 7" descr="allchan_PDS2.png"/>
-          <p:cNvPicPr>
-            <a:picLocks noChangeAspect="1"/>
-          </p:cNvPicPr>
-          <p:nvPr/>
-        </p:nvPicPr>
-        <p:blipFill>
-          <a:blip r:embed="rId6"/>
-          <a:stretch>
-            <a:fillRect/>
-          </a:stretch>
-        </p:blipFill>
-        <p:spPr>
-          <a:xfrm>
-            <a:off x="6217920" y="3166437"/>
-            <a:ext cx="5532120" cy="1896726"/>
-          </a:xfrm>
-          <a:prstGeom prst="rect">
-            <a:avLst/>
-          </a:prstGeom>
-        </p:spPr>
-      </p:pic>
-      <p:sp>
-        <p:nvSpPr>
-          <p:cNvPr id="9" name="TextBox 8"/>
+      <p:sp>
+        <p:nvSpPr>
+          <p:cNvPr id="6" name="TextBox 5"/>
           <p:cNvSpPr txBox="1"/>
           <p:nvPr/>
         </p:nvSpPr>

</xml_diff>

<commit_message>
snolab: drop the title subtitle and the charge clause on the question slide
Co-Authored-By: Claude Opus 5 (1M context) <noreply@anthropic.com>
Claude-Session: https://claude.ai/code/session_017642NhrahqPyV2kbDPpL5m
</commit_message>
<xml_diff>
--- a/snolab/collection_efficiency/presentation/SNOLAB_R4_collection_efficiency_20260910.pptx
+++ b/snolab/collection_efficiency/presentation/SNOLAB_R4_collection_efficiency_20260910.pptx
@@ -4710,17 +4710,6 @@
               <a:t>Phonon collection efficiency of Z7</a:t>
             </a:r>
           </a:p>
-          <a:p>
-            <a:r>
-              <a:rPr sz="1800" b="0" i="0">
-                <a:solidFill>
-                  <a:srgbClr val="666666"/>
-                </a:solidFill>
-                <a:latin typeface="Arial"/>
-              </a:rPr>
-              <a:t>how much of a 10.37 keV K-line event ends up in the TESs  —  read off one pulse, then followed to the whole detector</a:t>
-            </a:r>
-          </a:p>
         </p:txBody>
       </p:sp>
       <p:sp>
@@ -6451,7 +6440,7 @@
                 </a:solidFill>
                 <a:latin typeface="Arial"/>
               </a:rPr>
-              <a:t>The area under a current is a charge, not an energy — so the pulse must be turned into power first.</a:t>
+              <a:t>The area under a current is not an energy — so the pulse must be turned into power first.</a:t>
             </a:r>
           </a:p>
           <a:p>

</xml_diff>

<commit_message>
snolab: delete the bias-point sentence from the formula slide
Co-Authored-By: Claude Opus 5 (1M context) <noreply@anthropic.com>
Claude-Session: https://claude.ai/code/session_017642NhrahqPyV2kbDPpL5m
</commit_message>
<xml_diff>
--- a/snolab/collection_efficiency/presentation/SNOLAB_R4_collection_efficiency_20260910.pptx
+++ b/snolab/collection_efficiency/presentation/SNOLAB_R4_collection_efficiency_20260910.pptx
@@ -6649,22 +6649,6 @@
                 <a:latin typeface="Arial"/>
               </a:rPr>
               <a:t>Power = the change of Joule heating when the current moves by δI: a linear term and a small quadratic term.</a:t>
-            </a:r>
-          </a:p>
-          <a:p>
-            <a:pPr>
-              <a:spcAft>
-                <a:spcPts val="800"/>
-              </a:spcAft>
-            </a:pPr>
-            <a:r>
-              <a:rPr sz="1600" b="0" i="0">
-                <a:solidFill>
-                  <a:srgbClr val="333333"/>
-                </a:solidFill>
-                <a:latin typeface="Arial"/>
-              </a:rPr>
-              <a:t>Both coefficients are the measured bias point of the channel — nothing is fitted or tuned.</a:t>
             </a:r>
           </a:p>
           <a:p>

</xml_diff>

<commit_message>
snolab: explain where the power formula comes from, and drop the slide 8 subtitle
New slide 3 carries the circuit and the five steps from the heat-flow equation
to E = I0(R_L-R0) int dI + R_L int (dI)^2, with the two neglected terms (bath
leak, inductor end terms) named; the old formula slide follows it as slide 4.
Speaker script gets the matching bilingual paragraph and the timings are
retuned to about 750 s. The deck's overall logic is still under review and was
not restructured.

Co-Authored-By: Claude Opus 5 (1M context) <noreply@anthropic.com>
Claude-Session: https://claude.ai/code/session_017642NhrahqPyV2kbDPpL5m
</commit_message>
<xml_diff>
--- a/snolab/collection_efficiency/presentation/SNOLAB_R4_collection_efficiency_20260910.pptx
+++ b/snolab/collection_efficiency/presentation/SNOLAB_R4_collection_efficiency_20260910.pptx
@@ -22,6 +22,7 @@
     <p:sldId id="270" r:id="rId22"/>
     <p:sldId id="271" r:id="rId23"/>
     <p:sldId id="272" r:id="rId24"/>
+    <p:sldId id="273" r:id="rId25"/>
   </p:sldIdLst>
   <p:sldSz cx="12191695" cy="6858000" type="screen4x3"/>
   <p:notesSz cx="6858000" cy="9144000"/>
@@ -588,7 +589,7 @@
           <a:lstStyle/>
           <a:p>
             <a:r>
-              <a:t>Grey: ten channels that fit ≥ 95% of events, 1827 events, 3162 eV = 30.5%, width 7.5% — the position dependence cancels in the sum. PDS2 fits only 42% (the swing) and on those events the other ten channels are 4.8% low, so its share is a bracket: 31.5 to 32.9%. Red line 10.37 keV.</a:t>
+              <a:t>Red: fit. Grey outline: official window on the raw trace; same peak to 0.2%. Peak 285 eV, width 42 eV = 15%, for a fixed-energy line. Right tail to 600 eV: events near PBS1. The width is position, not noise.</a:t>
             </a:r>
           </a:p>
         </p:txBody>
@@ -658,7 +659,7 @@
           <a:lstStyle/>
           <a:p>
             <a:r>
-              <a:t>Chain: current -&gt; power -&gt; energy -&gt; sum -&gt; 32 ± 1%. R37 CUTE note: 26-41%. Open: Z7 only; HV bias unknown (0 V assumed); no dIdV, inductor term dropped; PDS2; 12.5% of events fit nowhere.</a:t>
+              <a:t>Grey: ten channels that fit ≥ 95% of events, 1827 events, 3162 eV = 30.5%, width 7.5% — the position dependence cancels in the sum. PDS2 fits only 42% (the swing) and on those events the other ten channels are 4.8% low, so its share is a bracket: 31.5 to 32.9%. Red line 10.37 keV.</a:t>
             </a:r>
           </a:p>
         </p:txBody>
@@ -728,7 +729,7 @@
           <a:lstStyle/>
           <a:p>
             <a:r>
-              <a:t>Z7 summed PTOFamps, our rebuild with no cut; K line at 2e-6 A.</a:t>
+              <a:t>Chain: current -&gt; power -&gt; energy -&gt; sum -&gt; 32 ± 1%. R37 CUTE note: 26-41%. Open: Z7 only; HV bias unknown (0 V assumed); no dIdV, inductor term dropped; PDS2; 12.5% of events fit nowhere.</a:t>
             </a:r>
           </a:p>
         </p:txBody>
@@ -798,7 +799,7 @@
           <a:lstStyle/>
           <a:p>
             <a:r>
-              <a:t>c2 = 2 Method 1 (used), 1 exact, -1 Method 2. Relative to exact: +0.58%, -1.15%.</a:t>
+              <a:t>Z7 summed PTOFamps, our rebuild with no cut; K line at 2e-6 A.</a:t>
             </a:r>
           </a:p>
         </p:txBody>
@@ -868,7 +869,7 @@
           <a:lstStyle/>
           <a:p>
             <a:r>
-              <a:t>All 15 example events.</a:t>
+              <a:t>c2 = 2 Method 1 (used), 1 exact, -1 Method 2. Relative to exact: +0.58%, -1.15%.</a:t>
             </a:r>
           </a:p>
         </p:txBody>
@@ -938,7 +939,7 @@
           <a:lstStyle/>
           <a:p>
             <a:r>
-              <a:t>Fit vs raw, 15 events.</a:t>
+              <a:t>All 15 example events.</a:t>
             </a:r>
           </a:p>
         </p:txBody>
@@ -1008,7 +1009,7 @@
           <a:lstStyle/>
           <a:p>
             <a:r>
-              <a:t>Sum 3419 eV = 33.0%.</a:t>
+              <a:t>Fit vs raw, 15 events.</a:t>
             </a:r>
           </a:p>
         </p:txBody>
@@ -1078,6 +1079,76 @@
           <a:lstStyle/>
           <a:p>
             <a:r>
+              <a:t>Sum 3419 eV = 33.0%.</a:t>
+            </a:r>
+          </a:p>
+        </p:txBody>
+      </p:sp>
+      <p:sp>
+        <p:nvSpPr>
+          <p:cNvPr id="4" name="Slide Number Placeholder 3"/>
+          <p:cNvSpPr>
+            <a:spLocks noGrp="1"/>
+          </p:cNvSpPr>
+          <p:nvPr>
+            <p:ph type="sldNum" idx="5" sz="quarter"/>
+          </p:nvPr>
+        </p:nvSpPr>
+        <p:spPr/>
+      </p:sp>
+    </p:spTree>
+  </p:cSld>
+  <p:clrMapOvr>
+    <a:masterClrMapping/>
+  </p:clrMapOvr>
+</p:notes>
+</file>
+
+<file path=ppt/notesSlides/notesSlide18.xml><?xml version="1.0" encoding="utf-8"?>
+<p:notes xmlns:a="http://schemas.openxmlformats.org/drawingml/2006/main" xmlns:p="http://schemas.openxmlformats.org/presentationml/2006/main" xmlns:r="http://schemas.openxmlformats.org/officeDocument/2006/relationships">
+  <p:cSld>
+    <p:spTree>
+      <p:nvGrpSpPr>
+        <p:cNvPr id="1" name=""/>
+        <p:cNvGrpSpPr/>
+        <p:nvPr/>
+      </p:nvGrpSpPr>
+      <p:grpSpPr>
+        <a:xfrm>
+          <a:off x="0" y="0"/>
+          <a:ext cx="0" cy="0"/>
+          <a:chOff x="0" y="0"/>
+          <a:chExt cx="0" cy="0"/>
+        </a:xfrm>
+      </p:grpSpPr>
+      <p:sp>
+        <p:nvSpPr>
+          <p:cNvPr id="2" name="Slide Image Placeholder 1"/>
+          <p:cNvSpPr>
+            <a:spLocks noGrp="1"/>
+          </p:cNvSpPr>
+          <p:nvPr>
+            <p:ph type="sldImg" idx="2"/>
+          </p:nvPr>
+        </p:nvSpPr>
+        <p:spPr/>
+      </p:sp>
+      <p:sp>
+        <p:nvSpPr>
+          <p:cNvPr id="3" name="Notes Placeholder 2"/>
+          <p:cNvSpPr>
+            <a:spLocks noGrp="1"/>
+          </p:cNvSpPr>
+          <p:nvPr>
+            <p:ph type="body" idx="3" sz="quarter"/>
+          </p:nvPr>
+        </p:nvSpPr>
+        <p:spPr/>
+        <p:txBody>
+          <a:bodyPr/>
+          <a:lstStyle/>
+          <a:p>
+            <a:r>
               <a:t>Every channel is right-skewed; the peaks must not be added (21% low), the means add. PDS2 left out.</a:t>
             </a:r>
           </a:p>
@@ -1218,7 +1289,7 @@
           <a:lstStyle/>
           <a:p>
             <a:r>
-              <a:t>TES small-signal result (Irwin &amp; Hilton), Method 1 of the CDMS note. Coefficients from the measured bias point of each channel. For a two-exponential pulse the integral from -inf to +inf is a formula in A, tau_f, tau_r.</a:t>
+              <a:t>An event heats the film, R_TES rises, the current falls, and the Joule heating I*V_TES falls by what the event delivered: negative electro-thermal feedback. Integrating the heat equation over the whole pulse kills the C dT term, so the absorbed energy is minus the integrated change of Joule power, which the circuit turns into an expression in dI alone. Not included: the bath leak G*int dT and the inductor end terms, both of which need G and L from dI/dV.</a:t>
             </a:r>
           </a:p>
         </p:txBody>
@@ -1288,7 +1359,7 @@
           <a:lstStyle/>
           <a:p>
             <a:r>
-              <a:t>Top: the pulse zoomed on its peak, three axes. Bottom: the power and its area. 1 ADC = 0.318 nA. The next two slides walk through the two panels.</a:t>
+              <a:t>TES small-signal result (Irwin &amp; Hilton), Method 1 of the CDMS note. Coefficients from the measured bias point of each channel. For a two-exponential pulse the integral from -inf to +inf is a formula in A, tau_f, tau_r.</a:t>
             </a:r>
           </a:p>
         </p:txBody>
@@ -1358,7 +1429,7 @@
           <a:lstStyle/>
           <a:p>
             <a:r>
-              <a:t>Grey raw samples, blue 100 kHz low pass (what the fit sees), green 20 kHz (official prefilter), red the two-exponential fit, pink band fit ± 1 sigma (89 ADC). Yellow: 98 samples within 10% of the peak. Raw max 885 ADC vs fit 717: +23%. The maximum of 98 equal samples is the biggest upward noise. The fit averages every sample.</a:t>
+              <a:t>Top: the pulse zoomed on its peak, three axes. Bottom: the power and its area. 1 ADC = 0.318 nA. The next two slides walk through the two panels.</a:t>
             </a:r>
           </a:p>
         </p:txBody>
@@ -1428,7 +1499,7 @@
           <a:lstStyle/>
           <a:p>
             <a:r>
-              <a:t>Red: power from the fitted current, two terms added. Blue dashed: linear term alone. Purple dotted: quadratic term x20. Peak 104.6 fW = 102.6 + 2.0: quadratic 1.9% of peak, 1.3% of energy. Shaded area 305.2 eV, 99% inside this window. Bottom line: the bias point that fixes the coefficients.</a:t>
+              <a:t>Grey raw samples, blue 100 kHz low pass (what the fit sees), green 20 kHz (official prefilter), red the two-exponential fit, pink band fit ± 1 sigma (89 ADC). Yellow: 98 samples within 10% of the peak. Raw max 885 ADC vs fit 717: +23%. The maximum of 98 equal samples is the biggest upward noise. The fit averages every sample.</a:t>
             </a:r>
           </a:p>
         </p:txBody>
@@ -1498,7 +1569,7 @@
           <a:lstStyle/>
           <a:p>
             <a:r>
-              <a:t>Red from the fit: zero, up within 1 ms, flat; the end equals the formula (green). Grey from the raw trace: drifts, 1 nA over 15 ms is 42 eV. Right: fit 277 eV, raw -169.</a:t>
+              <a:t>Red: power from the fitted current, two terms added. Blue dashed: linear term alone. Purple dotted: quadratic term x20. Peak 104.6 fW = 102.6 + 2.0: quadratic 1.9% of peak, 1.3% of energy. Shaded area 305.2 eV, 99% inside this window. Bottom line: the bias point that fixes the coefficients.</a:t>
             </a:r>
           </a:p>
         </p:txBody>
@@ -1568,7 +1639,7 @@
           <a:lstStyle/>
           <a:p>
             <a:r>
-              <a:t>PES1 489 eV, PES2 195 eV: position. Sum over 11 channels 3419 eV = 33.0%. Official window on the raw traces: 3397 eV = 32.8%. PDS2: slow swing after 5 ms, a low-frequency artefact; residual 0.14, three times the others.</a:t>
+              <a:t>Red from the fit: zero, up within 1 ms, flat; the end equals the formula (green). Grey from the raw trace: drifts, 1 nA over 15 ms is 42 eV. Right: fit 277 eV, raw -169.</a:t>
             </a:r>
           </a:p>
         </p:txBody>
@@ -1638,7 +1709,7 @@
           <a:lstStyle/>
           <a:p>
             <a:r>
-              <a:t>Red: fit. Grey outline: official window on the raw trace; same peak to 0.2%. Peak 285 eV, width 42 eV = 15%, for a fixed-energy line. Right tail to 600 eV: events near PBS1. The width is position, not noise.</a:t>
+              <a:t>PES1 489 eV, PES2 195 eV: position. Sum over 11 channels 3419 eV = 33.0%. Official window on the raw traces: 3397 eV = 32.8%. PDS2: slow swing after 5 ms, a low-frequency artefact; residual 0.14, three times the others.</a:t>
             </a:r>
           </a:p>
         </p:txBody>
@@ -4804,7 +4875,7 @@
                 </a:solidFill>
                 <a:latin typeface="Arial"/>
               </a:rPr>
-              <a:t>Summed over the channels: 32 ± 1 %</a:t>
+              <a:t>Now every event: one channel gives a wide, lopsided distribution</a:t>
             </a:r>
           </a:p>
           <a:p>
@@ -4815,7 +4886,7 @@
                 </a:solidFill>
                 <a:latin typeface="Arial"/>
               </a:rPr>
-              <a:t>the total energy the TESs absorbed per K-line event</a:t>
+              <a:t>PBS1, 1917 K-line events, one fit and one integral each</a:t>
             </a:r>
           </a:p>
         </p:txBody>
@@ -4899,7 +4970,7 @@
       </p:sp>
       <p:pic>
         <p:nvPicPr>
-          <p:cNvPr id="5" name="Picture 4" descr="hist_sum.png"/>
+          <p:cNvPr id="5" name="Picture 4" descr="hist_PBS1.png"/>
           <p:cNvPicPr>
             <a:picLocks noChangeAspect="1"/>
           </p:cNvPicPr>
@@ -4949,13 +5020,13 @@
               </a:spcAft>
             </a:pPr>
             <a:r>
-              <a:rPr sz="1500" b="1" i="0">
-                <a:solidFill>
-                  <a:srgbClr val="C0392B"/>
+              <a:rPr sz="1500" b="0" i="0">
+                <a:solidFill>
+                  <a:srgbClr val="333333"/>
                 </a:solidFill>
                 <a:latin typeface="Arial"/>
               </a:rPr>
-              <a:t>Ten channels summed, 1827 events: 3162 eV = 30.5 %, and the width drops to 7.5 % — the position effect cancels.</a:t>
+              <a:t>Red: from the fit. Grey: the official window on the raw trace. Same peak to 0.2 %.</a:t>
             </a:r>
           </a:p>
           <a:p>
@@ -4965,13 +5036,13 @@
               </a:spcAft>
             </a:pPr>
             <a:r>
-              <a:rPr sz="1500" b="0" i="0">
-                <a:solidFill>
-                  <a:srgbClr val="333333"/>
+              <a:rPr sz="1500" b="1" i="0">
+                <a:solidFill>
+                  <a:srgbClr val="C0392B"/>
                 </a:solidFill>
                 <a:latin typeface="Arial"/>
               </a:rPr>
-              <a:t>PDS2 fits only 42 % of the events (that slow swing), and those events are not typical; its share can only be bracketed.</a:t>
+              <a:t>Peak 285 eV, width 15 % — for a line whose energy is fixed.</a:t>
             </a:r>
           </a:p>
           <a:p>
@@ -4981,13 +5052,13 @@
               </a:spcAft>
             </a:pPr>
             <a:r>
-              <a:rPr sz="1500" b="1" i="0">
-                <a:solidFill>
-                  <a:srgbClr val="C0392B"/>
+              <a:rPr sz="1500" b="0" i="0">
+                <a:solidFill>
+                  <a:srgbClr val="333333"/>
                 </a:solidFill>
                 <a:latin typeface="Arial"/>
               </a:rPr>
-              <a:t>Full efficiency 31.5–32.9 %:  32 ± 1 %.</a:t>
+              <a:t>The tail to the right is the events that happened near this channel.</a:t>
             </a:r>
           </a:p>
           <a:p>
@@ -4997,13 +5068,13 @@
               </a:spcAft>
             </a:pPr>
             <a:r>
-              <a:rPr sz="1500" b="0" i="0">
-                <a:solidFill>
-                  <a:srgbClr val="333333"/>
+              <a:rPr sz="1500" b="1" i="0">
+                <a:solidFill>
+                  <a:srgbClr val="C0392B"/>
                 </a:solidFill>
                 <a:latin typeface="Arial"/>
               </a:rPr>
-              <a:t>Red line: 10.37 keV — two thirds of the energy never reaches the TESs.</a:t>
+              <a:t>One channel's width is event position, not noise.</a:t>
             </a:r>
           </a:p>
         </p:txBody>
@@ -5055,7 +5126,18 @@
                 </a:solidFill>
                 <a:latin typeface="Arial"/>
               </a:rPr>
-              <a:t>Summary, and what is still open</a:t>
+              <a:t>Summed over the channels: 32 ± 1 %</a:t>
+            </a:r>
+          </a:p>
+          <a:p>
+            <a:r>
+              <a:rPr sz="1400" b="0" i="0">
+                <a:solidFill>
+                  <a:srgbClr val="666666"/>
+                </a:solidFill>
+                <a:latin typeface="Arial"/>
+              </a:rPr>
+              <a:t>the total energy the TESs absorbed per K-line event</a:t>
             </a:r>
           </a:p>
         </p:txBody>
@@ -5137,16 +5219,40 @@
           </a:p>
         </p:txBody>
       </p:sp>
-      <p:sp>
-        <p:nvSpPr>
-          <p:cNvPr id="5" name="TextBox 4"/>
+      <p:pic>
+        <p:nvPicPr>
+          <p:cNvPr id="5" name="Picture 4" descr="hist_sum.png"/>
+          <p:cNvPicPr>
+            <a:picLocks noChangeAspect="1"/>
+          </p:cNvPicPr>
+          <p:nvPr/>
+        </p:nvPicPr>
+        <p:blipFill>
+          <a:blip r:embed="rId3"/>
+          <a:stretch>
+            <a:fillRect/>
+          </a:stretch>
+        </p:blipFill>
+        <p:spPr>
+          <a:xfrm>
+            <a:off x="502920" y="1412748"/>
+            <a:ext cx="7863840" cy="4718304"/>
+          </a:xfrm>
+          <a:prstGeom prst="rect">
+            <a:avLst/>
+          </a:prstGeom>
+        </p:spPr>
+      </p:pic>
+      <p:sp>
+        <p:nvSpPr>
+          <p:cNvPr id="6" name="TextBox 5"/>
           <p:cNvSpPr txBox="1"/>
           <p:nvPr/>
         </p:nvSpPr>
         <p:spPr>
           <a:xfrm>
-            <a:off x="502920" y="1325880"/>
-            <a:ext cx="11247120" cy="5029200"/>
+            <a:off x="8549640" y="1463040"/>
+            <a:ext cx="3291840" cy="4572000"/>
           </a:xfrm>
           <a:prstGeom prst="rect">
             <a:avLst/>
@@ -5165,13 +5271,13 @@
               </a:spcAft>
             </a:pPr>
             <a:r>
-              <a:rPr sz="1700" b="0" i="0">
-                <a:solidFill>
-                  <a:srgbClr val="333333"/>
+              <a:rPr sz="1500" b="1" i="0">
+                <a:solidFill>
+                  <a:srgbClr val="C0392B"/>
                 </a:solidFill>
                 <a:latin typeface="Arial"/>
               </a:rPr>
-              <a:t>A current pulse becomes a power pulse through the TES equations; the area under the power is the energy. The quadratic term is 2 %.</a:t>
+              <a:t>Ten channels summed, 1827 events: 3162 eV = 30.5 %, and the width drops to 7.5 % — the position effect cancels.</a:t>
             </a:r>
           </a:p>
           <a:p>
@@ -5181,13 +5287,13 @@
               </a:spcAft>
             </a:pPr>
             <a:r>
-              <a:rPr sz="1700" b="0" i="0">
+              <a:rPr sz="1500" b="0" i="0">
                 <a:solidFill>
                   <a:srgbClr val="333333"/>
                 </a:solidFill>
                 <a:latin typeface="Arial"/>
               </a:rPr>
-              <a:t>The energy comes from the fitted pulse, integrated from −∞ to +∞: no bias from the noisy maximum, no drift.</a:t>
+              <a:t>PDS2 fits only 42 % of the events (that slow swing), and those events are not typical; its share can only be bracketed.</a:t>
             </a:r>
           </a:p>
           <a:p>
@@ -5197,13 +5303,13 @@
               </a:spcAft>
             </a:pPr>
             <a:r>
-              <a:rPr sz="1700" b="0" i="0">
-                <a:solidFill>
-                  <a:srgbClr val="333333"/>
+              <a:rPr sz="1500" b="1" i="0">
+                <a:solidFill>
+                  <a:srgbClr val="C0392B"/>
                 </a:solidFill>
                 <a:latin typeface="Arial"/>
               </a:rPr>
-              <a:t>One channel: 15 % wide and lopsided (position). Ten channels summed: 7.5 % and symmetric.</a:t>
+              <a:t>Full efficiency 31.5–32.9 %:  32 ± 1 %.</a:t>
             </a:r>
           </a:p>
           <a:p>
@@ -5213,29 +5319,13 @@
               </a:spcAft>
             </a:pPr>
             <a:r>
-              <a:rPr sz="1700" b="1" i="0">
-                <a:solidFill>
-                  <a:srgbClr val="C0392B"/>
+              <a:rPr sz="1500" b="0" i="0">
+                <a:solidFill>
+                  <a:srgbClr val="333333"/>
                 </a:solidFill>
                 <a:latin typeface="Arial"/>
               </a:rPr>
-              <a:t>Z7 absorbs 32 ± 1 % of a 10.37 keV event in its TESs. The CDMS note on the R37 CUTE tower reports 26–41 %.</a:t>
-            </a:r>
-          </a:p>
-          <a:p>
-            <a:pPr>
-              <a:spcAft>
-                <a:spcPts val="800"/>
-              </a:spcAft>
-            </a:pPr>
-            <a:r>
-              <a:rPr sz="1700" b="0" i="0">
-                <a:solidFill>
-                  <a:srgbClr val="333333"/>
-                </a:solidFill>
-                <a:latin typeface="Arial"/>
-              </a:rPr>
-              <a:t>Open: Z7 only · the HV bias of Z7 is not established (0 V assumed) · no dI/dV, so the inductor term is dropped · PDS2 is the ± 1 % · 12.5 % of events fit in no channel and are not in the histograms.</a:t>
+              <a:t>Red line: 10.37 keV — two thirds of the energy never reaches the TESs.</a:t>
             </a:r>
           </a:p>
         </p:txBody>
@@ -5287,7 +5377,7 @@
                 </a:solidFill>
                 <a:latin typeface="Arial"/>
               </a:rPr>
-              <a:t>Backup — the events</a:t>
+              <a:t>Summary, and what is still open</a:t>
             </a:r>
           </a:p>
         </p:txBody>
@@ -5369,30 +5459,109 @@
           </a:p>
         </p:txBody>
       </p:sp>
-      <p:pic>
-        <p:nvPicPr>
-          <p:cNvPr id="5" name="Picture 4" descr="spectrum_zip7.png"/>
-          <p:cNvPicPr>
-            <a:picLocks noChangeAspect="1"/>
-          </p:cNvPicPr>
+      <p:sp>
+        <p:nvSpPr>
+          <p:cNvPr id="5" name="TextBox 4"/>
+          <p:cNvSpPr txBox="1"/>
           <p:nvPr/>
-        </p:nvPicPr>
-        <p:blipFill>
-          <a:blip r:embed="rId3"/>
-          <a:stretch>
-            <a:fillRect/>
-          </a:stretch>
-        </p:blipFill>
-        <p:spPr>
-          <a:xfrm>
-            <a:off x="991910" y="1143000"/>
-            <a:ext cx="10269140" cy="5257800"/>
-          </a:xfrm>
-          <a:prstGeom prst="rect">
-            <a:avLst/>
-          </a:prstGeom>
-        </p:spPr>
-      </p:pic>
+        </p:nvSpPr>
+        <p:spPr>
+          <a:xfrm>
+            <a:off x="502920" y="1325880"/>
+            <a:ext cx="11247120" cy="5029200"/>
+          </a:xfrm>
+          <a:prstGeom prst="rect">
+            <a:avLst/>
+          </a:prstGeom>
+          <a:noFill/>
+        </p:spPr>
+        <p:txBody>
+          <a:bodyPr wrap="square">
+            <a:spAutoFit/>
+          </a:bodyPr>
+          <a:lstStyle/>
+          <a:p>
+            <a:pPr>
+              <a:spcAft>
+                <a:spcPts val="800"/>
+              </a:spcAft>
+            </a:pPr>
+            <a:r>
+              <a:rPr sz="1700" b="0" i="0">
+                <a:solidFill>
+                  <a:srgbClr val="333333"/>
+                </a:solidFill>
+                <a:latin typeface="Arial"/>
+              </a:rPr>
+              <a:t>A current pulse becomes a power pulse through the TES equations; the area under the power is the energy. The quadratic term is 2 %.</a:t>
+            </a:r>
+          </a:p>
+          <a:p>
+            <a:pPr>
+              <a:spcAft>
+                <a:spcPts val="800"/>
+              </a:spcAft>
+            </a:pPr>
+            <a:r>
+              <a:rPr sz="1700" b="0" i="0">
+                <a:solidFill>
+                  <a:srgbClr val="333333"/>
+                </a:solidFill>
+                <a:latin typeface="Arial"/>
+              </a:rPr>
+              <a:t>The energy comes from the fitted pulse, integrated from −∞ to +∞: no bias from the noisy maximum, no drift.</a:t>
+            </a:r>
+          </a:p>
+          <a:p>
+            <a:pPr>
+              <a:spcAft>
+                <a:spcPts val="800"/>
+              </a:spcAft>
+            </a:pPr>
+            <a:r>
+              <a:rPr sz="1700" b="0" i="0">
+                <a:solidFill>
+                  <a:srgbClr val="333333"/>
+                </a:solidFill>
+                <a:latin typeface="Arial"/>
+              </a:rPr>
+              <a:t>One channel: 15 % wide and lopsided (position). Ten channels summed: 7.5 % and symmetric.</a:t>
+            </a:r>
+          </a:p>
+          <a:p>
+            <a:pPr>
+              <a:spcAft>
+                <a:spcPts val="800"/>
+              </a:spcAft>
+            </a:pPr>
+            <a:r>
+              <a:rPr sz="1700" b="1" i="0">
+                <a:solidFill>
+                  <a:srgbClr val="C0392B"/>
+                </a:solidFill>
+                <a:latin typeface="Arial"/>
+              </a:rPr>
+              <a:t>Z7 absorbs 32 ± 1 % of a 10.37 keV event in its TESs. The CDMS note on the R37 CUTE tower reports 26–41 %.</a:t>
+            </a:r>
+          </a:p>
+          <a:p>
+            <a:pPr>
+              <a:spcAft>
+                <a:spcPts val="800"/>
+              </a:spcAft>
+            </a:pPr>
+            <a:r>
+              <a:rPr sz="1700" b="0" i="0">
+                <a:solidFill>
+                  <a:srgbClr val="333333"/>
+                </a:solidFill>
+                <a:latin typeface="Arial"/>
+              </a:rPr>
+              <a:t>Open: Z7 only · the HV bias of Z7 is not established (0 V assumed) · no dI/dV, so the inductor term is dropped · PDS2 is the ± 1 % · 12.5 % of events fit in no channel and are not in the histograms.</a:t>
+            </a:r>
+          </a:p>
+        </p:txBody>
+      </p:sp>
     </p:spTree>
   </p:cSld>
   <p:clrMapOvr>
@@ -5440,7 +5609,7 @@
                 </a:solidFill>
                 <a:latin typeface="Arial"/>
               </a:rPr>
-              <a:t>Backup — the three versions of the power formula</a:t>
+              <a:t>Backup — the events</a:t>
             </a:r>
           </a:p>
         </p:txBody>
@@ -5522,93 +5691,30 @@
           </a:p>
         </p:txBody>
       </p:sp>
-      <p:sp>
-        <p:nvSpPr>
-          <p:cNvPr id="5" name="TextBox 4"/>
-          <p:cNvSpPr txBox="1"/>
+      <p:pic>
+        <p:nvPicPr>
+          <p:cNvPr id="5" name="Picture 4" descr="spectrum_zip7.png"/>
+          <p:cNvPicPr>
+            <a:picLocks noChangeAspect="1"/>
+          </p:cNvPicPr>
           <p:nvPr/>
-        </p:nvSpPr>
-        <p:spPr>
-          <a:xfrm>
-            <a:off x="502920" y="1325880"/>
-            <a:ext cx="11247120" cy="5029200"/>
-          </a:xfrm>
-          <a:prstGeom prst="rect">
-            <a:avLst/>
-          </a:prstGeom>
-          <a:noFill/>
-        </p:spPr>
-        <p:txBody>
-          <a:bodyPr wrap="square">
-            <a:spAutoFit/>
-          </a:bodyPr>
-          <a:lstStyle/>
-          <a:p>
-            <a:pPr>
-              <a:spcAft>
-                <a:spcPts val="800"/>
-              </a:spcAft>
-            </a:pPr>
-            <a:r>
-              <a:rPr sz="1700" b="0" i="0">
-                <a:solidFill>
-                  <a:srgbClr val="333333"/>
-                </a:solidFill>
-                <a:latin typeface="Arial"/>
-              </a:rPr>
-              <a:t>P = I₀(R_L − R₀)·δI + c₂·R_L·(δI)²     with c₂ = 2 (Method 1, used here), 1 (exact small-signal), −1 (Method 2)</a:t>
-            </a:r>
-          </a:p>
-          <a:p>
-            <a:pPr>
-              <a:spcAft>
-                <a:spcPts val="800"/>
-              </a:spcAft>
-            </a:pPr>
-            <a:r>
-              <a:rPr sz="1700" b="0" i="0">
-                <a:solidFill>
-                  <a:srgbClr val="333333"/>
-                </a:solidFill>
-                <a:latin typeface="Arial"/>
-              </a:rPr>
-              <a:t>Relative to the exact form: Method 1 +0.58 %, Method 2 −1.15 % in energy — far below the 15 % single-channel width and the PDS2 bracket.</a:t>
-            </a:r>
-          </a:p>
-          <a:p>
-            <a:pPr>
-              <a:spcAft>
-                <a:spcPts val="800"/>
-              </a:spcAft>
-            </a:pPr>
-            <a:r>
-              <a:rPr sz="1700" b="0" i="0">
-                <a:solidFill>
-                  <a:srgbClr val="333333"/>
-                </a:solidFill>
-                <a:latin typeface="Arial"/>
-              </a:rPr>
-              <a:t>The inductor term of the full equations needs L and the loop gain from dI/dV, which do not exist for these series on MSI; it is neglected.</a:t>
-            </a:r>
-          </a:p>
-          <a:p>
-            <a:pPr>
-              <a:spcAft>
-                <a:spcPts val="800"/>
-              </a:spcAft>
-            </a:pPr>
-            <a:r>
-              <a:rPr sz="1700" b="0" i="0">
-                <a:solidFill>
-                  <a:srgbClr val="333333"/>
-                </a:solidFill>
-                <a:latin typeface="Arial"/>
-              </a:rPr>
-              <a:t>The official Eabs (trigger bin 16383, baseline bins 93..15758, 5-pole 20 kHz prefilter, window −0.5/+1 ms, same formula) is reproduced to 0.2 %; the grey outlines on the histogram slides are it.</a:t>
-            </a:r>
-          </a:p>
-        </p:txBody>
-      </p:sp>
+        </p:nvPicPr>
+        <p:blipFill>
+          <a:blip r:embed="rId3"/>
+          <a:stretch>
+            <a:fillRect/>
+          </a:stretch>
+        </p:blipFill>
+        <p:spPr>
+          <a:xfrm>
+            <a:off x="991910" y="1143000"/>
+            <a:ext cx="10269140" cy="5257800"/>
+          </a:xfrm>
+          <a:prstGeom prst="rect">
+            <a:avLst/>
+          </a:prstGeom>
+        </p:spPr>
+      </p:pic>
     </p:spTree>
   </p:cSld>
   <p:clrMapOvr>
@@ -5656,7 +5762,7 @@
                 </a:solidFill>
                 <a:latin typeface="Arial"/>
               </a:rPr>
-              <a:t>Backup — 15 events, fitted current and power (PBS1)</a:t>
+              <a:t>Backup — the three versions of the power formula</a:t>
             </a:r>
           </a:p>
         </p:txBody>
@@ -5738,30 +5844,93 @@
           </a:p>
         </p:txBody>
       </p:sp>
-      <p:pic>
-        <p:nvPicPr>
-          <p:cNvPr id="5" name="Picture 4" descr="pulse_15events.png"/>
-          <p:cNvPicPr>
-            <a:picLocks noChangeAspect="1"/>
-          </p:cNvPicPr>
+      <p:sp>
+        <p:nvSpPr>
+          <p:cNvPr id="5" name="TextBox 4"/>
+          <p:cNvSpPr txBox="1"/>
           <p:nvPr/>
-        </p:nvPicPr>
-        <p:blipFill>
-          <a:blip r:embed="rId3"/>
-          <a:stretch>
-            <a:fillRect/>
-          </a:stretch>
-        </p:blipFill>
-        <p:spPr>
-          <a:xfrm>
-            <a:off x="2671354" y="1143000"/>
-            <a:ext cx="6910251" cy="5257800"/>
-          </a:xfrm>
-          <a:prstGeom prst="rect">
-            <a:avLst/>
-          </a:prstGeom>
-        </p:spPr>
-      </p:pic>
+        </p:nvSpPr>
+        <p:spPr>
+          <a:xfrm>
+            <a:off x="502920" y="1325880"/>
+            <a:ext cx="11247120" cy="5029200"/>
+          </a:xfrm>
+          <a:prstGeom prst="rect">
+            <a:avLst/>
+          </a:prstGeom>
+          <a:noFill/>
+        </p:spPr>
+        <p:txBody>
+          <a:bodyPr wrap="square">
+            <a:spAutoFit/>
+          </a:bodyPr>
+          <a:lstStyle/>
+          <a:p>
+            <a:pPr>
+              <a:spcAft>
+                <a:spcPts val="800"/>
+              </a:spcAft>
+            </a:pPr>
+            <a:r>
+              <a:rPr sz="1700" b="0" i="0">
+                <a:solidFill>
+                  <a:srgbClr val="333333"/>
+                </a:solidFill>
+                <a:latin typeface="Arial"/>
+              </a:rPr>
+              <a:t>P = I₀(R_L − R₀)·δI + c₂·R_L·(δI)²     with c₂ = 2 (Method 1, used here), 1 (exact small-signal), −1 (Method 2)</a:t>
+            </a:r>
+          </a:p>
+          <a:p>
+            <a:pPr>
+              <a:spcAft>
+                <a:spcPts val="800"/>
+              </a:spcAft>
+            </a:pPr>
+            <a:r>
+              <a:rPr sz="1700" b="0" i="0">
+                <a:solidFill>
+                  <a:srgbClr val="333333"/>
+                </a:solidFill>
+                <a:latin typeface="Arial"/>
+              </a:rPr>
+              <a:t>Relative to the exact form: Method 1 +0.58 %, Method 2 −1.15 % in energy — far below the 15 % single-channel width and the PDS2 bracket.</a:t>
+            </a:r>
+          </a:p>
+          <a:p>
+            <a:pPr>
+              <a:spcAft>
+                <a:spcPts val="800"/>
+              </a:spcAft>
+            </a:pPr>
+            <a:r>
+              <a:rPr sz="1700" b="0" i="0">
+                <a:solidFill>
+                  <a:srgbClr val="333333"/>
+                </a:solidFill>
+                <a:latin typeface="Arial"/>
+              </a:rPr>
+              <a:t>The inductor term of the full equations needs L and the loop gain from dI/dV, which do not exist for these series on MSI; it is neglected.</a:t>
+            </a:r>
+          </a:p>
+          <a:p>
+            <a:pPr>
+              <a:spcAft>
+                <a:spcPts val="800"/>
+              </a:spcAft>
+            </a:pPr>
+            <a:r>
+              <a:rPr sz="1700" b="0" i="0">
+                <a:solidFill>
+                  <a:srgbClr val="333333"/>
+                </a:solidFill>
+                <a:latin typeface="Arial"/>
+              </a:rPr>
+              <a:t>The official Eabs (trigger bin 16383, baseline bins 93..15758, 5-pole 20 kHz prefilter, window −0.5/+1 ms, same formula) is reproduced to 0.2 %; the grey outlines on the histogram slides are it.</a:t>
+            </a:r>
+          </a:p>
+        </p:txBody>
+      </p:sp>
     </p:spTree>
   </p:cSld>
   <p:clrMapOvr>
@@ -5809,7 +5978,7 @@
                 </a:solidFill>
                 <a:latin typeface="Arial"/>
               </a:rPr>
-              <a:t>Backup — 15 events, cumulative energy (PBS1)</a:t>
+              <a:t>Backup — 15 events, fitted current and power (PBS1)</a:t>
             </a:r>
           </a:p>
         </p:txBody>
@@ -5893,7 +6062,7 @@
       </p:sp>
       <p:pic>
         <p:nvPicPr>
-          <p:cNvPr id="5" name="Picture 4" descr="cum_15events.png"/>
+          <p:cNvPr id="5" name="Picture 4" descr="pulse_15events.png"/>
           <p:cNvPicPr>
             <a:picLocks noChangeAspect="1"/>
           </p:cNvPicPr>
@@ -5962,7 +6131,7 @@
                 </a:solidFill>
                 <a:latin typeface="Arial"/>
               </a:rPr>
-              <a:t>Backup — event 30646, all channels</a:t>
+              <a:t>Backup — 15 events, cumulative energy (PBS1)</a:t>
             </a:r>
           </a:p>
         </p:txBody>
@@ -6046,7 +6215,7 @@
       </p:sp>
       <p:pic>
         <p:nvPicPr>
-          <p:cNvPr id="5" name="Picture 4" descr="allchan_pulses.png"/>
+          <p:cNvPr id="5" name="Picture 4" descr="cum_15events.png"/>
           <p:cNvPicPr>
             <a:picLocks noChangeAspect="1"/>
           </p:cNvPicPr>
@@ -6060,8 +6229,8 @@
         </p:blipFill>
         <p:spPr>
           <a:xfrm>
-            <a:off x="502920" y="1758921"/>
-            <a:ext cx="11247120" cy="4025957"/>
+            <a:off x="2671354" y="1143000"/>
+            <a:ext cx="6910251" cy="5257800"/>
           </a:xfrm>
           <a:prstGeom prst="rect">
             <a:avLst/>
@@ -6115,7 +6284,7 @@
                 </a:solidFill>
                 <a:latin typeface="Arial"/>
               </a:rPr>
-              <a:t>Backup — energy distribution of every channel</a:t>
+              <a:t>Backup — event 30646, all channels</a:t>
             </a:r>
           </a:p>
         </p:txBody>
@@ -6193,6 +6362,159 @@
                 <a:latin typeface="Arial"/>
               </a:rPr>
               <a:t>17</a:t>
+            </a:r>
+          </a:p>
+        </p:txBody>
+      </p:sp>
+      <p:pic>
+        <p:nvPicPr>
+          <p:cNvPr id="5" name="Picture 4" descr="allchan_pulses.png"/>
+          <p:cNvPicPr>
+            <a:picLocks noChangeAspect="1"/>
+          </p:cNvPicPr>
+          <p:nvPr/>
+        </p:nvPicPr>
+        <p:blipFill>
+          <a:blip r:embed="rId3"/>
+          <a:stretch>
+            <a:fillRect/>
+          </a:stretch>
+        </p:blipFill>
+        <p:spPr>
+          <a:xfrm>
+            <a:off x="502920" y="1758921"/>
+            <a:ext cx="11247120" cy="4025957"/>
+          </a:xfrm>
+          <a:prstGeom prst="rect">
+            <a:avLst/>
+          </a:prstGeom>
+        </p:spPr>
+      </p:pic>
+    </p:spTree>
+  </p:cSld>
+  <p:clrMapOvr>
+    <a:masterClrMapping/>
+  </p:clrMapOvr>
+</p:sld>
+</file>
+
+<file path=ppt/slides/slide18.xml><?xml version="1.0" encoding="utf-8"?>
+<p:sld xmlns:a="http://schemas.openxmlformats.org/drawingml/2006/main" xmlns:p="http://schemas.openxmlformats.org/presentationml/2006/main" xmlns:r="http://schemas.openxmlformats.org/officeDocument/2006/relationships">
+  <p:cSld>
+    <p:spTree>
+      <p:nvGrpSpPr>
+        <p:cNvPr id="1" name=""/>
+        <p:cNvGrpSpPr/>
+        <p:nvPr/>
+      </p:nvGrpSpPr>
+      <p:grpSpPr/>
+      <p:sp>
+        <p:nvSpPr>
+          <p:cNvPr id="2" name="TextBox 1"/>
+          <p:cNvSpPr txBox="1"/>
+          <p:nvPr/>
+        </p:nvSpPr>
+        <p:spPr>
+          <a:xfrm>
+            <a:off x="502920" y="228600"/>
+            <a:ext cx="11247120" cy="731520"/>
+          </a:xfrm>
+          <a:prstGeom prst="rect">
+            <a:avLst/>
+          </a:prstGeom>
+          <a:noFill/>
+        </p:spPr>
+        <p:txBody>
+          <a:bodyPr wrap="square">
+            <a:spAutoFit/>
+          </a:bodyPr>
+          <a:lstStyle/>
+          <a:p>
+            <a:r>
+              <a:rPr sz="2700" b="1" i="0">
+                <a:solidFill>
+                  <a:srgbClr val="1F3864"/>
+                </a:solidFill>
+                <a:latin typeface="Arial"/>
+              </a:rPr>
+              <a:t>Backup — energy distribution of every channel</a:t>
+            </a:r>
+          </a:p>
+        </p:txBody>
+      </p:sp>
+      <p:sp>
+        <p:nvSpPr>
+          <p:cNvPr id="3" name="Rectangle 2"/>
+          <p:cNvSpPr/>
+          <p:nvPr/>
+        </p:nvSpPr>
+        <p:spPr>
+          <a:xfrm>
+            <a:off x="502920" y="969264"/>
+            <a:ext cx="11247120" cy="18000"/>
+          </a:xfrm>
+          <a:prstGeom prst="rect">
+            <a:avLst/>
+          </a:prstGeom>
+          <a:solidFill>
+            <a:srgbClr val="1F3864"/>
+          </a:solidFill>
+          <a:ln>
+            <a:noFill/>
+          </a:ln>
+        </p:spPr>
+        <p:style>
+          <a:lnRef idx="1">
+            <a:schemeClr val="accent1"/>
+          </a:lnRef>
+          <a:fillRef idx="3">
+            <a:schemeClr val="accent1"/>
+          </a:fillRef>
+          <a:effectRef idx="2">
+            <a:schemeClr val="accent1"/>
+          </a:effectRef>
+          <a:fontRef idx="minor">
+            <a:schemeClr val="lt1"/>
+          </a:fontRef>
+        </p:style>
+        <p:txBody>
+          <a:bodyPr rtlCol="0" anchor="ctr"/>
+          <a:lstStyle/>
+          <a:p>
+            <a:pPr algn="ctr"/>
+          </a:p>
+        </p:txBody>
+      </p:sp>
+      <p:sp>
+        <p:nvSpPr>
+          <p:cNvPr id="4" name="TextBox 3"/>
+          <p:cNvSpPr txBox="1"/>
+          <p:nvPr/>
+        </p:nvSpPr>
+        <p:spPr>
+          <a:xfrm>
+            <a:off x="11430000" y="6446520"/>
+            <a:ext cx="548640" cy="320040"/>
+          </a:xfrm>
+          <a:prstGeom prst="rect">
+            <a:avLst/>
+          </a:prstGeom>
+          <a:noFill/>
+        </p:spPr>
+        <p:txBody>
+          <a:bodyPr wrap="square">
+            <a:spAutoFit/>
+          </a:bodyPr>
+          <a:lstStyle/>
+          <a:p>
+            <a:r>
+              <a:rPr sz="1000" b="0" i="0">
+                <a:solidFill>
+                  <a:srgbClr val="666666"/>
+                </a:solidFill>
+                <a:latin typeface="Arial"/>
+              </a:rPr>
+              <a:t>18</a:t>
             </a:r>
           </a:p>
         </p:txBody>
@@ -6508,7 +6830,18 @@
                 </a:solidFill>
                 <a:latin typeface="Arial"/>
               </a:rPr>
-              <a:t>From current to power, from power to energy</a:t>
+              <a:t>Where the formula comes from</a:t>
+            </a:r>
+          </a:p>
+          <a:p>
+            <a:r>
+              <a:rPr sz="1400" b="0" i="0">
+                <a:solidFill>
+                  <a:srgbClr val="666666"/>
+                </a:solidFill>
+                <a:latin typeface="Arial"/>
+              </a:rPr>
+              <a:t>the film pays for the absorbed energy out of its own Joule heating</a:t>
             </a:r>
           </a:p>
         </p:txBody>
@@ -6592,7 +6925,7 @@
       </p:sp>
       <p:pic>
         <p:nvPicPr>
-          <p:cNvPr id="5" name="Picture 4" descr="formula.png"/>
+          <p:cNvPr id="5" name="Picture 4" descr="circuit.png"/>
           <p:cNvPicPr>
             <a:picLocks noChangeAspect="1"/>
           </p:cNvPicPr>
@@ -6606,24 +6939,48 @@
         </p:blipFill>
         <p:spPr>
           <a:xfrm>
-            <a:off x="997889" y="1143000"/>
-            <a:ext cx="10257182" cy="3931920"/>
+            <a:off x="502920" y="1595301"/>
+            <a:ext cx="4434840" cy="3484517"/>
           </a:xfrm>
           <a:prstGeom prst="rect">
             <a:avLst/>
           </a:prstGeom>
         </p:spPr>
       </p:pic>
-      <p:sp>
-        <p:nvSpPr>
-          <p:cNvPr id="6" name="TextBox 5"/>
+      <p:pic>
+        <p:nvPicPr>
+          <p:cNvPr id="6" name="Picture 5" descr="derivation.png"/>
+          <p:cNvPicPr>
+            <a:picLocks noChangeAspect="1"/>
+          </p:cNvPicPr>
+          <p:nvPr/>
+        </p:nvPicPr>
+        <p:blipFill>
+          <a:blip r:embed="rId4"/>
+          <a:stretch>
+            <a:fillRect/>
+          </a:stretch>
+        </p:blipFill>
+        <p:spPr>
+          <a:xfrm>
+            <a:off x="5120640" y="1179151"/>
+            <a:ext cx="6629400" cy="4316818"/>
+          </a:xfrm>
+          <a:prstGeom prst="rect">
+            <a:avLst/>
+          </a:prstGeom>
+        </p:spPr>
+      </p:pic>
+      <p:sp>
+        <p:nvSpPr>
+          <p:cNvPr id="7" name="TextBox 6"/>
           <p:cNvSpPr txBox="1"/>
           <p:nvPr/>
         </p:nvSpPr>
         <p:spPr>
           <a:xfrm>
-            <a:off x="502920" y="5166360"/>
-            <a:ext cx="11247120" cy="1371600"/>
+            <a:off x="502920" y="5669280"/>
+            <a:ext cx="11247120" cy="1097280"/>
           </a:xfrm>
           <a:prstGeom prst="rect">
             <a:avLst/>
@@ -6642,13 +6999,13 @@
               </a:spcAft>
             </a:pPr>
             <a:r>
-              <a:rPr sz="1600" b="0" i="0">
+              <a:rPr sz="1300" b="0" i="0">
                 <a:solidFill>
                   <a:srgbClr val="333333"/>
                 </a:solidFill>
                 <a:latin typeface="Arial"/>
               </a:rPr>
-              <a:t>Power = the change of Joule heating when the current moves by δI: a linear term and a small quadratic term.</a:t>
+              <a:t>An event heats the film, its resistance rises, the current falls — and the Joule heating falls by exactly what the event delivered (negative electro-thermal feedback).</a:t>
             </a:r>
           </a:p>
           <a:p>
@@ -6658,13 +7015,29 @@
               </a:spcAft>
             </a:pPr>
             <a:r>
-              <a:rPr sz="1600" b="1" i="0">
+              <a:rPr sz="1300" b="1" i="0">
                 <a:solidFill>
                   <a:srgbClr val="C0392B"/>
                 </a:solidFill>
                 <a:latin typeface="Arial"/>
               </a:rPr>
-              <a:t>Fit the two-exponential, integrate it from −∞ to +∞: the energy is a formula in A, τ_f, τ_r.</a:t>
+              <a:t>So the absorbed energy can be read from the current alone: E = −∫δP_J dt, which is the formula on the next slide.</a:t>
+            </a:r>
+          </a:p>
+          <a:p>
+            <a:pPr>
+              <a:spcAft>
+                <a:spcPts val="800"/>
+              </a:spcAft>
+            </a:pPr>
+            <a:r>
+              <a:rPr sz="1300" b="0" i="0">
+                <a:solidFill>
+                  <a:srgbClr val="333333"/>
+                </a:solidFill>
+                <a:latin typeface="Arial"/>
+              </a:rPr>
+              <a:t>Left out: the bath leak and the inductor end terms. Both need G and L from dI/dV, which these series do not have.</a:t>
             </a:r>
           </a:p>
         </p:txBody>
@@ -6716,18 +7089,7 @@
                 </a:solidFill>
                 <a:latin typeface="Arial"/>
               </a:rPr>
-              <a:t>One pulse, read three ways</a:t>
-            </a:r>
-          </a:p>
-          <a:p>
-            <a:r>
-              <a:rPr sz="1400" b="0" i="0">
-                <a:solidFill>
-                  <a:srgbClr val="666666"/>
-                </a:solidFill>
-                <a:latin typeface="Arial"/>
-              </a:rPr>
-              <a:t>Z7 PBS1, event 30646: the same trace as ADC counts, as current, as power</a:t>
+              <a:t>The formula, and the two numbers it needs</a:t>
             </a:r>
           </a:p>
         </p:txBody>
@@ -6811,7 +7173,7 @@
       </p:sp>
       <p:pic>
         <p:nvPicPr>
-          <p:cNvPr id="5" name="Picture 4" descr="peak_full.png"/>
+          <p:cNvPr id="5" name="Picture 4" descr="formula.png"/>
           <p:cNvPicPr>
             <a:picLocks noChangeAspect="1"/>
           </p:cNvPicPr>
@@ -6825,14 +7187,69 @@
         </p:blipFill>
         <p:spPr>
           <a:xfrm>
-            <a:off x="2713966" y="1143000"/>
-            <a:ext cx="6825028" cy="5257800"/>
+            <a:off x="997889" y="1143000"/>
+            <a:ext cx="10257182" cy="3931920"/>
           </a:xfrm>
           <a:prstGeom prst="rect">
             <a:avLst/>
           </a:prstGeom>
         </p:spPr>
       </p:pic>
+      <p:sp>
+        <p:nvSpPr>
+          <p:cNvPr id="6" name="TextBox 5"/>
+          <p:cNvSpPr txBox="1"/>
+          <p:nvPr/>
+        </p:nvSpPr>
+        <p:spPr>
+          <a:xfrm>
+            <a:off x="502920" y="5166360"/>
+            <a:ext cx="11247120" cy="1371600"/>
+          </a:xfrm>
+          <a:prstGeom prst="rect">
+            <a:avLst/>
+          </a:prstGeom>
+          <a:noFill/>
+        </p:spPr>
+        <p:txBody>
+          <a:bodyPr wrap="square">
+            <a:spAutoFit/>
+          </a:bodyPr>
+          <a:lstStyle/>
+          <a:p>
+            <a:pPr>
+              <a:spcAft>
+                <a:spcPts val="800"/>
+              </a:spcAft>
+            </a:pPr>
+            <a:r>
+              <a:rPr sz="1600" b="0" i="0">
+                <a:solidFill>
+                  <a:srgbClr val="333333"/>
+                </a:solidFill>
+                <a:latin typeface="Arial"/>
+              </a:rPr>
+              <a:t>Power = the change of Joule heating when the current moves by δI: a linear term and a small quadratic term.</a:t>
+            </a:r>
+          </a:p>
+          <a:p>
+            <a:pPr>
+              <a:spcAft>
+                <a:spcPts val="800"/>
+              </a:spcAft>
+            </a:pPr>
+            <a:r>
+              <a:rPr sz="1600" b="1" i="0">
+                <a:solidFill>
+                  <a:srgbClr val="C0392B"/>
+                </a:solidFill>
+                <a:latin typeface="Arial"/>
+              </a:rPr>
+              <a:t>Fit the two-exponential, integrate it from −∞ to +∞: the energy is a formula in A, τ_f, τ_r.</a:t>
+            </a:r>
+          </a:p>
+        </p:txBody>
+      </p:sp>
     </p:spTree>
   </p:cSld>
   <p:clrMapOvr>
@@ -6880,7 +7297,18 @@
                 </a:solidFill>
                 <a:latin typeface="Arial"/>
               </a:rPr>
-              <a:t>The height: take it from the fit, not from the largest sample</a:t>
+              <a:t>One pulse, read three ways</a:t>
+            </a:r>
+          </a:p>
+          <a:p>
+            <a:r>
+              <a:rPr sz="1400" b="0" i="0">
+                <a:solidFill>
+                  <a:srgbClr val="666666"/>
+                </a:solidFill>
+                <a:latin typeface="Arial"/>
+              </a:rPr>
+              <a:t>Z7 PBS1, event 30646: the same trace as ADC counts, as current, as power</a:t>
             </a:r>
           </a:p>
         </p:txBody>
@@ -6964,7 +7392,7 @@
       </p:sp>
       <p:pic>
         <p:nvPicPr>
-          <p:cNvPr id="5" name="Picture 4" descr="peak_top.png"/>
+          <p:cNvPr id="5" name="Picture 4" descr="peak_full.png"/>
           <p:cNvPicPr>
             <a:picLocks noChangeAspect="1"/>
           </p:cNvPicPr>
@@ -6978,69 +7406,14 @@
         </p:blipFill>
         <p:spPr>
           <a:xfrm>
-            <a:off x="1077759" y="1143000"/>
-            <a:ext cx="10097441" cy="4160520"/>
+            <a:off x="2713966" y="1143000"/>
+            <a:ext cx="6825028" cy="5257800"/>
           </a:xfrm>
           <a:prstGeom prst="rect">
             <a:avLst/>
           </a:prstGeom>
         </p:spPr>
       </p:pic>
-      <p:sp>
-        <p:nvSpPr>
-          <p:cNvPr id="6" name="TextBox 5"/>
-          <p:cNvSpPr txBox="1"/>
-          <p:nvPr/>
-        </p:nvSpPr>
-        <p:spPr>
-          <a:xfrm>
-            <a:off x="502920" y="5394960"/>
-            <a:ext cx="11247120" cy="1097280"/>
-          </a:xfrm>
-          <a:prstGeom prst="rect">
-            <a:avLst/>
-          </a:prstGeom>
-          <a:noFill/>
-        </p:spPr>
-        <p:txBody>
-          <a:bodyPr wrap="square">
-            <a:spAutoFit/>
-          </a:bodyPr>
-          <a:lstStyle/>
-          <a:p>
-            <a:pPr>
-              <a:spcAft>
-                <a:spcPts val="800"/>
-              </a:spcAft>
-            </a:pPr>
-            <a:r>
-              <a:rPr sz="1600" b="0" i="0">
-                <a:solidFill>
-                  <a:srgbClr val="333333"/>
-                </a:solidFill>
-                <a:latin typeface="Arial"/>
-              </a:rPr>
-              <a:t>Yellow band: 98 samples sit within 10 % of the peak. The largest of them is the largest noise excursion.</a:t>
-            </a:r>
-          </a:p>
-          <a:p>
-            <a:pPr>
-              <a:spcAft>
-                <a:spcPts val="800"/>
-              </a:spcAft>
-            </a:pPr>
-            <a:r>
-              <a:rPr sz="1600" b="1" i="0">
-                <a:solidFill>
-                  <a:srgbClr val="C0392B"/>
-                </a:solidFill>
-                <a:latin typeface="Arial"/>
-              </a:rPr>
-              <a:t>Largest raw sample 885 ADC, fit 717 ADC: the maximum reads 23 % high. Filtering helps; the fit removes it.</a:t>
-            </a:r>
-          </a:p>
-        </p:txBody>
-      </p:sp>
     </p:spTree>
   </p:cSld>
   <p:clrMapOvr>
@@ -7088,7 +7461,7 @@
                 </a:solidFill>
                 <a:latin typeface="Arial"/>
               </a:rPr>
-              <a:t>The power pulse, and its area is the energy</a:t>
+              <a:t>The height: take it from the fit, not from the largest sample</a:t>
             </a:r>
           </a:p>
         </p:txBody>
@@ -7172,7 +7545,7 @@
       </p:sp>
       <p:pic>
         <p:nvPicPr>
-          <p:cNvPr id="5" name="Picture 4" descr="peak_bottom.png"/>
+          <p:cNvPr id="5" name="Picture 4" descr="peak_top.png"/>
           <p:cNvPicPr>
             <a:picLocks noChangeAspect="1"/>
           </p:cNvPicPr>
@@ -7186,8 +7559,8 @@
         </p:blipFill>
         <p:spPr>
           <a:xfrm>
-            <a:off x="502920" y="1213485"/>
-            <a:ext cx="11247120" cy="2967990"/>
+            <a:off x="1077759" y="1143000"/>
+            <a:ext cx="10097441" cy="4160520"/>
           </a:xfrm>
           <a:prstGeom prst="rect">
             <a:avLst/>
@@ -7202,8 +7575,8 @@
         </p:nvSpPr>
         <p:spPr>
           <a:xfrm>
-            <a:off x="502920" y="4389120"/>
-            <a:ext cx="11247120" cy="2011680"/>
+            <a:off x="502920" y="5394960"/>
+            <a:ext cx="11247120" cy="1097280"/>
           </a:xfrm>
           <a:prstGeom prst="rect">
             <a:avLst/>
@@ -7228,7 +7601,7 @@
                 </a:solidFill>
                 <a:latin typeface="Arial"/>
               </a:rPr>
-              <a:t>Red: the fitted current put through the formula. Blue dashed: the linear term alone. Purple: the quadratic term, ×20.</a:t>
+              <a:t>Yellow band: 98 samples sit within 10 % of the peak. The largest of them is the largest noise excursion.</a:t>
             </a:r>
           </a:p>
           <a:p>
@@ -7244,23 +7617,7 @@
                 </a:solidFill>
                 <a:latin typeface="Arial"/>
               </a:rPr>
-              <a:t>The quadratic term is 1.9 % of the peak — the power pulse has the shape of the current pulse.</a:t>
-            </a:r>
-          </a:p>
-          <a:p>
-            <a:pPr>
-              <a:spcAft>
-                <a:spcPts val="800"/>
-              </a:spcAft>
-            </a:pPr>
-            <a:r>
-              <a:rPr sz="1600" b="1" i="0">
-                <a:solidFill>
-                  <a:srgbClr val="C0392B"/>
-                </a:solidFill>
-                <a:latin typeface="Arial"/>
-              </a:rPr>
-              <a:t>The shaded area is the energy this channel absorbed: 305 eV.</a:t>
+              <a:t>Largest raw sample 885 ADC, fit 717 ADC: the maximum reads 23 % high. Filtering helps; the fit removes it.</a:t>
             </a:r>
           </a:p>
         </p:txBody>
@@ -7312,18 +7669,7 @@
                 </a:solidFill>
                 <a:latin typeface="Arial"/>
               </a:rPr>
-              <a:t>Why the fitted pulse is integrated, and not the data</a:t>
-            </a:r>
-          </a:p>
-          <a:p>
-            <a:r>
-              <a:rPr sz="1400" b="0" i="0">
-                <a:solidFill>
-                  <a:srgbClr val="666666"/>
-                </a:solidFill>
-                <a:latin typeface="Arial"/>
-              </a:rPr>
-              <a:t>energy accumulated from the start of the 52 ms trace; trigger at the dotted line</a:t>
+              <a:t>The power pulse, and its area is the energy</a:t>
             </a:r>
           </a:p>
         </p:txBody>
@@ -7407,7 +7753,7 @@
       </p:sp>
       <p:pic>
         <p:nvPicPr>
-          <p:cNvPr id="5" name="Picture 4" descr="cum_slide.png"/>
+          <p:cNvPr id="5" name="Picture 4" descr="peak_bottom.png"/>
           <p:cNvPicPr>
             <a:picLocks noChangeAspect="1"/>
           </p:cNvPicPr>
@@ -7421,8 +7767,8 @@
         </p:blipFill>
         <p:spPr>
           <a:xfrm>
-            <a:off x="502920" y="1413509"/>
-            <a:ext cx="11247120" cy="3436620"/>
+            <a:off x="502920" y="1213485"/>
+            <a:ext cx="11247120" cy="2967990"/>
           </a:xfrm>
           <a:prstGeom prst="rect">
             <a:avLst/>
@@ -7437,8 +7783,8 @@
         </p:nvSpPr>
         <p:spPr>
           <a:xfrm>
-            <a:off x="502920" y="5257800"/>
-            <a:ext cx="11247120" cy="1234440"/>
+            <a:off x="502920" y="4389120"/>
+            <a:ext cx="11247120" cy="2011680"/>
           </a:xfrm>
           <a:prstGeom prst="rect">
             <a:avLst/>
@@ -7457,13 +7803,13 @@
               </a:spcAft>
             </a:pPr>
             <a:r>
-              <a:rPr sz="1500" b="0" i="0">
+              <a:rPr sz="1600" b="0" i="0">
                 <a:solidFill>
                   <a:srgbClr val="333333"/>
                 </a:solidFill>
                 <a:latin typeface="Arial"/>
               </a:rPr>
-              <a:t>Red, from the fit: nothing before the pulse, up within 1 ms, then flat — and the end value is exactly the formula.</a:t>
+              <a:t>Red: the fitted current put through the formula. Blue dashed: the linear term alone. Purple: the quadratic term, ×20.</a:t>
             </a:r>
           </a:p>
           <a:p>
@@ -7473,13 +7819,29 @@
               </a:spcAft>
             </a:pPr>
             <a:r>
-              <a:rPr sz="1500" b="1" i="0">
+              <a:rPr sz="1600" b="1" i="0">
                 <a:solidFill>
                   <a:srgbClr val="C0392B"/>
                 </a:solidFill>
                 <a:latin typeface="Arial"/>
               </a:rPr>
-              <a:t>Grey, from the raw trace: it drifts. A 1 nA baseline offset over 15 ms is already 42 eV. Right: fit 277 eV, raw −169 eV.</a:t>
+              <a:t>The quadratic term is 1.9 % of the peak — the power pulse has the shape of the current pulse.</a:t>
+            </a:r>
+          </a:p>
+          <a:p>
+            <a:pPr>
+              <a:spcAft>
+                <a:spcPts val="800"/>
+              </a:spcAft>
+            </a:pPr>
+            <a:r>
+              <a:rPr sz="1600" b="1" i="0">
+                <a:solidFill>
+                  <a:srgbClr val="C0392B"/>
+                </a:solidFill>
+                <a:latin typeface="Arial"/>
+              </a:rPr>
+              <a:t>The shaded area is the energy this channel absorbed: 305 eV.</a:t>
             </a:r>
           </a:p>
         </p:txBody>
@@ -7531,18 +7893,7 @@
                 </a:solidFill>
                 <a:latin typeface="Arial"/>
               </a:rPr>
-              <a:t>The same event in its other channels: they add up to 33 %</a:t>
-            </a:r>
-          </a:p>
-          <a:p>
-            <a:r>
-              <a:rPr sz="1400" b="0" i="0">
-                <a:solidFill>
-                  <a:srgbClr val="666666"/>
-                </a:solidFill>
-                <a:latin typeface="Arial"/>
-              </a:rPr>
-              <a:t>Z7 event 30646; four of the eleven channels</a:t>
+              <a:t>Why the fitted pulse is integrated, and not the data</a:t>
             </a:r>
           </a:p>
         </p:txBody>
@@ -7626,7 +7977,7 @@
       </p:sp>
       <p:pic>
         <p:nvPicPr>
-          <p:cNvPr id="5" name="Picture 4" descr="allchan_slide.png"/>
+          <p:cNvPr id="5" name="Picture 4" descr="cum_slide.png"/>
           <p:cNvPicPr>
             <a:picLocks noChangeAspect="1"/>
           </p:cNvPicPr>
@@ -7640,8 +7991,8 @@
         </p:blipFill>
         <p:spPr>
           <a:xfrm>
-            <a:off x="1941141" y="1143000"/>
-            <a:ext cx="8370678" cy="4069080"/>
+            <a:off x="502920" y="1413509"/>
+            <a:ext cx="11247120" cy="3436620"/>
           </a:xfrm>
           <a:prstGeom prst="rect">
             <a:avLst/>
@@ -7657,7 +8008,7 @@
         <p:spPr>
           <a:xfrm>
             <a:off x="502920" y="5257800"/>
-            <a:ext cx="11247120" cy="1188720"/>
+            <a:ext cx="11247120" cy="1234440"/>
           </a:xfrm>
           <a:prstGeom prst="rect">
             <a:avLst/>
@@ -7682,7 +8033,7 @@
                 </a:solidFill>
                 <a:latin typeface="Arial"/>
               </a:rPr>
-              <a:t>The channels share the energy unevenly (PES1 489 eV, PES2 195 eV): the event sat closer to one side.</a:t>
+              <a:t>Red, from the fit: nothing before the pulse, up within 1 ms, then flat — and the end value is exactly the formula.</a:t>
             </a:r>
           </a:p>
           <a:p>
@@ -7698,7 +8049,7 @@
                 </a:solidFill>
                 <a:latin typeface="Arial"/>
               </a:rPr>
-              <a:t>Summed over the eleven channels: 3419 eV = 33.0 % of 10.37 keV.   PDS2 (bottom right) carries a slow swing — remember it.</a:t>
+              <a:t>Grey, from the raw trace: it drifts. A 1 nA baseline offset over 15 ms is already 42 eV. Right: fit 277 eV, raw −169 eV.</a:t>
             </a:r>
           </a:p>
         </p:txBody>
@@ -7750,7 +8101,7 @@
                 </a:solidFill>
                 <a:latin typeface="Arial"/>
               </a:rPr>
-              <a:t>Now every event: one channel gives a wide, lopsided distribution</a:t>
+              <a:t>The same event in its other channels: they add up to 33 %</a:t>
             </a:r>
           </a:p>
           <a:p>
@@ -7761,7 +8112,7 @@
                 </a:solidFill>
                 <a:latin typeface="Arial"/>
               </a:rPr>
-              <a:t>PBS1, 1917 K-line events, one fit and one integral each</a:t>
+              <a:t>Z7 event 30646; four of the eleven channels</a:t>
             </a:r>
           </a:p>
         </p:txBody>
@@ -7845,7 +8196,7 @@
       </p:sp>
       <p:pic>
         <p:nvPicPr>
-          <p:cNvPr id="5" name="Picture 4" descr="hist_PBS1.png"/>
+          <p:cNvPr id="5" name="Picture 4" descr="allchan_slide.png"/>
           <p:cNvPicPr>
             <a:picLocks noChangeAspect="1"/>
           </p:cNvPicPr>
@@ -7859,8 +8210,8 @@
         </p:blipFill>
         <p:spPr>
           <a:xfrm>
-            <a:off x="502920" y="1412748"/>
-            <a:ext cx="7863840" cy="4718304"/>
+            <a:off x="1941141" y="1143000"/>
+            <a:ext cx="8370678" cy="4069080"/>
           </a:xfrm>
           <a:prstGeom prst="rect">
             <a:avLst/>
@@ -7875,8 +8226,8 @@
         </p:nvSpPr>
         <p:spPr>
           <a:xfrm>
-            <a:off x="8549640" y="1463040"/>
-            <a:ext cx="3291840" cy="4572000"/>
+            <a:off x="502920" y="5257800"/>
+            <a:ext cx="11247120" cy="1188720"/>
           </a:xfrm>
           <a:prstGeom prst="rect">
             <a:avLst/>
@@ -7901,7 +8252,7 @@
                 </a:solidFill>
                 <a:latin typeface="Arial"/>
               </a:rPr>
-              <a:t>Red: from the fit. Grey: the official window on the raw trace. Same peak to 0.2 %.</a:t>
+              <a:t>The channels share the energy unevenly (PES1 489 eV, PES2 195 eV): the event sat closer to one side.</a:t>
             </a:r>
           </a:p>
           <a:p>
@@ -7917,39 +8268,7 @@
                 </a:solidFill>
                 <a:latin typeface="Arial"/>
               </a:rPr>
-              <a:t>Peak 285 eV, width 15 % — for a line whose energy is fixed.</a:t>
-            </a:r>
-          </a:p>
-          <a:p>
-            <a:pPr>
-              <a:spcAft>
-                <a:spcPts val="800"/>
-              </a:spcAft>
-            </a:pPr>
-            <a:r>
-              <a:rPr sz="1500" b="0" i="0">
-                <a:solidFill>
-                  <a:srgbClr val="333333"/>
-                </a:solidFill>
-                <a:latin typeface="Arial"/>
-              </a:rPr>
-              <a:t>The tail to the right is the events that happened near this channel.</a:t>
-            </a:r>
-          </a:p>
-          <a:p>
-            <a:pPr>
-              <a:spcAft>
-                <a:spcPts val="800"/>
-              </a:spcAft>
-            </a:pPr>
-            <a:r>
-              <a:rPr sz="1500" b="1" i="0">
-                <a:solidFill>
-                  <a:srgbClr val="C0392B"/>
-                </a:solidFill>
-                <a:latin typeface="Arial"/>
-              </a:rPr>
-              <a:t>One channel's width is event position, not noise.</a:t>
+              <a:t>Summed over the eleven channels: 3419 eV = 33.0 % of 10.37 keV.   PDS2 (bottom right) carries a slow swing — remember it.</a:t>
             </a:r>
           </a:p>
         </p:txBody>

</xml_diff>

<commit_message>
snolab: apply Prof. Liu's annotations to the collection-efficiency talk
- question slide: 0 V / no NTL condition on the definition, energy summed over
  channels, deltaP in the chain, the two struck lines removed, data from SNOLAB R4
- formula slide: deltaP, I0(R_L-R0) as 0.45 uV, the -inf..+inf line removed
- example slide: new title, bold description, fit stated to be on the 100 kHz LP
- fit-vs-raw slide: raw current of both events drawn above the cumulative energy
- other-channels slide: 'remember it' removed
The annotated PDF is kept next to the deck. Speaker script updated to match.

Co-Authored-By: Claude Opus 5 (1M context) <noreply@anthropic.com>
Claude-Session: https://claude.ai/code/session_017642NhrahqPyV2kbDPpL5m
</commit_message>
<xml_diff>
--- a/snolab/collection_efficiency/presentation/SNOLAB_R4_collection_efficiency_20260910.pptx
+++ b/snolab/collection_efficiency/presentation/SNOLAB_R4_collection_efficiency_20260910.pptx
@@ -1219,7 +1219,7 @@
           <a:lstStyle/>
           <a:p>
             <a:r>
-              <a:t>Efficiency = energy in the TES films / 10.37 keV. The trace is a current; its area is a charge, not an energy. Z7, K-line events of the Ge activation, 2207 events over 30 series, raw traces of all 11 channels saved.</a:t>
+              <a:t>Efficiency = energy absorbed by the TESs, summed over all channels, / 10.37 keV, for a detector operated at 0 V (no NTL amplification). Z7, K-line events of the Ge activation, SNOLAB R4, 2207 events over 30 series.</a:t>
             </a:r>
           </a:p>
         </p:txBody>
@@ -1359,7 +1359,7 @@
           <a:lstStyle/>
           <a:p>
             <a:r>
-              <a:t>TES small-signal result (Irwin &amp; Hilton), Method 1 of the CDMS note. Coefficients from the measured bias point of each channel. For a two-exponential pulse the integral from -inf to +inf is a formula in A, tau_f, tau_r.</a:t>
+              <a:t>TES small-signal result (Irwin &amp; Hilton), Method 1 of the CDMS note. Coefficients from the measured bias point of each channel: I0(R_L-R0) = 0.45 uV, 2R_L = 0.0385 Ohm for PBS1. For a two-exponential pulse the integral is a formula in A, tau_f, tau_r.</a:t>
             </a:r>
           </a:p>
         </p:txBody>
@@ -1639,7 +1639,7 @@
           <a:lstStyle/>
           <a:p>
             <a:r>
-              <a:t>Red from the fit: zero, up within 1 ms, flat; the end equals the formula (green). Grey from the raw trace: drifts, 1 nA over 15 ms is 42 eV. Right: fit 277 eV, raw -169.</a:t>
+              <a:t>Top: raw current of events 30646 and 210571, y zoomed to +-60 nA; dashed green is the mean after the pulse. Bottom: accumulated energy. Left: after-pulse mean +0.1 nA, raw 316 vs fit 305 eV. Right: -6.2 nA, i.e. -2.8 fW over 24 ms = -420 eV, raw -169 vs fit 277.</a:t>
             </a:r>
           </a:p>
         </p:txBody>
@@ -5878,7 +5878,7 @@
                 </a:solidFill>
                 <a:latin typeface="Arial"/>
               </a:rPr>
-              <a:t>P = I₀(R_L − R₀)·δI + c₂·R_L·(δI)²     with c₂ = 2 (Method 1, used here), 1 (exact small-signal), −1 (Method 2)</a:t>
+              <a:t>δP = I₀(R_L − R₀)·δI + c₂·R_L·(δI)²     with c₂ = 2 (Method 1, used here), 1 (exact small-signal), −1 (Method 2)</a:t>
             </a:r>
           </a:p>
           <a:p>
@@ -6724,13 +6724,13 @@
               </a:spcAft>
             </a:pPr>
             <a:r>
-              <a:rPr sz="1800" b="0" i="0">
-                <a:solidFill>
-                  <a:srgbClr val="333333"/>
+              <a:rPr sz="1800" b="1" i="0">
+                <a:solidFill>
+                  <a:srgbClr val="C0392B"/>
                 </a:solidFill>
                 <a:latin typeface="Arial"/>
               </a:rPr>
-              <a:t>Collection efficiency  =  energy that reaches the TES films  ÷  the 10.37 keV of the event</a:t>
+              <a:t>For detectors operated at 0 V (no NTL effect):</a:t>
             </a:r>
           </a:p>
           <a:p>
@@ -6746,7 +6746,7 @@
                 </a:solidFill>
                 <a:latin typeface="Arial"/>
               </a:rPr>
-              <a:t>What we record is a current pulse.</a:t>
+              <a:t>Collection efficiency  =  energy absorbed by the TESs, summed over all channels  ÷  the 10.37 keV of the event</a:t>
             </a:r>
           </a:p>
           <a:p>
@@ -6756,29 +6756,13 @@
               </a:spcAft>
             </a:pPr>
             <a:r>
-              <a:rPr sz="1800" b="1" i="0">
-                <a:solidFill>
-                  <a:srgbClr val="C0392B"/>
+              <a:rPr sz="1800" b="0" i="0">
+                <a:solidFill>
+                  <a:srgbClr val="333333"/>
                 </a:solidFill>
                 <a:latin typeface="Arial"/>
               </a:rPr>
-              <a:t>The area under a current is not an energy — so the pulse must be turned into power first.</a:t>
-            </a:r>
-          </a:p>
-          <a:p>
-            <a:pPr>
-              <a:spcAft>
-                <a:spcPts val="800"/>
-              </a:spcAft>
-            </a:pPr>
-            <a:r>
-              <a:rPr sz="1800" b="0" i="0">
-                <a:solidFill>
-                  <a:srgbClr val="333333"/>
-                </a:solidFill>
-                <a:latin typeface="Arial"/>
-              </a:rPr>
-              <a:t>Sample: Z7, the K-line events of the Ge activation run (2207 events, 30 series, all 11 channels saved raw).</a:t>
+              <a:t>Sample: Z7, the K-line events of the Ge activation run, from SNOLAB R4 (2207 events, 30 series, all 11 channels).</a:t>
             </a:r>
           </a:p>
         </p:txBody>
@@ -7229,23 +7213,7 @@
                 </a:solidFill>
                 <a:latin typeface="Arial"/>
               </a:rPr>
-              <a:t>Power = the change of Joule heating when the current moves by δI: a linear term and a small quadratic term.</a:t>
-            </a:r>
-          </a:p>
-          <a:p>
-            <a:pPr>
-              <a:spcAft>
-                <a:spcPts val="800"/>
-              </a:spcAft>
-            </a:pPr>
-            <a:r>
-              <a:rPr sz="1600" b="1" i="0">
-                <a:solidFill>
-                  <a:srgbClr val="C0392B"/>
-                </a:solidFill>
-                <a:latin typeface="Arial"/>
-              </a:rPr>
-              <a:t>Fit the two-exponential, integrate it from −∞ to +∞: the energy is a formula in A, τ_f, τ_r.</a:t>
+              <a:t>δP = the change of Joule heating when the current moves by δI: a linear term and a small quadratic term.</a:t>
             </a:r>
           </a:p>
         </p:txBody>
@@ -7297,7 +7265,7 @@
                 </a:solidFill>
                 <a:latin typeface="Arial"/>
               </a:rPr>
-              <a:t>One pulse, read three ways</a:t>
+              <a:t>Example: one pulse</a:t>
             </a:r>
           </a:p>
           <a:p>
@@ -7308,7 +7276,16 @@
                 </a:solidFill>
                 <a:latin typeface="Arial"/>
               </a:rPr>
-              <a:t>Z7 PBS1, event 30646: the same trace as ADC counts, as current, as power</a:t>
+              <a:t>Z7 PBS1, event 30646:  </a:t>
+            </a:r>
+            <a:r>
+              <a:rPr sz="1400" b="1" i="0">
+                <a:solidFill>
+                  <a:srgbClr val="333333"/>
+                </a:solidFill>
+                <a:latin typeface="Arial"/>
+              </a:rPr>
+              <a:t>the same trace as ADC counts, as current, as power</a:t>
             </a:r>
           </a:p>
         </p:txBody>
@@ -7406,14 +7383,53 @@
         </p:blipFill>
         <p:spPr>
           <a:xfrm>
-            <a:off x="2713966" y="1143000"/>
-            <a:ext cx="6825028" cy="5257800"/>
+            <a:off x="2981032" y="1143000"/>
+            <a:ext cx="6290896" cy="4846320"/>
           </a:xfrm>
           <a:prstGeom prst="rect">
             <a:avLst/>
           </a:prstGeom>
         </p:spPr>
       </p:pic>
+      <p:sp>
+        <p:nvSpPr>
+          <p:cNvPr id="6" name="TextBox 5"/>
+          <p:cNvSpPr txBox="1"/>
+          <p:nvPr/>
+        </p:nvSpPr>
+        <p:spPr>
+          <a:xfrm>
+            <a:off x="502920" y="6053328"/>
+            <a:ext cx="11247120" cy="457200"/>
+          </a:xfrm>
+          <a:prstGeom prst="rect">
+            <a:avLst/>
+          </a:prstGeom>
+          <a:noFill/>
+        </p:spPr>
+        <p:txBody>
+          <a:bodyPr wrap="square">
+            <a:spAutoFit/>
+          </a:bodyPr>
+          <a:lstStyle/>
+          <a:p>
+            <a:pPr>
+              <a:spcAft>
+                <a:spcPts val="800"/>
+              </a:spcAft>
+            </a:pPr>
+            <a:r>
+              <a:rPr sz="1400" b="1" i="0">
+                <a:solidFill>
+                  <a:srgbClr val="C0392B"/>
+                </a:solidFill>
+                <a:latin typeface="Arial"/>
+              </a:rPr>
+              <a:t>The two-exponential is fitted to the 100 kHz low-passed trace (blue), not to the raw samples; the raw samples are only drawn.</a:t>
+            </a:r>
+          </a:p>
+        </p:txBody>
+      </p:sp>
     </p:spTree>
   </p:cSld>
   <p:clrMapOvr>
@@ -7977,7 +7993,7 @@
       </p:sp>
       <p:pic>
         <p:nvPicPr>
-          <p:cNvPr id="5" name="Picture 4" descr="cum_slide.png"/>
+          <p:cNvPr id="5" name="Picture 4" descr="raw_cum_slide.png"/>
           <p:cNvPicPr>
             <a:picLocks noChangeAspect="1"/>
           </p:cNvPicPr>
@@ -7991,8 +8007,8 @@
         </p:blipFill>
         <p:spPr>
           <a:xfrm>
-            <a:off x="502920" y="1413509"/>
-            <a:ext cx="11247120" cy="3436620"/>
+            <a:off x="1751798" y="1143000"/>
+            <a:ext cx="8749364" cy="4617720"/>
           </a:xfrm>
           <a:prstGeom prst="rect">
             <a:avLst/>
@@ -8007,8 +8023,8 @@
         </p:nvSpPr>
         <p:spPr>
           <a:xfrm>
-            <a:off x="502920" y="5257800"/>
-            <a:ext cx="11247120" cy="1234440"/>
+            <a:off x="502920" y="5788152"/>
+            <a:ext cx="11247120" cy="822960"/>
           </a:xfrm>
           <a:prstGeom prst="rect">
             <a:avLst/>
@@ -8027,13 +8043,13 @@
               </a:spcAft>
             </a:pPr>
             <a:r>
-              <a:rPr sz="1500" b="0" i="0">
+              <a:rPr sz="1300" b="0" i="0">
                 <a:solidFill>
                   <a:srgbClr val="333333"/>
                 </a:solidFill>
                 <a:latin typeface="Arial"/>
               </a:rPr>
-              <a:t>Red, from the fit: nothing before the pulse, up within 1 ms, then flat — and the end value is exactly the formula.</a:t>
+              <a:t>Top: the raw current of the same two events, zoomed on the baseline. Bottom: the energy accumulated from it (grey) and from the fit (red).</a:t>
             </a:r>
           </a:p>
           <a:p>
@@ -8043,13 +8059,13 @@
               </a:spcAft>
             </a:pPr>
             <a:r>
-              <a:rPr sz="1500" b="1" i="0">
+              <a:rPr sz="1300" b="1" i="0">
                 <a:solidFill>
                   <a:srgbClr val="C0392B"/>
                 </a:solidFill>
                 <a:latin typeface="Arial"/>
               </a:rPr>
-              <a:t>Grey, from the raw trace: it drifts. A 1 nA baseline offset over 15 ms is already 42 eV. Right: fit 277 eV, raw −169 eV.</a:t>
+              <a:t>Right: after the pulse the current sits 6 nA below its baseline — hidden in 28 nA of noise, yet over 24 ms it is −420 eV: raw −169 eV, fit 277 eV.</a:t>
             </a:r>
           </a:p>
         </p:txBody>
@@ -8268,7 +8284,7 @@
                 </a:solidFill>
                 <a:latin typeface="Arial"/>
               </a:rPr>
-              <a:t>Summed over the eleven channels: 3419 eV = 33.0 % of 10.37 keV.   PDS2 (bottom right) carries a slow swing — remember it.</a:t>
+              <a:t>Summed over the eleven channels: 3419 eV = 33.0 % of 10.37 keV.   PDS2 (bottom right) carries a slow swing.</a:t>
             </a:r>
           </a:p>
         </p:txBody>

</xml_diff>

<commit_message>
snolab: take the derivation slide out, name Method 1 and mention Method 2
The derivation is for the speaker, not the audience: slide removed, answered
in the script's likely questions instead. The formula slide now says it is
Method 1 of the CDMS note and adds one line on Method 2 (same linear term,
quadratic -R_L in our sign convention, 1.7% less energy on PBS1).

Co-Authored-By: Claude Opus 5 (1M context) <noreply@anthropic.com>
Claude-Session: https://claude.ai/code/session_017642NhrahqPyV2kbDPpL5m
</commit_message>
<xml_diff>
--- a/snolab/collection_efficiency/presentation/SNOLAB_R4_collection_efficiency_20260910.pptx
+++ b/snolab/collection_efficiency/presentation/SNOLAB_R4_collection_efficiency_20260910.pptx
@@ -22,7 +22,6 @@
     <p:sldId id="270" r:id="rId22"/>
     <p:sldId id="271" r:id="rId23"/>
     <p:sldId id="272" r:id="rId24"/>
-    <p:sldId id="273" r:id="rId25"/>
   </p:sldIdLst>
   <p:sldSz cx="12191695" cy="6858000" type="screen4x3"/>
   <p:notesSz cx="6858000" cy="9144000"/>
@@ -589,7 +588,7 @@
           <a:lstStyle/>
           <a:p>
             <a:r>
-              <a:t>Red: fit. Grey outline: official window on the raw trace; same peak to 0.2%. Peak 285 eV, width 42 eV = 15%, for a fixed-energy line. Right tail to 600 eV: events near PBS1. The width is position, not noise.</a:t>
+              <a:t>Grey: ten channels that fit ≥ 95% of events, 1827 events, 3162 eV = 30.5%, width 7.5% — the position dependence cancels in the sum. PDS2 fits only 42% (the swing) and on those events the other ten channels are 4.8% low, so its share is a bracket: 31.5 to 32.9%. Red line 10.37 keV.</a:t>
             </a:r>
           </a:p>
         </p:txBody>
@@ -659,7 +658,7 @@
           <a:lstStyle/>
           <a:p>
             <a:r>
-              <a:t>Grey: ten channels that fit ≥ 95% of events, 1827 events, 3162 eV = 30.5%, width 7.5% — the position dependence cancels in the sum. PDS2 fits only 42% (the swing) and on those events the other ten channels are 4.8% low, so its share is a bracket: 31.5 to 32.9%. Red line 10.37 keV.</a:t>
+              <a:t>Chain: current -&gt; power -&gt; energy -&gt; sum -&gt; 32 ± 1%. R37 CUTE note: 26-41%. Open: Z7 only; HV bias unknown (0 V assumed); no dIdV, inductor term dropped; PDS2; 12.5% of events fit nowhere.</a:t>
             </a:r>
           </a:p>
         </p:txBody>
@@ -729,7 +728,7 @@
           <a:lstStyle/>
           <a:p>
             <a:r>
-              <a:t>Chain: current -&gt; power -&gt; energy -&gt; sum -&gt; 32 ± 1%. R37 CUTE note: 26-41%. Open: Z7 only; HV bias unknown (0 V assumed); no dIdV, inductor term dropped; PDS2; 12.5% of events fit nowhere.</a:t>
+              <a:t>Z7 summed PTOFamps, our rebuild with no cut; K line at 2e-6 A.</a:t>
             </a:r>
           </a:p>
         </p:txBody>
@@ -799,7 +798,7 @@
           <a:lstStyle/>
           <a:p>
             <a:r>
-              <a:t>Z7 summed PTOFamps, our rebuild with no cut; K line at 2e-6 A.</a:t>
+              <a:t>c2 = 2 Method 1 (used), 1 exact, -1 Method 2. Relative to exact: +0.58%, -1.15%.</a:t>
             </a:r>
           </a:p>
         </p:txBody>
@@ -869,7 +868,7 @@
           <a:lstStyle/>
           <a:p>
             <a:r>
-              <a:t>c2 = 2 Method 1 (used), 1 exact, -1 Method 2. Relative to exact: +0.58%, -1.15%.</a:t>
+              <a:t>All 15 example events.</a:t>
             </a:r>
           </a:p>
         </p:txBody>
@@ -939,7 +938,7 @@
           <a:lstStyle/>
           <a:p>
             <a:r>
-              <a:t>All 15 example events.</a:t>
+              <a:t>Fit vs raw, 15 events.</a:t>
             </a:r>
           </a:p>
         </p:txBody>
@@ -1009,7 +1008,7 @@
           <a:lstStyle/>
           <a:p>
             <a:r>
-              <a:t>Fit vs raw, 15 events.</a:t>
+              <a:t>Sum 3419 eV = 33.0%.</a:t>
             </a:r>
           </a:p>
         </p:txBody>
@@ -1079,76 +1078,6 @@
           <a:lstStyle/>
           <a:p>
             <a:r>
-              <a:t>Sum 3419 eV = 33.0%.</a:t>
-            </a:r>
-          </a:p>
-        </p:txBody>
-      </p:sp>
-      <p:sp>
-        <p:nvSpPr>
-          <p:cNvPr id="4" name="Slide Number Placeholder 3"/>
-          <p:cNvSpPr>
-            <a:spLocks noGrp="1"/>
-          </p:cNvSpPr>
-          <p:nvPr>
-            <p:ph type="sldNum" idx="5" sz="quarter"/>
-          </p:nvPr>
-        </p:nvSpPr>
-        <p:spPr/>
-      </p:sp>
-    </p:spTree>
-  </p:cSld>
-  <p:clrMapOvr>
-    <a:masterClrMapping/>
-  </p:clrMapOvr>
-</p:notes>
-</file>
-
-<file path=ppt/notesSlides/notesSlide18.xml><?xml version="1.0" encoding="utf-8"?>
-<p:notes xmlns:a="http://schemas.openxmlformats.org/drawingml/2006/main" xmlns:p="http://schemas.openxmlformats.org/presentationml/2006/main" xmlns:r="http://schemas.openxmlformats.org/officeDocument/2006/relationships">
-  <p:cSld>
-    <p:spTree>
-      <p:nvGrpSpPr>
-        <p:cNvPr id="1" name=""/>
-        <p:cNvGrpSpPr/>
-        <p:nvPr/>
-      </p:nvGrpSpPr>
-      <p:grpSpPr>
-        <a:xfrm>
-          <a:off x="0" y="0"/>
-          <a:ext cx="0" cy="0"/>
-          <a:chOff x="0" y="0"/>
-          <a:chExt cx="0" cy="0"/>
-        </a:xfrm>
-      </p:grpSpPr>
-      <p:sp>
-        <p:nvSpPr>
-          <p:cNvPr id="2" name="Slide Image Placeholder 1"/>
-          <p:cNvSpPr>
-            <a:spLocks noGrp="1"/>
-          </p:cNvSpPr>
-          <p:nvPr>
-            <p:ph type="sldImg" idx="2"/>
-          </p:nvPr>
-        </p:nvSpPr>
-        <p:spPr/>
-      </p:sp>
-      <p:sp>
-        <p:nvSpPr>
-          <p:cNvPr id="3" name="Notes Placeholder 2"/>
-          <p:cNvSpPr>
-            <a:spLocks noGrp="1"/>
-          </p:cNvSpPr>
-          <p:nvPr>
-            <p:ph type="body" idx="3" sz="quarter"/>
-          </p:nvPr>
-        </p:nvSpPr>
-        <p:spPr/>
-        <p:txBody>
-          <a:bodyPr/>
-          <a:lstStyle/>
-          <a:p>
-            <a:r>
               <a:t>Every channel is right-skewed; the peaks must not be added (21% low), the means add. PDS2 left out.</a:t>
             </a:r>
           </a:p>
@@ -1289,7 +1218,7 @@
           <a:lstStyle/>
           <a:p>
             <a:r>
-              <a:t>An event heats the film, R_TES rises, the current falls, and the Joule heating I*V_TES falls by what the event delivered: negative electro-thermal feedback. Integrating the heat equation over the whole pulse kills the C dT term, so the absorbed energy is minus the integrated change of Joule power, which the circuit turns into an expression in dI alone. Not included: the bath leak G*int dT and the inductor end terms, both of which need G and L from dI/dV.</a:t>
+              <a:t>TES small-signal result (Irwin &amp; Hilton), Method 1 of the CDMS note. Coefficients from the measured bias point of each channel: I0(R_L-R0) = 0.45 uV, 2R_L = 0.0385 Ohm for PBS1. For a two-exponential pulse the integral is a formula in A, tau_f, tau_r.</a:t>
             </a:r>
           </a:p>
         </p:txBody>
@@ -1359,7 +1288,7 @@
           <a:lstStyle/>
           <a:p>
             <a:r>
-              <a:t>TES small-signal result (Irwin &amp; Hilton), Method 1 of the CDMS note. Coefficients from the measured bias point of each channel: I0(R_L-R0) = 0.45 uV, 2R_L = 0.0385 Ohm for PBS1. For a two-exponential pulse the integral is a formula in A, tau_f, tau_r.</a:t>
+              <a:t>Top: the pulse zoomed on its peak, three axes. Bottom: the power and its area. 1 ADC = 0.318 nA. The next two slides walk through the two panels.</a:t>
             </a:r>
           </a:p>
         </p:txBody>
@@ -1429,7 +1358,7 @@
           <a:lstStyle/>
           <a:p>
             <a:r>
-              <a:t>Top: the pulse zoomed on its peak, three axes. Bottom: the power and its area. 1 ADC = 0.318 nA. The next two slides walk through the two panels.</a:t>
+              <a:t>Grey raw samples, blue 100 kHz low pass (what the fit sees), green 20 kHz (official prefilter), red the two-exponential fit, pink band fit ± 1 sigma (89 ADC). Yellow: 98 samples within 10% of the peak. Raw max 885 ADC vs fit 717: +23%. The maximum of 98 equal samples is the biggest upward noise. The fit averages every sample.</a:t>
             </a:r>
           </a:p>
         </p:txBody>
@@ -1499,7 +1428,7 @@
           <a:lstStyle/>
           <a:p>
             <a:r>
-              <a:t>Grey raw samples, blue 100 kHz low pass (what the fit sees), green 20 kHz (official prefilter), red the two-exponential fit, pink band fit ± 1 sigma (89 ADC). Yellow: 98 samples within 10% of the peak. Raw max 885 ADC vs fit 717: +23%. The maximum of 98 equal samples is the biggest upward noise. The fit averages every sample.</a:t>
+              <a:t>Red: power from the fitted current, two terms added. Blue dashed: linear term alone. Purple dotted: quadratic term x20. Peak 104.6 fW = 102.6 + 2.0: quadratic 1.9% of peak, 1.3% of energy. Shaded area 305.2 eV, 99% inside this window. Bottom line: the bias point that fixes the coefficients.</a:t>
             </a:r>
           </a:p>
         </p:txBody>
@@ -1569,7 +1498,7 @@
           <a:lstStyle/>
           <a:p>
             <a:r>
-              <a:t>Red: power from the fitted current, two terms added. Blue dashed: linear term alone. Purple dotted: quadratic term x20. Peak 104.6 fW = 102.6 + 2.0: quadratic 1.9% of peak, 1.3% of energy. Shaded area 305.2 eV, 99% inside this window. Bottom line: the bias point that fixes the coefficients.</a:t>
+              <a:t>Top: raw current of events 30646 and 210571, y zoomed to +-60 nA; dashed green is the mean after the pulse. Bottom: accumulated energy. Left: after-pulse mean +0.1 nA, raw 316 vs fit 305 eV. Right: -6.2 nA, i.e. -2.8 fW over 24 ms = -420 eV, raw -169 vs fit 277.</a:t>
             </a:r>
           </a:p>
         </p:txBody>
@@ -1639,7 +1568,7 @@
           <a:lstStyle/>
           <a:p>
             <a:r>
-              <a:t>Top: raw current of events 30646 and 210571, y zoomed to +-60 nA; dashed green is the mean after the pulse. Bottom: accumulated energy. Left: after-pulse mean +0.1 nA, raw 316 vs fit 305 eV. Right: -6.2 nA, i.e. -2.8 fW over 24 ms = -420 eV, raw -169 vs fit 277.</a:t>
+              <a:t>PES1 489 eV, PES2 195 eV: position. Sum over 11 channels 3419 eV = 33.0%. Official window on the raw traces: 3397 eV = 32.8%. PDS2: slow swing after 5 ms, a low-frequency artefact; residual 0.14, three times the others.</a:t>
             </a:r>
           </a:p>
         </p:txBody>
@@ -1709,7 +1638,7 @@
           <a:lstStyle/>
           <a:p>
             <a:r>
-              <a:t>PES1 489 eV, PES2 195 eV: position. Sum over 11 channels 3419 eV = 33.0%. Official window on the raw traces: 3397 eV = 32.8%. PDS2: slow swing after 5 ms, a low-frequency artefact; residual 0.14, three times the others.</a:t>
+              <a:t>Red: fit. Grey outline: official window on the raw trace; same peak to 0.2%. Peak 285 eV, width 42 eV = 15%, for a fixed-energy line. Right tail to 600 eV: events near PBS1. The width is position, not noise.</a:t>
             </a:r>
           </a:p>
         </p:txBody>
@@ -4875,7 +4804,7 @@
                 </a:solidFill>
                 <a:latin typeface="Arial"/>
               </a:rPr>
-              <a:t>Now every event: one channel gives a wide, lopsided distribution</a:t>
+              <a:t>Summed over the channels: 32 ± 1 %</a:t>
             </a:r>
           </a:p>
           <a:p>
@@ -4886,7 +4815,7 @@
                 </a:solidFill>
                 <a:latin typeface="Arial"/>
               </a:rPr>
-              <a:t>PBS1, 1917 K-line events, one fit and one integral each</a:t>
+              <a:t>the total energy the TESs absorbed per K-line event</a:t>
             </a:r>
           </a:p>
         </p:txBody>
@@ -4970,7 +4899,7 @@
       </p:sp>
       <p:pic>
         <p:nvPicPr>
-          <p:cNvPr id="5" name="Picture 4" descr="hist_PBS1.png"/>
+          <p:cNvPr id="5" name="Picture 4" descr="hist_sum.png"/>
           <p:cNvPicPr>
             <a:picLocks noChangeAspect="1"/>
           </p:cNvPicPr>
@@ -5020,13 +4949,13 @@
               </a:spcAft>
             </a:pPr>
             <a:r>
-              <a:rPr sz="1500" b="0" i="0">
-                <a:solidFill>
-                  <a:srgbClr val="333333"/>
+              <a:rPr sz="1500" b="1" i="0">
+                <a:solidFill>
+                  <a:srgbClr val="C0392B"/>
                 </a:solidFill>
                 <a:latin typeface="Arial"/>
               </a:rPr>
-              <a:t>Red: from the fit. Grey: the official window on the raw trace. Same peak to 0.2 %.</a:t>
+              <a:t>Ten channels summed, 1827 events: 3162 eV = 30.5 %, and the width drops to 7.5 % — the position effect cancels.</a:t>
             </a:r>
           </a:p>
           <a:p>
@@ -5036,13 +4965,13 @@
               </a:spcAft>
             </a:pPr>
             <a:r>
-              <a:rPr sz="1500" b="1" i="0">
-                <a:solidFill>
-                  <a:srgbClr val="C0392B"/>
+              <a:rPr sz="1500" b="0" i="0">
+                <a:solidFill>
+                  <a:srgbClr val="333333"/>
                 </a:solidFill>
                 <a:latin typeface="Arial"/>
               </a:rPr>
-              <a:t>Peak 285 eV, width 15 % — for a line whose energy is fixed.</a:t>
+              <a:t>PDS2 fits only 42 % of the events (that slow swing), and those events are not typical; its share can only be bracketed.</a:t>
             </a:r>
           </a:p>
           <a:p>
@@ -5052,13 +4981,13 @@
               </a:spcAft>
             </a:pPr>
             <a:r>
-              <a:rPr sz="1500" b="0" i="0">
-                <a:solidFill>
-                  <a:srgbClr val="333333"/>
+              <a:rPr sz="1500" b="1" i="0">
+                <a:solidFill>
+                  <a:srgbClr val="C0392B"/>
                 </a:solidFill>
                 <a:latin typeface="Arial"/>
               </a:rPr>
-              <a:t>The tail to the right is the events that happened near this channel.</a:t>
+              <a:t>Full efficiency 31.5–32.9 %:  32 ± 1 %.</a:t>
             </a:r>
           </a:p>
           <a:p>
@@ -5068,13 +4997,13 @@
               </a:spcAft>
             </a:pPr>
             <a:r>
-              <a:rPr sz="1500" b="1" i="0">
-                <a:solidFill>
-                  <a:srgbClr val="C0392B"/>
+              <a:rPr sz="1500" b="0" i="0">
+                <a:solidFill>
+                  <a:srgbClr val="333333"/>
                 </a:solidFill>
                 <a:latin typeface="Arial"/>
               </a:rPr>
-              <a:t>One channel's width is event position, not noise.</a:t>
+              <a:t>Red line: 10.37 keV — two thirds of the energy never reaches the TESs.</a:t>
             </a:r>
           </a:p>
         </p:txBody>
@@ -5126,18 +5055,7 @@
                 </a:solidFill>
                 <a:latin typeface="Arial"/>
               </a:rPr>
-              <a:t>Summed over the channels: 32 ± 1 %</a:t>
-            </a:r>
-          </a:p>
-          <a:p>
-            <a:r>
-              <a:rPr sz="1400" b="0" i="0">
-                <a:solidFill>
-                  <a:srgbClr val="666666"/>
-                </a:solidFill>
-                <a:latin typeface="Arial"/>
-              </a:rPr>
-              <a:t>the total energy the TESs absorbed per K-line event</a:t>
+              <a:t>Summary, and what is still open</a:t>
             </a:r>
           </a:p>
         </p:txBody>
@@ -5219,40 +5137,16 @@
           </a:p>
         </p:txBody>
       </p:sp>
-      <p:pic>
-        <p:nvPicPr>
-          <p:cNvPr id="5" name="Picture 4" descr="hist_sum.png"/>
-          <p:cNvPicPr>
-            <a:picLocks noChangeAspect="1"/>
-          </p:cNvPicPr>
-          <p:nvPr/>
-        </p:nvPicPr>
-        <p:blipFill>
-          <a:blip r:embed="rId3"/>
-          <a:stretch>
-            <a:fillRect/>
-          </a:stretch>
-        </p:blipFill>
-        <p:spPr>
-          <a:xfrm>
-            <a:off x="502920" y="1412748"/>
-            <a:ext cx="7863840" cy="4718304"/>
-          </a:xfrm>
-          <a:prstGeom prst="rect">
-            <a:avLst/>
-          </a:prstGeom>
-        </p:spPr>
-      </p:pic>
-      <p:sp>
-        <p:nvSpPr>
-          <p:cNvPr id="6" name="TextBox 5"/>
+      <p:sp>
+        <p:nvSpPr>
+          <p:cNvPr id="5" name="TextBox 4"/>
           <p:cNvSpPr txBox="1"/>
           <p:nvPr/>
         </p:nvSpPr>
         <p:spPr>
           <a:xfrm>
-            <a:off x="8549640" y="1463040"/>
-            <a:ext cx="3291840" cy="4572000"/>
+            <a:off x="502920" y="1325880"/>
+            <a:ext cx="11247120" cy="5029200"/>
           </a:xfrm>
           <a:prstGeom prst="rect">
             <a:avLst/>
@@ -5271,13 +5165,13 @@
               </a:spcAft>
             </a:pPr>
             <a:r>
-              <a:rPr sz="1500" b="1" i="0">
-                <a:solidFill>
-                  <a:srgbClr val="C0392B"/>
+              <a:rPr sz="1700" b="0" i="0">
+                <a:solidFill>
+                  <a:srgbClr val="333333"/>
                 </a:solidFill>
                 <a:latin typeface="Arial"/>
               </a:rPr>
-              <a:t>Ten channels summed, 1827 events: 3162 eV = 30.5 %, and the width drops to 7.5 % — the position effect cancels.</a:t>
+              <a:t>A current pulse becomes a power pulse through the TES equations; the area under the power is the energy. The quadratic term is 2 %.</a:t>
             </a:r>
           </a:p>
           <a:p>
@@ -5287,13 +5181,13 @@
               </a:spcAft>
             </a:pPr>
             <a:r>
-              <a:rPr sz="1500" b="0" i="0">
+              <a:rPr sz="1700" b="0" i="0">
                 <a:solidFill>
                   <a:srgbClr val="333333"/>
                 </a:solidFill>
                 <a:latin typeface="Arial"/>
               </a:rPr>
-              <a:t>PDS2 fits only 42 % of the events (that slow swing), and those events are not typical; its share can only be bracketed.</a:t>
+              <a:t>The energy comes from the fitted pulse, integrated from −∞ to +∞: no bias from the noisy maximum, no drift.</a:t>
             </a:r>
           </a:p>
           <a:p>
@@ -5303,13 +5197,13 @@
               </a:spcAft>
             </a:pPr>
             <a:r>
-              <a:rPr sz="1500" b="1" i="0">
-                <a:solidFill>
-                  <a:srgbClr val="C0392B"/>
+              <a:rPr sz="1700" b="0" i="0">
+                <a:solidFill>
+                  <a:srgbClr val="333333"/>
                 </a:solidFill>
                 <a:latin typeface="Arial"/>
               </a:rPr>
-              <a:t>Full efficiency 31.5–32.9 %:  32 ± 1 %.</a:t>
+              <a:t>One channel: 15 % wide and lopsided (position). Ten channels summed: 7.5 % and symmetric.</a:t>
             </a:r>
           </a:p>
           <a:p>
@@ -5319,13 +5213,29 @@
               </a:spcAft>
             </a:pPr>
             <a:r>
-              <a:rPr sz="1500" b="0" i="0">
-                <a:solidFill>
-                  <a:srgbClr val="333333"/>
+              <a:rPr sz="1700" b="1" i="0">
+                <a:solidFill>
+                  <a:srgbClr val="C0392B"/>
                 </a:solidFill>
                 <a:latin typeface="Arial"/>
               </a:rPr>
-              <a:t>Red line: 10.37 keV — two thirds of the energy never reaches the TESs.</a:t>
+              <a:t>Z7 absorbs 32 ± 1 % of a 10.37 keV event in its TESs. The CDMS note on the R37 CUTE tower reports 26–41 %.</a:t>
+            </a:r>
+          </a:p>
+          <a:p>
+            <a:pPr>
+              <a:spcAft>
+                <a:spcPts val="800"/>
+              </a:spcAft>
+            </a:pPr>
+            <a:r>
+              <a:rPr sz="1700" b="0" i="0">
+                <a:solidFill>
+                  <a:srgbClr val="333333"/>
+                </a:solidFill>
+                <a:latin typeface="Arial"/>
+              </a:rPr>
+              <a:t>Open: Z7 only · the HV bias of Z7 is not established (0 V assumed) · no dI/dV, so the inductor term is dropped · PDS2 is the ± 1 % · 12.5 % of events fit in no channel and are not in the histograms.</a:t>
             </a:r>
           </a:p>
         </p:txBody>
@@ -5377,7 +5287,7 @@
                 </a:solidFill>
                 <a:latin typeface="Arial"/>
               </a:rPr>
-              <a:t>Summary, and what is still open</a:t>
+              <a:t>Backup — the events</a:t>
             </a:r>
           </a:p>
         </p:txBody>
@@ -5459,109 +5369,30 @@
           </a:p>
         </p:txBody>
       </p:sp>
-      <p:sp>
-        <p:nvSpPr>
-          <p:cNvPr id="5" name="TextBox 4"/>
-          <p:cNvSpPr txBox="1"/>
+      <p:pic>
+        <p:nvPicPr>
+          <p:cNvPr id="5" name="Picture 4" descr="spectrum_zip7.png"/>
+          <p:cNvPicPr>
+            <a:picLocks noChangeAspect="1"/>
+          </p:cNvPicPr>
           <p:nvPr/>
-        </p:nvSpPr>
-        <p:spPr>
-          <a:xfrm>
-            <a:off x="502920" y="1325880"/>
-            <a:ext cx="11247120" cy="5029200"/>
+        </p:nvPicPr>
+        <p:blipFill>
+          <a:blip r:embed="rId3"/>
+          <a:stretch>
+            <a:fillRect/>
+          </a:stretch>
+        </p:blipFill>
+        <p:spPr>
+          <a:xfrm>
+            <a:off x="991910" y="1143000"/>
+            <a:ext cx="10269140" cy="5257800"/>
           </a:xfrm>
           <a:prstGeom prst="rect">
             <a:avLst/>
           </a:prstGeom>
-          <a:noFill/>
-        </p:spPr>
-        <p:txBody>
-          <a:bodyPr wrap="square">
-            <a:spAutoFit/>
-          </a:bodyPr>
-          <a:lstStyle/>
-          <a:p>
-            <a:pPr>
-              <a:spcAft>
-                <a:spcPts val="800"/>
-              </a:spcAft>
-            </a:pPr>
-            <a:r>
-              <a:rPr sz="1700" b="0" i="0">
-                <a:solidFill>
-                  <a:srgbClr val="333333"/>
-                </a:solidFill>
-                <a:latin typeface="Arial"/>
-              </a:rPr>
-              <a:t>A current pulse becomes a power pulse through the TES equations; the area under the power is the energy. The quadratic term is 2 %.</a:t>
-            </a:r>
-          </a:p>
-          <a:p>
-            <a:pPr>
-              <a:spcAft>
-                <a:spcPts val="800"/>
-              </a:spcAft>
-            </a:pPr>
-            <a:r>
-              <a:rPr sz="1700" b="0" i="0">
-                <a:solidFill>
-                  <a:srgbClr val="333333"/>
-                </a:solidFill>
-                <a:latin typeface="Arial"/>
-              </a:rPr>
-              <a:t>The energy comes from the fitted pulse, integrated from −∞ to +∞: no bias from the noisy maximum, no drift.</a:t>
-            </a:r>
-          </a:p>
-          <a:p>
-            <a:pPr>
-              <a:spcAft>
-                <a:spcPts val="800"/>
-              </a:spcAft>
-            </a:pPr>
-            <a:r>
-              <a:rPr sz="1700" b="0" i="0">
-                <a:solidFill>
-                  <a:srgbClr val="333333"/>
-                </a:solidFill>
-                <a:latin typeface="Arial"/>
-              </a:rPr>
-              <a:t>One channel: 15 % wide and lopsided (position). Ten channels summed: 7.5 % and symmetric.</a:t>
-            </a:r>
-          </a:p>
-          <a:p>
-            <a:pPr>
-              <a:spcAft>
-                <a:spcPts val="800"/>
-              </a:spcAft>
-            </a:pPr>
-            <a:r>
-              <a:rPr sz="1700" b="1" i="0">
-                <a:solidFill>
-                  <a:srgbClr val="C0392B"/>
-                </a:solidFill>
-                <a:latin typeface="Arial"/>
-              </a:rPr>
-              <a:t>Z7 absorbs 32 ± 1 % of a 10.37 keV event in its TESs. The CDMS note on the R37 CUTE tower reports 26–41 %.</a:t>
-            </a:r>
-          </a:p>
-          <a:p>
-            <a:pPr>
-              <a:spcAft>
-                <a:spcPts val="800"/>
-              </a:spcAft>
-            </a:pPr>
-            <a:r>
-              <a:rPr sz="1700" b="0" i="0">
-                <a:solidFill>
-                  <a:srgbClr val="333333"/>
-                </a:solidFill>
-                <a:latin typeface="Arial"/>
-              </a:rPr>
-              <a:t>Open: Z7 only · the HV bias of Z7 is not established (0 V assumed) · no dI/dV, so the inductor term is dropped · PDS2 is the ± 1 % · 12.5 % of events fit in no channel and are not in the histograms.</a:t>
-            </a:r>
-          </a:p>
-        </p:txBody>
-      </p:sp>
+        </p:spPr>
+      </p:pic>
     </p:spTree>
   </p:cSld>
   <p:clrMapOvr>
@@ -5609,7 +5440,7 @@
                 </a:solidFill>
                 <a:latin typeface="Arial"/>
               </a:rPr>
-              <a:t>Backup — the events</a:t>
+              <a:t>Backup — the three versions of the power formula</a:t>
             </a:r>
           </a:p>
         </p:txBody>
@@ -5691,30 +5522,93 @@
           </a:p>
         </p:txBody>
       </p:sp>
-      <p:pic>
-        <p:nvPicPr>
-          <p:cNvPr id="5" name="Picture 4" descr="spectrum_zip7.png"/>
-          <p:cNvPicPr>
-            <a:picLocks noChangeAspect="1"/>
-          </p:cNvPicPr>
+      <p:sp>
+        <p:nvSpPr>
+          <p:cNvPr id="5" name="TextBox 4"/>
+          <p:cNvSpPr txBox="1"/>
           <p:nvPr/>
-        </p:nvPicPr>
-        <p:blipFill>
-          <a:blip r:embed="rId3"/>
-          <a:stretch>
-            <a:fillRect/>
-          </a:stretch>
-        </p:blipFill>
-        <p:spPr>
-          <a:xfrm>
-            <a:off x="991910" y="1143000"/>
-            <a:ext cx="10269140" cy="5257800"/>
+        </p:nvSpPr>
+        <p:spPr>
+          <a:xfrm>
+            <a:off x="502920" y="1325880"/>
+            <a:ext cx="11247120" cy="5029200"/>
           </a:xfrm>
           <a:prstGeom prst="rect">
             <a:avLst/>
           </a:prstGeom>
-        </p:spPr>
-      </p:pic>
+          <a:noFill/>
+        </p:spPr>
+        <p:txBody>
+          <a:bodyPr wrap="square">
+            <a:spAutoFit/>
+          </a:bodyPr>
+          <a:lstStyle/>
+          <a:p>
+            <a:pPr>
+              <a:spcAft>
+                <a:spcPts val="800"/>
+              </a:spcAft>
+            </a:pPr>
+            <a:r>
+              <a:rPr sz="1700" b="0" i="0">
+                <a:solidFill>
+                  <a:srgbClr val="333333"/>
+                </a:solidFill>
+                <a:latin typeface="Arial"/>
+              </a:rPr>
+              <a:t>δP = I₀(R_L − R₀)·δI + c₂·R_L·(δI)²     with c₂ = 2 (Method 1, used here), 1 (exact small-signal), −1 (Method 2)</a:t>
+            </a:r>
+          </a:p>
+          <a:p>
+            <a:pPr>
+              <a:spcAft>
+                <a:spcPts val="800"/>
+              </a:spcAft>
+            </a:pPr>
+            <a:r>
+              <a:rPr sz="1700" b="0" i="0">
+                <a:solidFill>
+                  <a:srgbClr val="333333"/>
+                </a:solidFill>
+                <a:latin typeface="Arial"/>
+              </a:rPr>
+              <a:t>Relative to the exact form: Method 1 +0.58 %, Method 2 −1.15 % in energy — far below the 15 % single-channel width and the PDS2 bracket.</a:t>
+            </a:r>
+          </a:p>
+          <a:p>
+            <a:pPr>
+              <a:spcAft>
+                <a:spcPts val="800"/>
+              </a:spcAft>
+            </a:pPr>
+            <a:r>
+              <a:rPr sz="1700" b="0" i="0">
+                <a:solidFill>
+                  <a:srgbClr val="333333"/>
+                </a:solidFill>
+                <a:latin typeface="Arial"/>
+              </a:rPr>
+              <a:t>The inductor term of the full equations needs L and the loop gain from dI/dV, which do not exist for these series on MSI; it is neglected.</a:t>
+            </a:r>
+          </a:p>
+          <a:p>
+            <a:pPr>
+              <a:spcAft>
+                <a:spcPts val="800"/>
+              </a:spcAft>
+            </a:pPr>
+            <a:r>
+              <a:rPr sz="1700" b="0" i="0">
+                <a:solidFill>
+                  <a:srgbClr val="333333"/>
+                </a:solidFill>
+                <a:latin typeface="Arial"/>
+              </a:rPr>
+              <a:t>The official Eabs (trigger bin 16383, baseline bins 93..15758, 5-pole 20 kHz prefilter, window −0.5/+1 ms, same formula) is reproduced to 0.2 %; the grey outlines on the histogram slides are it.</a:t>
+            </a:r>
+          </a:p>
+        </p:txBody>
+      </p:sp>
     </p:spTree>
   </p:cSld>
   <p:clrMapOvr>
@@ -5762,7 +5656,7 @@
                 </a:solidFill>
                 <a:latin typeface="Arial"/>
               </a:rPr>
-              <a:t>Backup — the three versions of the power formula</a:t>
+              <a:t>Backup — 15 events, fitted current and power (PBS1)</a:t>
             </a:r>
           </a:p>
         </p:txBody>
@@ -5844,93 +5738,30 @@
           </a:p>
         </p:txBody>
       </p:sp>
-      <p:sp>
-        <p:nvSpPr>
-          <p:cNvPr id="5" name="TextBox 4"/>
-          <p:cNvSpPr txBox="1"/>
+      <p:pic>
+        <p:nvPicPr>
+          <p:cNvPr id="5" name="Picture 4" descr="pulse_15events.png"/>
+          <p:cNvPicPr>
+            <a:picLocks noChangeAspect="1"/>
+          </p:cNvPicPr>
           <p:nvPr/>
-        </p:nvSpPr>
-        <p:spPr>
-          <a:xfrm>
-            <a:off x="502920" y="1325880"/>
-            <a:ext cx="11247120" cy="5029200"/>
+        </p:nvPicPr>
+        <p:blipFill>
+          <a:blip r:embed="rId3"/>
+          <a:stretch>
+            <a:fillRect/>
+          </a:stretch>
+        </p:blipFill>
+        <p:spPr>
+          <a:xfrm>
+            <a:off x="2671354" y="1143000"/>
+            <a:ext cx="6910251" cy="5257800"/>
           </a:xfrm>
           <a:prstGeom prst="rect">
             <a:avLst/>
           </a:prstGeom>
-          <a:noFill/>
-        </p:spPr>
-        <p:txBody>
-          <a:bodyPr wrap="square">
-            <a:spAutoFit/>
-          </a:bodyPr>
-          <a:lstStyle/>
-          <a:p>
-            <a:pPr>
-              <a:spcAft>
-                <a:spcPts val="800"/>
-              </a:spcAft>
-            </a:pPr>
-            <a:r>
-              <a:rPr sz="1700" b="0" i="0">
-                <a:solidFill>
-                  <a:srgbClr val="333333"/>
-                </a:solidFill>
-                <a:latin typeface="Arial"/>
-              </a:rPr>
-              <a:t>δP = I₀(R_L − R₀)·δI + c₂·R_L·(δI)²     with c₂ = 2 (Method 1, used here), 1 (exact small-signal), −1 (Method 2)</a:t>
-            </a:r>
-          </a:p>
-          <a:p>
-            <a:pPr>
-              <a:spcAft>
-                <a:spcPts val="800"/>
-              </a:spcAft>
-            </a:pPr>
-            <a:r>
-              <a:rPr sz="1700" b="0" i="0">
-                <a:solidFill>
-                  <a:srgbClr val="333333"/>
-                </a:solidFill>
-                <a:latin typeface="Arial"/>
-              </a:rPr>
-              <a:t>Relative to the exact form: Method 1 +0.58 %, Method 2 −1.15 % in energy — far below the 15 % single-channel width and the PDS2 bracket.</a:t>
-            </a:r>
-          </a:p>
-          <a:p>
-            <a:pPr>
-              <a:spcAft>
-                <a:spcPts val="800"/>
-              </a:spcAft>
-            </a:pPr>
-            <a:r>
-              <a:rPr sz="1700" b="0" i="0">
-                <a:solidFill>
-                  <a:srgbClr val="333333"/>
-                </a:solidFill>
-                <a:latin typeface="Arial"/>
-              </a:rPr>
-              <a:t>The inductor term of the full equations needs L and the loop gain from dI/dV, which do not exist for these series on MSI; it is neglected.</a:t>
-            </a:r>
-          </a:p>
-          <a:p>
-            <a:pPr>
-              <a:spcAft>
-                <a:spcPts val="800"/>
-              </a:spcAft>
-            </a:pPr>
-            <a:r>
-              <a:rPr sz="1700" b="0" i="0">
-                <a:solidFill>
-                  <a:srgbClr val="333333"/>
-                </a:solidFill>
-                <a:latin typeface="Arial"/>
-              </a:rPr>
-              <a:t>The official Eabs (trigger bin 16383, baseline bins 93..15758, 5-pole 20 kHz prefilter, window −0.5/+1 ms, same formula) is reproduced to 0.2 %; the grey outlines on the histogram slides are it.</a:t>
-            </a:r>
-          </a:p>
-        </p:txBody>
-      </p:sp>
+        </p:spPr>
+      </p:pic>
     </p:spTree>
   </p:cSld>
   <p:clrMapOvr>
@@ -5978,7 +5809,7 @@
                 </a:solidFill>
                 <a:latin typeface="Arial"/>
               </a:rPr>
-              <a:t>Backup — 15 events, fitted current and power (PBS1)</a:t>
+              <a:t>Backup — 15 events, cumulative energy (PBS1)</a:t>
             </a:r>
           </a:p>
         </p:txBody>
@@ -6062,7 +5893,7 @@
       </p:sp>
       <p:pic>
         <p:nvPicPr>
-          <p:cNvPr id="5" name="Picture 4" descr="pulse_15events.png"/>
+          <p:cNvPr id="5" name="Picture 4" descr="cum_15events.png"/>
           <p:cNvPicPr>
             <a:picLocks noChangeAspect="1"/>
           </p:cNvPicPr>
@@ -6131,7 +5962,7 @@
                 </a:solidFill>
                 <a:latin typeface="Arial"/>
               </a:rPr>
-              <a:t>Backup — 15 events, cumulative energy (PBS1)</a:t>
+              <a:t>Backup — event 30646, all channels</a:t>
             </a:r>
           </a:p>
         </p:txBody>
@@ -6215,7 +6046,7 @@
       </p:sp>
       <p:pic>
         <p:nvPicPr>
-          <p:cNvPr id="5" name="Picture 4" descr="cum_15events.png"/>
+          <p:cNvPr id="5" name="Picture 4" descr="allchan_pulses.png"/>
           <p:cNvPicPr>
             <a:picLocks noChangeAspect="1"/>
           </p:cNvPicPr>
@@ -6229,8 +6060,8 @@
         </p:blipFill>
         <p:spPr>
           <a:xfrm>
-            <a:off x="2671354" y="1143000"/>
-            <a:ext cx="6910251" cy="5257800"/>
+            <a:off x="502920" y="1758921"/>
+            <a:ext cx="11247120" cy="4025957"/>
           </a:xfrm>
           <a:prstGeom prst="rect">
             <a:avLst/>
@@ -6284,7 +6115,7 @@
                 </a:solidFill>
                 <a:latin typeface="Arial"/>
               </a:rPr>
-              <a:t>Backup — event 30646, all channels</a:t>
+              <a:t>Backup — energy distribution of every channel</a:t>
             </a:r>
           </a:p>
         </p:txBody>
@@ -6362,159 +6193,6 @@
                 <a:latin typeface="Arial"/>
               </a:rPr>
               <a:t>17</a:t>
-            </a:r>
-          </a:p>
-        </p:txBody>
-      </p:sp>
-      <p:pic>
-        <p:nvPicPr>
-          <p:cNvPr id="5" name="Picture 4" descr="allchan_pulses.png"/>
-          <p:cNvPicPr>
-            <a:picLocks noChangeAspect="1"/>
-          </p:cNvPicPr>
-          <p:nvPr/>
-        </p:nvPicPr>
-        <p:blipFill>
-          <a:blip r:embed="rId3"/>
-          <a:stretch>
-            <a:fillRect/>
-          </a:stretch>
-        </p:blipFill>
-        <p:spPr>
-          <a:xfrm>
-            <a:off x="502920" y="1758921"/>
-            <a:ext cx="11247120" cy="4025957"/>
-          </a:xfrm>
-          <a:prstGeom prst="rect">
-            <a:avLst/>
-          </a:prstGeom>
-        </p:spPr>
-      </p:pic>
-    </p:spTree>
-  </p:cSld>
-  <p:clrMapOvr>
-    <a:masterClrMapping/>
-  </p:clrMapOvr>
-</p:sld>
-</file>
-
-<file path=ppt/slides/slide18.xml><?xml version="1.0" encoding="utf-8"?>
-<p:sld xmlns:a="http://schemas.openxmlformats.org/drawingml/2006/main" xmlns:p="http://schemas.openxmlformats.org/presentationml/2006/main" xmlns:r="http://schemas.openxmlformats.org/officeDocument/2006/relationships">
-  <p:cSld>
-    <p:spTree>
-      <p:nvGrpSpPr>
-        <p:cNvPr id="1" name=""/>
-        <p:cNvGrpSpPr/>
-        <p:nvPr/>
-      </p:nvGrpSpPr>
-      <p:grpSpPr/>
-      <p:sp>
-        <p:nvSpPr>
-          <p:cNvPr id="2" name="TextBox 1"/>
-          <p:cNvSpPr txBox="1"/>
-          <p:nvPr/>
-        </p:nvSpPr>
-        <p:spPr>
-          <a:xfrm>
-            <a:off x="502920" y="228600"/>
-            <a:ext cx="11247120" cy="731520"/>
-          </a:xfrm>
-          <a:prstGeom prst="rect">
-            <a:avLst/>
-          </a:prstGeom>
-          <a:noFill/>
-        </p:spPr>
-        <p:txBody>
-          <a:bodyPr wrap="square">
-            <a:spAutoFit/>
-          </a:bodyPr>
-          <a:lstStyle/>
-          <a:p>
-            <a:r>
-              <a:rPr sz="2700" b="1" i="0">
-                <a:solidFill>
-                  <a:srgbClr val="1F3864"/>
-                </a:solidFill>
-                <a:latin typeface="Arial"/>
-              </a:rPr>
-              <a:t>Backup — energy distribution of every channel</a:t>
-            </a:r>
-          </a:p>
-        </p:txBody>
-      </p:sp>
-      <p:sp>
-        <p:nvSpPr>
-          <p:cNvPr id="3" name="Rectangle 2"/>
-          <p:cNvSpPr/>
-          <p:nvPr/>
-        </p:nvSpPr>
-        <p:spPr>
-          <a:xfrm>
-            <a:off x="502920" y="969264"/>
-            <a:ext cx="11247120" cy="18000"/>
-          </a:xfrm>
-          <a:prstGeom prst="rect">
-            <a:avLst/>
-          </a:prstGeom>
-          <a:solidFill>
-            <a:srgbClr val="1F3864"/>
-          </a:solidFill>
-          <a:ln>
-            <a:noFill/>
-          </a:ln>
-        </p:spPr>
-        <p:style>
-          <a:lnRef idx="1">
-            <a:schemeClr val="accent1"/>
-          </a:lnRef>
-          <a:fillRef idx="3">
-            <a:schemeClr val="accent1"/>
-          </a:fillRef>
-          <a:effectRef idx="2">
-            <a:schemeClr val="accent1"/>
-          </a:effectRef>
-          <a:fontRef idx="minor">
-            <a:schemeClr val="lt1"/>
-          </a:fontRef>
-        </p:style>
-        <p:txBody>
-          <a:bodyPr rtlCol="0" anchor="ctr"/>
-          <a:lstStyle/>
-          <a:p>
-            <a:pPr algn="ctr"/>
-          </a:p>
-        </p:txBody>
-      </p:sp>
-      <p:sp>
-        <p:nvSpPr>
-          <p:cNvPr id="4" name="TextBox 3"/>
-          <p:cNvSpPr txBox="1"/>
-          <p:nvPr/>
-        </p:nvSpPr>
-        <p:spPr>
-          <a:xfrm>
-            <a:off x="11430000" y="6446520"/>
-            <a:ext cx="548640" cy="320040"/>
-          </a:xfrm>
-          <a:prstGeom prst="rect">
-            <a:avLst/>
-          </a:prstGeom>
-          <a:noFill/>
-        </p:spPr>
-        <p:txBody>
-          <a:bodyPr wrap="square">
-            <a:spAutoFit/>
-          </a:bodyPr>
-          <a:lstStyle/>
-          <a:p>
-            <a:r>
-              <a:rPr sz="1000" b="0" i="0">
-                <a:solidFill>
-                  <a:srgbClr val="666666"/>
-                </a:solidFill>
-                <a:latin typeface="Arial"/>
-              </a:rPr>
-              <a:t>18</a:t>
             </a:r>
           </a:p>
         </p:txBody>
@@ -6814,7 +6492,7 @@
                 </a:solidFill>
                 <a:latin typeface="Arial"/>
               </a:rPr>
-              <a:t>Where the formula comes from</a:t>
+              <a:t>The formula, and the two numbers it needs</a:t>
             </a:r>
           </a:p>
           <a:p>
@@ -6825,7 +6503,7 @@
                 </a:solidFill>
                 <a:latin typeface="Arial"/>
               </a:rPr>
-              <a:t>the film pays for the absorbed energy out of its own Joule heating</a:t>
+              <a:t>Method 1 of the CDMS collection-efficiency note</a:t>
             </a:r>
           </a:p>
         </p:txBody>
@@ -6909,7 +6587,7 @@
       </p:sp>
       <p:pic>
         <p:nvPicPr>
-          <p:cNvPr id="5" name="Picture 4" descr="circuit.png"/>
+          <p:cNvPr id="5" name="Picture 4" descr="formula.png"/>
           <p:cNvPicPr>
             <a:picLocks noChangeAspect="1"/>
           </p:cNvPicPr>
@@ -6923,48 +6601,24 @@
         </p:blipFill>
         <p:spPr>
           <a:xfrm>
-            <a:off x="502920" y="1595301"/>
-            <a:ext cx="4434840" cy="3484517"/>
+            <a:off x="997889" y="1143000"/>
+            <a:ext cx="10257182" cy="3931920"/>
           </a:xfrm>
           <a:prstGeom prst="rect">
             <a:avLst/>
           </a:prstGeom>
         </p:spPr>
       </p:pic>
-      <p:pic>
-        <p:nvPicPr>
-          <p:cNvPr id="6" name="Picture 5" descr="derivation.png"/>
-          <p:cNvPicPr>
-            <a:picLocks noChangeAspect="1"/>
-          </p:cNvPicPr>
-          <p:nvPr/>
-        </p:nvPicPr>
-        <p:blipFill>
-          <a:blip r:embed="rId4"/>
-          <a:stretch>
-            <a:fillRect/>
-          </a:stretch>
-        </p:blipFill>
-        <p:spPr>
-          <a:xfrm>
-            <a:off x="5120640" y="1179151"/>
-            <a:ext cx="6629400" cy="4316818"/>
-          </a:xfrm>
-          <a:prstGeom prst="rect">
-            <a:avLst/>
-          </a:prstGeom>
-        </p:spPr>
-      </p:pic>
-      <p:sp>
-        <p:nvSpPr>
-          <p:cNvPr id="7" name="TextBox 6"/>
+      <p:sp>
+        <p:nvSpPr>
+          <p:cNvPr id="6" name="TextBox 5"/>
           <p:cNvSpPr txBox="1"/>
           <p:nvPr/>
         </p:nvSpPr>
         <p:spPr>
           <a:xfrm>
-            <a:off x="502920" y="5669280"/>
-            <a:ext cx="11247120" cy="1097280"/>
+            <a:off x="502920" y="5120640"/>
+            <a:ext cx="11247120" cy="1463040"/>
           </a:xfrm>
           <a:prstGeom prst="rect">
             <a:avLst/>
@@ -6983,13 +6637,13 @@
               </a:spcAft>
             </a:pPr>
             <a:r>
-              <a:rPr sz="1300" b="0" i="0">
+              <a:rPr sz="1500" b="0" i="0">
                 <a:solidFill>
                   <a:srgbClr val="333333"/>
                 </a:solidFill>
                 <a:latin typeface="Arial"/>
               </a:rPr>
-              <a:t>An event heats the film, its resistance rises, the current falls — and the Joule heating falls by exactly what the event delivered (negative electro-thermal feedback).</a:t>
+              <a:t>δP = the change of Joule heating when the current moves by δI: a linear term and a small quadratic term.</a:t>
             </a:r>
           </a:p>
           <a:p>
@@ -6999,29 +6653,13 @@
               </a:spcAft>
             </a:pPr>
             <a:r>
-              <a:rPr sz="1300" b="1" i="0">
-                <a:solidFill>
-                  <a:srgbClr val="C0392B"/>
+              <a:rPr sz="1500" b="0" i="0">
+                <a:solidFill>
+                  <a:srgbClr val="333333"/>
                 </a:solidFill>
                 <a:latin typeface="Arial"/>
               </a:rPr>
-              <a:t>So the absorbed energy can be read from the current alone: E = −∫δP_J dt, which is the formula on the next slide.</a:t>
-            </a:r>
-          </a:p>
-          <a:p>
-            <a:pPr>
-              <a:spcAft>
-                <a:spcPts val="800"/>
-              </a:spcAft>
-            </a:pPr>
-            <a:r>
-              <a:rPr sz="1300" b="0" i="0">
-                <a:solidFill>
-                  <a:srgbClr val="333333"/>
-                </a:solidFill>
-                <a:latin typeface="Arial"/>
-              </a:rPr>
-              <a:t>Left out: the bath leak and the inductor end terms. Both need G and L from dI/dV, which these series do not have.</a:t>
+              <a:t>The note also gives Method 2. In our sign convention it reads δP = I₀(R_L − R₀)·δI − R_L·(δI)²: the same linear term, only the quadratic term differs, and it gives 1.7 % less energy (PBS1, median of 15 events).</a:t>
             </a:r>
           </a:p>
         </p:txBody>
@@ -7073,7 +6711,27 @@
                 </a:solidFill>
                 <a:latin typeface="Arial"/>
               </a:rPr>
-              <a:t>The formula, and the two numbers it needs</a:t>
+              <a:t>Example: one pulse</a:t>
+            </a:r>
+          </a:p>
+          <a:p>
+            <a:r>
+              <a:rPr sz="1400" b="0" i="0">
+                <a:solidFill>
+                  <a:srgbClr val="666666"/>
+                </a:solidFill>
+                <a:latin typeface="Arial"/>
+              </a:rPr>
+              <a:t>Z7 PBS1, event 30646:  </a:t>
+            </a:r>
+            <a:r>
+              <a:rPr sz="1400" b="1" i="0">
+                <a:solidFill>
+                  <a:srgbClr val="333333"/>
+                </a:solidFill>
+                <a:latin typeface="Arial"/>
+              </a:rPr>
+              <a:t>the same trace as ADC counts, as current, as power</a:t>
             </a:r>
           </a:p>
         </p:txBody>
@@ -7157,7 +6815,7 @@
       </p:sp>
       <p:pic>
         <p:nvPicPr>
-          <p:cNvPr id="5" name="Picture 4" descr="formula.png"/>
+          <p:cNvPr id="5" name="Picture 4" descr="peak_full.png"/>
           <p:cNvPicPr>
             <a:picLocks noChangeAspect="1"/>
           </p:cNvPicPr>
@@ -7171,8 +6829,8 @@
         </p:blipFill>
         <p:spPr>
           <a:xfrm>
-            <a:off x="997889" y="1143000"/>
-            <a:ext cx="10257182" cy="3931920"/>
+            <a:off x="2981032" y="1143000"/>
+            <a:ext cx="6290896" cy="4846320"/>
           </a:xfrm>
           <a:prstGeom prst="rect">
             <a:avLst/>
@@ -7187,8 +6845,8 @@
         </p:nvSpPr>
         <p:spPr>
           <a:xfrm>
-            <a:off x="502920" y="5166360"/>
-            <a:ext cx="11247120" cy="1371600"/>
+            <a:off x="502920" y="6053328"/>
+            <a:ext cx="11247120" cy="457200"/>
           </a:xfrm>
           <a:prstGeom prst="rect">
             <a:avLst/>
@@ -7207,13 +6865,13 @@
               </a:spcAft>
             </a:pPr>
             <a:r>
-              <a:rPr sz="1600" b="0" i="0">
-                <a:solidFill>
-                  <a:srgbClr val="333333"/>
+              <a:rPr sz="1400" b="1" i="0">
+                <a:solidFill>
+                  <a:srgbClr val="C0392B"/>
                 </a:solidFill>
                 <a:latin typeface="Arial"/>
               </a:rPr>
-              <a:t>δP = the change of Joule heating when the current moves by δI: a linear term and a small quadratic term.</a:t>
+              <a:t>The two-exponential is fitted to the 100 kHz low-passed trace (blue), not to the raw samples; the raw samples are only drawn.</a:t>
             </a:r>
           </a:p>
         </p:txBody>
@@ -7265,27 +6923,7 @@
                 </a:solidFill>
                 <a:latin typeface="Arial"/>
               </a:rPr>
-              <a:t>Example: one pulse</a:t>
-            </a:r>
-          </a:p>
-          <a:p>
-            <a:r>
-              <a:rPr sz="1400" b="0" i="0">
-                <a:solidFill>
-                  <a:srgbClr val="666666"/>
-                </a:solidFill>
-                <a:latin typeface="Arial"/>
-              </a:rPr>
-              <a:t>Z7 PBS1, event 30646:  </a:t>
-            </a:r>
-            <a:r>
-              <a:rPr sz="1400" b="1" i="0">
-                <a:solidFill>
-                  <a:srgbClr val="333333"/>
-                </a:solidFill>
-                <a:latin typeface="Arial"/>
-              </a:rPr>
-              <a:t>the same trace as ADC counts, as current, as power</a:t>
+              <a:t>The height: take it from the fit, not from the largest sample</a:t>
             </a:r>
           </a:p>
         </p:txBody>
@@ -7369,7 +7007,7 @@
       </p:sp>
       <p:pic>
         <p:nvPicPr>
-          <p:cNvPr id="5" name="Picture 4" descr="peak_full.png"/>
+          <p:cNvPr id="5" name="Picture 4" descr="peak_top.png"/>
           <p:cNvPicPr>
             <a:picLocks noChangeAspect="1"/>
           </p:cNvPicPr>
@@ -7383,8 +7021,8 @@
         </p:blipFill>
         <p:spPr>
           <a:xfrm>
-            <a:off x="2981032" y="1143000"/>
-            <a:ext cx="6290896" cy="4846320"/>
+            <a:off x="1077759" y="1143000"/>
+            <a:ext cx="10097441" cy="4160520"/>
           </a:xfrm>
           <a:prstGeom prst="rect">
             <a:avLst/>
@@ -7399,8 +7037,8 @@
         </p:nvSpPr>
         <p:spPr>
           <a:xfrm>
-            <a:off x="502920" y="6053328"/>
-            <a:ext cx="11247120" cy="457200"/>
+            <a:off x="502920" y="5394960"/>
+            <a:ext cx="11247120" cy="1097280"/>
           </a:xfrm>
           <a:prstGeom prst="rect">
             <a:avLst/>
@@ -7419,13 +7057,29 @@
               </a:spcAft>
             </a:pPr>
             <a:r>
-              <a:rPr sz="1400" b="1" i="0">
-                <a:solidFill>
-                  <a:srgbClr val="C0392B"/>
+              <a:rPr sz="1600" b="0" i="0">
+                <a:solidFill>
+                  <a:srgbClr val="333333"/>
                 </a:solidFill>
                 <a:latin typeface="Arial"/>
               </a:rPr>
-              <a:t>The two-exponential is fitted to the 100 kHz low-passed trace (blue), not to the raw samples; the raw samples are only drawn.</a:t>
+              <a:t>Yellow band: 98 samples sit within 10 % of the peak. The largest of them is the largest noise excursion.</a:t>
+            </a:r>
+          </a:p>
+          <a:p>
+            <a:pPr>
+              <a:spcAft>
+                <a:spcPts val="800"/>
+              </a:spcAft>
+            </a:pPr>
+            <a:r>
+              <a:rPr sz="1600" b="1" i="0">
+                <a:solidFill>
+                  <a:srgbClr val="C0392B"/>
+                </a:solidFill>
+                <a:latin typeface="Arial"/>
+              </a:rPr>
+              <a:t>Largest raw sample 885 ADC, fit 717 ADC: the maximum reads 23 % high. Filtering helps; the fit removes it.</a:t>
             </a:r>
           </a:p>
         </p:txBody>
@@ -7477,7 +7131,7 @@
                 </a:solidFill>
                 <a:latin typeface="Arial"/>
               </a:rPr>
-              <a:t>The height: take it from the fit, not from the largest sample</a:t>
+              <a:t>The power pulse, and its area is the energy</a:t>
             </a:r>
           </a:p>
         </p:txBody>
@@ -7561,7 +7215,7 @@
       </p:sp>
       <p:pic>
         <p:nvPicPr>
-          <p:cNvPr id="5" name="Picture 4" descr="peak_top.png"/>
+          <p:cNvPr id="5" name="Picture 4" descr="peak_bottom.png"/>
           <p:cNvPicPr>
             <a:picLocks noChangeAspect="1"/>
           </p:cNvPicPr>
@@ -7575,8 +7229,8 @@
         </p:blipFill>
         <p:spPr>
           <a:xfrm>
-            <a:off x="1077759" y="1143000"/>
-            <a:ext cx="10097441" cy="4160520"/>
+            <a:off x="502920" y="1213485"/>
+            <a:ext cx="11247120" cy="2967990"/>
           </a:xfrm>
           <a:prstGeom prst="rect">
             <a:avLst/>
@@ -7591,8 +7245,8 @@
         </p:nvSpPr>
         <p:spPr>
           <a:xfrm>
-            <a:off x="502920" y="5394960"/>
-            <a:ext cx="11247120" cy="1097280"/>
+            <a:off x="502920" y="4389120"/>
+            <a:ext cx="11247120" cy="2011680"/>
           </a:xfrm>
           <a:prstGeom prst="rect">
             <a:avLst/>
@@ -7617,7 +7271,7 @@
                 </a:solidFill>
                 <a:latin typeface="Arial"/>
               </a:rPr>
-              <a:t>Yellow band: 98 samples sit within 10 % of the peak. The largest of them is the largest noise excursion.</a:t>
+              <a:t>Red: the fitted current put through the formula. Blue dashed: the linear term alone. Purple: the quadratic term, ×20.</a:t>
             </a:r>
           </a:p>
           <a:p>
@@ -7633,7 +7287,23 @@
                 </a:solidFill>
                 <a:latin typeface="Arial"/>
               </a:rPr>
-              <a:t>Largest raw sample 885 ADC, fit 717 ADC: the maximum reads 23 % high. Filtering helps; the fit removes it.</a:t>
+              <a:t>The quadratic term is 1.9 % of the peak — the power pulse has the shape of the current pulse.</a:t>
+            </a:r>
+          </a:p>
+          <a:p>
+            <a:pPr>
+              <a:spcAft>
+                <a:spcPts val="800"/>
+              </a:spcAft>
+            </a:pPr>
+            <a:r>
+              <a:rPr sz="1600" b="1" i="0">
+                <a:solidFill>
+                  <a:srgbClr val="C0392B"/>
+                </a:solidFill>
+                <a:latin typeface="Arial"/>
+              </a:rPr>
+              <a:t>The shaded area is the energy this channel absorbed: 305 eV.</a:t>
             </a:r>
           </a:p>
         </p:txBody>
@@ -7685,7 +7355,7 @@
                 </a:solidFill>
                 <a:latin typeface="Arial"/>
               </a:rPr>
-              <a:t>The power pulse, and its area is the energy</a:t>
+              <a:t>Why the fitted pulse is integrated, and not the data</a:t>
             </a:r>
           </a:p>
         </p:txBody>
@@ -7769,7 +7439,7 @@
       </p:sp>
       <p:pic>
         <p:nvPicPr>
-          <p:cNvPr id="5" name="Picture 4" descr="peak_bottom.png"/>
+          <p:cNvPr id="5" name="Picture 4" descr="raw_cum_slide.png"/>
           <p:cNvPicPr>
             <a:picLocks noChangeAspect="1"/>
           </p:cNvPicPr>
@@ -7783,8 +7453,8 @@
         </p:blipFill>
         <p:spPr>
           <a:xfrm>
-            <a:off x="502920" y="1213485"/>
-            <a:ext cx="11247120" cy="2967990"/>
+            <a:off x="1751798" y="1143000"/>
+            <a:ext cx="8749364" cy="4617720"/>
           </a:xfrm>
           <a:prstGeom prst="rect">
             <a:avLst/>
@@ -7799,8 +7469,8 @@
         </p:nvSpPr>
         <p:spPr>
           <a:xfrm>
-            <a:off x="502920" y="4389120"/>
-            <a:ext cx="11247120" cy="2011680"/>
+            <a:off x="502920" y="5788152"/>
+            <a:ext cx="11247120" cy="822960"/>
           </a:xfrm>
           <a:prstGeom prst="rect">
             <a:avLst/>
@@ -7819,13 +7489,13 @@
               </a:spcAft>
             </a:pPr>
             <a:r>
-              <a:rPr sz="1600" b="0" i="0">
+              <a:rPr sz="1300" b="0" i="0">
                 <a:solidFill>
                   <a:srgbClr val="333333"/>
                 </a:solidFill>
                 <a:latin typeface="Arial"/>
               </a:rPr>
-              <a:t>Red: the fitted current put through the formula. Blue dashed: the linear term alone. Purple: the quadratic term, ×20.</a:t>
+              <a:t>Top: the raw current of the same two events, zoomed on the baseline. Bottom: the energy accumulated from it (grey) and from the fit (red).</a:t>
             </a:r>
           </a:p>
           <a:p>
@@ -7835,29 +7505,13 @@
               </a:spcAft>
             </a:pPr>
             <a:r>
-              <a:rPr sz="1600" b="1" i="0">
+              <a:rPr sz="1300" b="1" i="0">
                 <a:solidFill>
                   <a:srgbClr val="C0392B"/>
                 </a:solidFill>
                 <a:latin typeface="Arial"/>
               </a:rPr>
-              <a:t>The quadratic term is 1.9 % of the peak — the power pulse has the shape of the current pulse.</a:t>
-            </a:r>
-          </a:p>
-          <a:p>
-            <a:pPr>
-              <a:spcAft>
-                <a:spcPts val="800"/>
-              </a:spcAft>
-            </a:pPr>
-            <a:r>
-              <a:rPr sz="1600" b="1" i="0">
-                <a:solidFill>
-                  <a:srgbClr val="C0392B"/>
-                </a:solidFill>
-                <a:latin typeface="Arial"/>
-              </a:rPr>
-              <a:t>The shaded area is the energy this channel absorbed: 305 eV.</a:t>
+              <a:t>Right: after the pulse the current sits 6 nA below its baseline — hidden in 28 nA of noise, yet over 24 ms it is −420 eV: raw −169 eV, fit 277 eV.</a:t>
             </a:r>
           </a:p>
         </p:txBody>
@@ -7909,7 +7563,18 @@
                 </a:solidFill>
                 <a:latin typeface="Arial"/>
               </a:rPr>
-              <a:t>Why the fitted pulse is integrated, and not the data</a:t>
+              <a:t>The same event in its other channels: they add up to 33 %</a:t>
+            </a:r>
+          </a:p>
+          <a:p>
+            <a:r>
+              <a:rPr sz="1400" b="0" i="0">
+                <a:solidFill>
+                  <a:srgbClr val="666666"/>
+                </a:solidFill>
+                <a:latin typeface="Arial"/>
+              </a:rPr>
+              <a:t>Z7 event 30646; four of the eleven channels</a:t>
             </a:r>
           </a:p>
         </p:txBody>
@@ -7993,7 +7658,7 @@
       </p:sp>
       <p:pic>
         <p:nvPicPr>
-          <p:cNvPr id="5" name="Picture 4" descr="raw_cum_slide.png"/>
+          <p:cNvPr id="5" name="Picture 4" descr="allchan_slide.png"/>
           <p:cNvPicPr>
             <a:picLocks noChangeAspect="1"/>
           </p:cNvPicPr>
@@ -8007,8 +7672,8 @@
         </p:blipFill>
         <p:spPr>
           <a:xfrm>
-            <a:off x="1751798" y="1143000"/>
-            <a:ext cx="8749364" cy="4617720"/>
+            <a:off x="1941141" y="1143000"/>
+            <a:ext cx="8370678" cy="4069080"/>
           </a:xfrm>
           <a:prstGeom prst="rect">
             <a:avLst/>
@@ -8023,8 +7688,8 @@
         </p:nvSpPr>
         <p:spPr>
           <a:xfrm>
-            <a:off x="502920" y="5788152"/>
-            <a:ext cx="11247120" cy="822960"/>
+            <a:off x="502920" y="5257800"/>
+            <a:ext cx="11247120" cy="1188720"/>
           </a:xfrm>
           <a:prstGeom prst="rect">
             <a:avLst/>
@@ -8043,13 +7708,13 @@
               </a:spcAft>
             </a:pPr>
             <a:r>
-              <a:rPr sz="1300" b="0" i="0">
+              <a:rPr sz="1500" b="0" i="0">
                 <a:solidFill>
                   <a:srgbClr val="333333"/>
                 </a:solidFill>
                 <a:latin typeface="Arial"/>
               </a:rPr>
-              <a:t>Top: the raw current of the same two events, zoomed on the baseline. Bottom: the energy accumulated from it (grey) and from the fit (red).</a:t>
+              <a:t>The channels share the energy unevenly (PES1 489 eV, PES2 195 eV): the event sat closer to one side.</a:t>
             </a:r>
           </a:p>
           <a:p>
@@ -8059,13 +7724,13 @@
               </a:spcAft>
             </a:pPr>
             <a:r>
-              <a:rPr sz="1300" b="1" i="0">
+              <a:rPr sz="1500" b="1" i="0">
                 <a:solidFill>
                   <a:srgbClr val="C0392B"/>
                 </a:solidFill>
                 <a:latin typeface="Arial"/>
               </a:rPr>
-              <a:t>Right: after the pulse the current sits 6 nA below its baseline — hidden in 28 nA of noise, yet over 24 ms it is −420 eV: raw −169 eV, fit 277 eV.</a:t>
+              <a:t>Summed over the eleven channels: 3419 eV = 33.0 % of 10.37 keV.   PDS2 (bottom right) carries a slow swing.</a:t>
             </a:r>
           </a:p>
         </p:txBody>
@@ -8117,7 +7782,7 @@
                 </a:solidFill>
                 <a:latin typeface="Arial"/>
               </a:rPr>
-              <a:t>The same event in its other channels: they add up to 33 %</a:t>
+              <a:t>Now every event: one channel gives a wide, lopsided distribution</a:t>
             </a:r>
           </a:p>
           <a:p>
@@ -8128,7 +7793,7 @@
                 </a:solidFill>
                 <a:latin typeface="Arial"/>
               </a:rPr>
-              <a:t>Z7 event 30646; four of the eleven channels</a:t>
+              <a:t>PBS1, 1917 K-line events, one fit and one integral each</a:t>
             </a:r>
           </a:p>
         </p:txBody>
@@ -8212,7 +7877,7 @@
       </p:sp>
       <p:pic>
         <p:nvPicPr>
-          <p:cNvPr id="5" name="Picture 4" descr="allchan_slide.png"/>
+          <p:cNvPr id="5" name="Picture 4" descr="hist_PBS1.png"/>
           <p:cNvPicPr>
             <a:picLocks noChangeAspect="1"/>
           </p:cNvPicPr>
@@ -8226,8 +7891,8 @@
         </p:blipFill>
         <p:spPr>
           <a:xfrm>
-            <a:off x="1941141" y="1143000"/>
-            <a:ext cx="8370678" cy="4069080"/>
+            <a:off x="502920" y="1412748"/>
+            <a:ext cx="7863840" cy="4718304"/>
           </a:xfrm>
           <a:prstGeom prst="rect">
             <a:avLst/>
@@ -8242,8 +7907,8 @@
         </p:nvSpPr>
         <p:spPr>
           <a:xfrm>
-            <a:off x="502920" y="5257800"/>
-            <a:ext cx="11247120" cy="1188720"/>
+            <a:off x="8549640" y="1463040"/>
+            <a:ext cx="3291840" cy="4572000"/>
           </a:xfrm>
           <a:prstGeom prst="rect">
             <a:avLst/>
@@ -8268,7 +7933,7 @@
                 </a:solidFill>
                 <a:latin typeface="Arial"/>
               </a:rPr>
-              <a:t>The channels share the energy unevenly (PES1 489 eV, PES2 195 eV): the event sat closer to one side.</a:t>
+              <a:t>Red: from the fit. Grey: the official window on the raw trace. Same peak to 0.2 %.</a:t>
             </a:r>
           </a:p>
           <a:p>
@@ -8284,7 +7949,39 @@
                 </a:solidFill>
                 <a:latin typeface="Arial"/>
               </a:rPr>
-              <a:t>Summed over the eleven channels: 3419 eV = 33.0 % of 10.37 keV.   PDS2 (bottom right) carries a slow swing.</a:t>
+              <a:t>Peak 285 eV, width 15 % — for a line whose energy is fixed.</a:t>
+            </a:r>
+          </a:p>
+          <a:p>
+            <a:pPr>
+              <a:spcAft>
+                <a:spcPts val="800"/>
+              </a:spcAft>
+            </a:pPr>
+            <a:r>
+              <a:rPr sz="1500" b="0" i="0">
+                <a:solidFill>
+                  <a:srgbClr val="333333"/>
+                </a:solidFill>
+                <a:latin typeface="Arial"/>
+              </a:rPr>
+              <a:t>The tail to the right is the events that happened near this channel.</a:t>
+            </a:r>
+          </a:p>
+          <a:p>
+            <a:pPr>
+              <a:spcAft>
+                <a:spcPts val="800"/>
+              </a:spcAft>
+            </a:pPr>
+            <a:r>
+              <a:rPr sz="1500" b="1" i="0">
+                <a:solidFill>
+                  <a:srgbClr val="C0392B"/>
+                </a:solidFill>
+                <a:latin typeface="Arial"/>
+              </a:rPr>
+              <a:t>One channel's width is event position, not noise.</a:t>
             </a:r>
           </a:p>
         </p:txBody>

</xml_diff>

<commit_message>
snolab: larger figures and larger text on every main slide
Per Prof. Liu: the figures and their text were too small on the slides.
- main pulse figure: all text scaled by 1.45, legends and annotations moved
  off the data, the two panels saved on their own axes' extents instead of
  pixel crops, footer split onto three lines
- slide 7/8 panel figures: 16 pt labels, 14 pt ticks and legends
- PBS1 and summed histograms: 16 pt labels, legends below the axes
- picture boxes on the slides enlarged
No number changed (the result text files are identical).

Co-Authored-By: Claude Opus 5 (1M context) <noreply@anthropic.com>
Claude-Session: https://claude.ai/code/session_017642NhrahqPyV2kbDPpL5m
</commit_message>
<xml_diff>
--- a/snolab/collection_efficiency/presentation/SNOLAB_R4_collection_efficiency_20260910.pptx
+++ b/snolab/collection_efficiency/presentation/SNOLAB_R4_collection_efficiency_20260910.pptx
@@ -4913,8 +4913,8 @@
         </p:blipFill>
         <p:spPr>
           <a:xfrm>
-            <a:off x="502920" y="1412748"/>
-            <a:ext cx="7863840" cy="4718304"/>
+            <a:off x="502920" y="1267932"/>
+            <a:ext cx="8046720" cy="5145096"/>
           </a:xfrm>
           <a:prstGeom prst="rect">
             <a:avLst/>
@@ -6829,8 +6829,8 @@
         </p:blipFill>
         <p:spPr>
           <a:xfrm>
-            <a:off x="2981032" y="1143000"/>
-            <a:ext cx="6290896" cy="4846320"/>
+            <a:off x="3097530" y="1143000"/>
+            <a:ext cx="6057900" cy="4846320"/>
           </a:xfrm>
           <a:prstGeom prst="rect">
             <a:avLst/>
@@ -7021,8 +7021,8 @@
         </p:blipFill>
         <p:spPr>
           <a:xfrm>
-            <a:off x="1077759" y="1143000"/>
-            <a:ext cx="10097441" cy="4160520"/>
+            <a:off x="1141012" y="1143000"/>
+            <a:ext cx="9970935" cy="4526280"/>
           </a:xfrm>
           <a:prstGeom prst="rect">
             <a:avLst/>
@@ -7037,8 +7037,8 @@
         </p:nvSpPr>
         <p:spPr>
           <a:xfrm>
-            <a:off x="502920" y="5394960"/>
-            <a:ext cx="11247120" cy="1097280"/>
+            <a:off x="502920" y="5760720"/>
+            <a:ext cx="11247120" cy="914400"/>
           </a:xfrm>
           <a:prstGeom prst="rect">
             <a:avLst/>
@@ -7057,7 +7057,7 @@
               </a:spcAft>
             </a:pPr>
             <a:r>
-              <a:rPr sz="1600" b="0" i="0">
+              <a:rPr sz="1500" b="0" i="0">
                 <a:solidFill>
                   <a:srgbClr val="333333"/>
                 </a:solidFill>
@@ -7073,7 +7073,7 @@
               </a:spcAft>
             </a:pPr>
             <a:r>
-              <a:rPr sz="1600" b="1" i="0">
+              <a:rPr sz="1500" b="1" i="0">
                 <a:solidFill>
                   <a:srgbClr val="C0392B"/>
                 </a:solidFill>
@@ -7229,8 +7229,8 @@
         </p:blipFill>
         <p:spPr>
           <a:xfrm>
-            <a:off x="502920" y="1213485"/>
-            <a:ext cx="11247120" cy="2967990"/>
+            <a:off x="1550903" y="1143000"/>
+            <a:ext cx="9151153" cy="3657599"/>
           </a:xfrm>
           <a:prstGeom prst="rect">
             <a:avLst/>
@@ -7245,8 +7245,8 @@
         </p:nvSpPr>
         <p:spPr>
           <a:xfrm>
-            <a:off x="502920" y="4389120"/>
-            <a:ext cx="11247120" cy="2011680"/>
+            <a:off x="502920" y="4937760"/>
+            <a:ext cx="11247120" cy="1645920"/>
           </a:xfrm>
           <a:prstGeom prst="rect">
             <a:avLst/>
@@ -7265,7 +7265,7 @@
               </a:spcAft>
             </a:pPr>
             <a:r>
-              <a:rPr sz="1600" b="0" i="0">
+              <a:rPr sz="1500" b="0" i="0">
                 <a:solidFill>
                   <a:srgbClr val="333333"/>
                 </a:solidFill>
@@ -7281,7 +7281,7 @@
               </a:spcAft>
             </a:pPr>
             <a:r>
-              <a:rPr sz="1600" b="1" i="0">
+              <a:rPr sz="1500" b="1" i="0">
                 <a:solidFill>
                   <a:srgbClr val="C0392B"/>
                 </a:solidFill>
@@ -7297,7 +7297,7 @@
               </a:spcAft>
             </a:pPr>
             <a:r>
-              <a:rPr sz="1600" b="1" i="0">
+              <a:rPr sz="1500" b="1" i="0">
                 <a:solidFill>
                   <a:srgbClr val="C0392B"/>
                 </a:solidFill>
@@ -7453,8 +7453,8 @@
         </p:blipFill>
         <p:spPr>
           <a:xfrm>
-            <a:off x="1751798" y="1143000"/>
-            <a:ext cx="8749364" cy="4617720"/>
+            <a:off x="1928553" y="1143000"/>
+            <a:ext cx="8395854" cy="4617720"/>
           </a:xfrm>
           <a:prstGeom prst="rect">
             <a:avLst/>
@@ -7672,8 +7672,8 @@
         </p:blipFill>
         <p:spPr>
           <a:xfrm>
-            <a:off x="1941141" y="1143000"/>
-            <a:ext cx="8370678" cy="4069080"/>
+            <a:off x="1978226" y="1143000"/>
+            <a:ext cx="8296507" cy="4251960"/>
           </a:xfrm>
           <a:prstGeom prst="rect">
             <a:avLst/>
@@ -7688,8 +7688,8 @@
         </p:nvSpPr>
         <p:spPr>
           <a:xfrm>
-            <a:off x="502920" y="5257800"/>
-            <a:ext cx="11247120" cy="1188720"/>
+            <a:off x="502920" y="5486400"/>
+            <a:ext cx="11247120" cy="1005840"/>
           </a:xfrm>
           <a:prstGeom prst="rect">
             <a:avLst/>
@@ -7891,8 +7891,8 @@
         </p:blipFill>
         <p:spPr>
           <a:xfrm>
-            <a:off x="502920" y="1412748"/>
-            <a:ext cx="7863840" cy="4718304"/>
+            <a:off x="502920" y="1148415"/>
+            <a:ext cx="8046719" cy="5384130"/>
           </a:xfrm>
           <a:prstGeom prst="rect">
             <a:avLst/>

</xml_diff>

<commit_message>
snolab: backup slide with the derivation of the power and energy formulas
One card per language: from the heat balance and the circuit to deltaP (c2 = 1
exact, 2 Method 1, -1 Method 2); the closed-form integrals of the two-exponential
pulse; symbols with the PBS1 values; the assumptions (0 V, bath heat flow not
included, the L term cancels only after integration). Chinese card uses a
DejaVu + Droid Sans Fallback font chain.

Co-Authored-By: Claude Opus 5 (1M context) <noreply@anthropic.com>
Claude-Session: https://claude.ai/code/session_017642NhrahqPyV2kbDPpL5m
</commit_message>
<xml_diff>
--- a/snolab/collection_efficiency/presentation/SNOLAB_R4_collection_efficiency_20260910.pptx
+++ b/snolab/collection_efficiency/presentation/SNOLAB_R4_collection_efficiency_20260910.pptx
@@ -22,6 +22,7 @@
     <p:sldId id="270" r:id="rId22"/>
     <p:sldId id="271" r:id="rId23"/>
     <p:sldId id="272" r:id="rId24"/>
+    <p:sldId id="273" r:id="rId25"/>
   </p:sldIdLst>
   <p:sldSz cx="12191695" cy="6858000" type="screen4x3"/>
   <p:notesSz cx="6858000" cy="9144000"/>
@@ -866,11 +867,7 @@
         <p:txBody>
           <a:bodyPr/>
           <a:lstStyle/>
-          <a:p>
-            <a:r>
-              <a:t>All 15 example events.</a:t>
-            </a:r>
-          </a:p>
+          <a:p/>
         </p:txBody>
       </p:sp>
       <p:sp>
@@ -938,7 +935,7 @@
           <a:lstStyle/>
           <a:p>
             <a:r>
-              <a:t>Fit vs raw, 15 events.</a:t>
+              <a:t>All 15 example events.</a:t>
             </a:r>
           </a:p>
         </p:txBody>
@@ -1008,7 +1005,7 @@
           <a:lstStyle/>
           <a:p>
             <a:r>
-              <a:t>Sum 3419 eV = 33.0%.</a:t>
+              <a:t>Fit vs raw, 15 events.</a:t>
             </a:r>
           </a:p>
         </p:txBody>
@@ -1034,6 +1031,76 @@
 </file>
 
 <file path=ppt/notesSlides/notesSlide17.xml><?xml version="1.0" encoding="utf-8"?>
+<p:notes xmlns:a="http://schemas.openxmlformats.org/drawingml/2006/main" xmlns:p="http://schemas.openxmlformats.org/presentationml/2006/main" xmlns:r="http://schemas.openxmlformats.org/officeDocument/2006/relationships">
+  <p:cSld>
+    <p:spTree>
+      <p:nvGrpSpPr>
+        <p:cNvPr id="1" name=""/>
+        <p:cNvGrpSpPr/>
+        <p:nvPr/>
+      </p:nvGrpSpPr>
+      <p:grpSpPr>
+        <a:xfrm>
+          <a:off x="0" y="0"/>
+          <a:ext cx="0" cy="0"/>
+          <a:chOff x="0" y="0"/>
+          <a:chExt cx="0" cy="0"/>
+        </a:xfrm>
+      </p:grpSpPr>
+      <p:sp>
+        <p:nvSpPr>
+          <p:cNvPr id="2" name="Slide Image Placeholder 1"/>
+          <p:cNvSpPr>
+            <a:spLocks noGrp="1"/>
+          </p:cNvSpPr>
+          <p:nvPr>
+            <p:ph type="sldImg" idx="2"/>
+          </p:nvPr>
+        </p:nvSpPr>
+        <p:spPr/>
+      </p:sp>
+      <p:sp>
+        <p:nvSpPr>
+          <p:cNvPr id="3" name="Notes Placeholder 2"/>
+          <p:cNvSpPr>
+            <a:spLocks noGrp="1"/>
+          </p:cNvSpPr>
+          <p:nvPr>
+            <p:ph type="body" idx="3" sz="quarter"/>
+          </p:nvPr>
+        </p:nvSpPr>
+        <p:spPr/>
+        <p:txBody>
+          <a:bodyPr/>
+          <a:lstStyle/>
+          <a:p>
+            <a:r>
+              <a:t>Sum 3419 eV = 33.0%.</a:t>
+            </a:r>
+          </a:p>
+        </p:txBody>
+      </p:sp>
+      <p:sp>
+        <p:nvSpPr>
+          <p:cNvPr id="4" name="Slide Number Placeholder 3"/>
+          <p:cNvSpPr>
+            <a:spLocks noGrp="1"/>
+          </p:cNvSpPr>
+          <p:nvPr>
+            <p:ph type="sldNum" idx="5" sz="quarter"/>
+          </p:nvPr>
+        </p:nvSpPr>
+        <p:spPr/>
+      </p:sp>
+    </p:spTree>
+  </p:cSld>
+  <p:clrMapOvr>
+    <a:masterClrMapping/>
+  </p:clrMapOvr>
+</p:notes>
+</file>
+
+<file path=ppt/notesSlides/notesSlide18.xml><?xml version="1.0" encoding="utf-8"?>
 <p:notes xmlns:a="http://schemas.openxmlformats.org/drawingml/2006/main" xmlns:p="http://schemas.openxmlformats.org/presentationml/2006/main" xmlns:r="http://schemas.openxmlformats.org/officeDocument/2006/relationships">
   <p:cSld>
     <p:spTree>
@@ -5656,7 +5723,7 @@
                 </a:solidFill>
                 <a:latin typeface="Arial"/>
               </a:rPr>
-              <a:t>Backup — 15 events, fitted current and power (PBS1)</a:t>
+              <a:t>Backup — how the formulas are derived</a:t>
             </a:r>
           </a:p>
         </p:txBody>
@@ -5740,7 +5807,7 @@
       </p:sp>
       <p:pic>
         <p:nvPicPr>
-          <p:cNvPr id="5" name="Picture 4" descr="pulse_15events.png"/>
+          <p:cNvPr id="5" name="Picture 4" descr="derivation_backup_en.png"/>
           <p:cNvPicPr>
             <a:picLocks noChangeAspect="1"/>
           </p:cNvPicPr>
@@ -5754,8 +5821,8 @@
         </p:blipFill>
         <p:spPr>
           <a:xfrm>
-            <a:off x="2671354" y="1143000"/>
-            <a:ext cx="6910251" cy="5257800"/>
+            <a:off x="997072" y="1143000"/>
+            <a:ext cx="10258816" cy="5349240"/>
           </a:xfrm>
           <a:prstGeom prst="rect">
             <a:avLst/>
@@ -5809,7 +5876,7 @@
                 </a:solidFill>
                 <a:latin typeface="Arial"/>
               </a:rPr>
-              <a:t>Backup — 15 events, cumulative energy (PBS1)</a:t>
+              <a:t>Backup — 15 events, fitted current and power (PBS1)</a:t>
             </a:r>
           </a:p>
         </p:txBody>
@@ -5893,7 +5960,7 @@
       </p:sp>
       <p:pic>
         <p:nvPicPr>
-          <p:cNvPr id="5" name="Picture 4" descr="cum_15events.png"/>
+          <p:cNvPr id="5" name="Picture 4" descr="pulse_15events.png"/>
           <p:cNvPicPr>
             <a:picLocks noChangeAspect="1"/>
           </p:cNvPicPr>
@@ -5962,7 +6029,7 @@
                 </a:solidFill>
                 <a:latin typeface="Arial"/>
               </a:rPr>
-              <a:t>Backup — event 30646, all channels</a:t>
+              <a:t>Backup — 15 events, cumulative energy (PBS1)</a:t>
             </a:r>
           </a:p>
         </p:txBody>
@@ -6046,7 +6113,7 @@
       </p:sp>
       <p:pic>
         <p:nvPicPr>
-          <p:cNvPr id="5" name="Picture 4" descr="allchan_pulses.png"/>
+          <p:cNvPr id="5" name="Picture 4" descr="cum_15events.png"/>
           <p:cNvPicPr>
             <a:picLocks noChangeAspect="1"/>
           </p:cNvPicPr>
@@ -6060,8 +6127,8 @@
         </p:blipFill>
         <p:spPr>
           <a:xfrm>
-            <a:off x="502920" y="1758921"/>
-            <a:ext cx="11247120" cy="4025957"/>
+            <a:off x="2671354" y="1143000"/>
+            <a:ext cx="6910251" cy="5257800"/>
           </a:xfrm>
           <a:prstGeom prst="rect">
             <a:avLst/>
@@ -6115,7 +6182,7 @@
                 </a:solidFill>
                 <a:latin typeface="Arial"/>
               </a:rPr>
-              <a:t>Backup — energy distribution of every channel</a:t>
+              <a:t>Backup — event 30646, all channels</a:t>
             </a:r>
           </a:p>
         </p:txBody>
@@ -6193,6 +6260,159 @@
                 <a:latin typeface="Arial"/>
               </a:rPr>
               <a:t>17</a:t>
+            </a:r>
+          </a:p>
+        </p:txBody>
+      </p:sp>
+      <p:pic>
+        <p:nvPicPr>
+          <p:cNvPr id="5" name="Picture 4" descr="allchan_pulses.png"/>
+          <p:cNvPicPr>
+            <a:picLocks noChangeAspect="1"/>
+          </p:cNvPicPr>
+          <p:nvPr/>
+        </p:nvPicPr>
+        <p:blipFill>
+          <a:blip r:embed="rId3"/>
+          <a:stretch>
+            <a:fillRect/>
+          </a:stretch>
+        </p:blipFill>
+        <p:spPr>
+          <a:xfrm>
+            <a:off x="502920" y="1758921"/>
+            <a:ext cx="11247120" cy="4025957"/>
+          </a:xfrm>
+          <a:prstGeom prst="rect">
+            <a:avLst/>
+          </a:prstGeom>
+        </p:spPr>
+      </p:pic>
+    </p:spTree>
+  </p:cSld>
+  <p:clrMapOvr>
+    <a:masterClrMapping/>
+  </p:clrMapOvr>
+</p:sld>
+</file>
+
+<file path=ppt/slides/slide18.xml><?xml version="1.0" encoding="utf-8"?>
+<p:sld xmlns:a="http://schemas.openxmlformats.org/drawingml/2006/main" xmlns:p="http://schemas.openxmlformats.org/presentationml/2006/main" xmlns:r="http://schemas.openxmlformats.org/officeDocument/2006/relationships">
+  <p:cSld>
+    <p:spTree>
+      <p:nvGrpSpPr>
+        <p:cNvPr id="1" name=""/>
+        <p:cNvGrpSpPr/>
+        <p:nvPr/>
+      </p:nvGrpSpPr>
+      <p:grpSpPr/>
+      <p:sp>
+        <p:nvSpPr>
+          <p:cNvPr id="2" name="TextBox 1"/>
+          <p:cNvSpPr txBox="1"/>
+          <p:nvPr/>
+        </p:nvSpPr>
+        <p:spPr>
+          <a:xfrm>
+            <a:off x="502920" y="228600"/>
+            <a:ext cx="11247120" cy="731520"/>
+          </a:xfrm>
+          <a:prstGeom prst="rect">
+            <a:avLst/>
+          </a:prstGeom>
+          <a:noFill/>
+        </p:spPr>
+        <p:txBody>
+          <a:bodyPr wrap="square">
+            <a:spAutoFit/>
+          </a:bodyPr>
+          <a:lstStyle/>
+          <a:p>
+            <a:r>
+              <a:rPr sz="2700" b="1" i="0">
+                <a:solidFill>
+                  <a:srgbClr val="1F3864"/>
+                </a:solidFill>
+                <a:latin typeface="Arial"/>
+              </a:rPr>
+              <a:t>Backup — energy distribution of every channel</a:t>
+            </a:r>
+          </a:p>
+        </p:txBody>
+      </p:sp>
+      <p:sp>
+        <p:nvSpPr>
+          <p:cNvPr id="3" name="Rectangle 2"/>
+          <p:cNvSpPr/>
+          <p:nvPr/>
+        </p:nvSpPr>
+        <p:spPr>
+          <a:xfrm>
+            <a:off x="502920" y="969264"/>
+            <a:ext cx="11247120" cy="18000"/>
+          </a:xfrm>
+          <a:prstGeom prst="rect">
+            <a:avLst/>
+          </a:prstGeom>
+          <a:solidFill>
+            <a:srgbClr val="1F3864"/>
+          </a:solidFill>
+          <a:ln>
+            <a:noFill/>
+          </a:ln>
+        </p:spPr>
+        <p:style>
+          <a:lnRef idx="1">
+            <a:schemeClr val="accent1"/>
+          </a:lnRef>
+          <a:fillRef idx="3">
+            <a:schemeClr val="accent1"/>
+          </a:fillRef>
+          <a:effectRef idx="2">
+            <a:schemeClr val="accent1"/>
+          </a:effectRef>
+          <a:fontRef idx="minor">
+            <a:schemeClr val="lt1"/>
+          </a:fontRef>
+        </p:style>
+        <p:txBody>
+          <a:bodyPr rtlCol="0" anchor="ctr"/>
+          <a:lstStyle/>
+          <a:p>
+            <a:pPr algn="ctr"/>
+          </a:p>
+        </p:txBody>
+      </p:sp>
+      <p:sp>
+        <p:nvSpPr>
+          <p:cNvPr id="4" name="TextBox 3"/>
+          <p:cNvSpPr txBox="1"/>
+          <p:nvPr/>
+        </p:nvSpPr>
+        <p:spPr>
+          <a:xfrm>
+            <a:off x="11430000" y="6446520"/>
+            <a:ext cx="548640" cy="320040"/>
+          </a:xfrm>
+          <a:prstGeom prst="rect">
+            <a:avLst/>
+          </a:prstGeom>
+          <a:noFill/>
+        </p:spPr>
+        <p:txBody>
+          <a:bodyPr wrap="square">
+            <a:spAutoFit/>
+          </a:bodyPr>
+          <a:lstStyle/>
+          <a:p>
+            <a:r>
+              <a:rPr sz="1000" b="0" i="0">
+                <a:solidFill>
+                  <a:srgbClr val="666666"/>
+                </a:solidFill>
+                <a:latin typeface="Arial"/>
+              </a:rPr>
+              <a:t>18</a:t>
             </a:r>
           </a:p>
         </p:txBody>

</xml_diff>

<commit_message>
snolab: write the two coefficients out as substituted equations
Formula card and the main figure's footer now show
I0(R_L-R0) = (-18.07 uA) x (19.24 mOhm - 44.16 mOhm) = 0.45 uV and
2 R_L = 2 x 19.24 mOhm = 0.0385 Ohm, instead of only the results.

Co-Authored-By: Claude Opus 5 (1M context) <noreply@anthropic.com>
Claude-Session: https://claude.ai/code/session_017642NhrahqPyV2kbDPpL5m
</commit_message>
<xml_diff>
--- a/snolab/collection_efficiency/presentation/SNOLAB_R4_collection_efficiency_20260910.pptx
+++ b/snolab/collection_efficiency/presentation/SNOLAB_R4_collection_efficiency_20260910.pptx
@@ -7241,8 +7241,8 @@
         </p:blipFill>
         <p:spPr>
           <a:xfrm>
-            <a:off x="1141012" y="1143000"/>
-            <a:ext cx="9970935" cy="4526280"/>
+            <a:off x="898558" y="1143000"/>
+            <a:ext cx="10455844" cy="4526280"/>
           </a:xfrm>
           <a:prstGeom prst="rect">
             <a:avLst/>
@@ -7449,8 +7449,8 @@
         </p:blipFill>
         <p:spPr>
           <a:xfrm>
-            <a:off x="1550903" y="1143000"/>
-            <a:ext cx="9151153" cy="3657599"/>
+            <a:off x="1752489" y="1143000"/>
+            <a:ext cx="8747982" cy="3657599"/>
           </a:xfrm>
           <a:prstGeom prst="rect">
             <a:avLst/>

</xml_diff>

<commit_message>
snolab: slide 7 figure, one legend per row and an arrowed label for the mean line
Co-Authored-By: Claude Opus 5 (1M context) <noreply@anthropic.com>
Claude-Session: https://claude.ai/code/session_017642NhrahqPyV2kbDPpL5m
</commit_message>
<xml_diff>
--- a/snolab/collection_efficiency/presentation/SNOLAB_R4_collection_efficiency_20260910.pptx
+++ b/snolab/collection_efficiency/presentation/SNOLAB_R4_collection_efficiency_20260910.pptx
@@ -7673,8 +7673,8 @@
         </p:blipFill>
         <p:spPr>
           <a:xfrm>
-            <a:off x="1928553" y="1143000"/>
-            <a:ext cx="8395854" cy="4617720"/>
+            <a:off x="2468880" y="1143000"/>
+            <a:ext cx="7315200" cy="4663440"/>
           </a:xfrm>
           <a:prstGeom prst="rect">
             <a:avLst/>

</xml_diff>

<commit_message>
snolab: slide 5 carries only the figure; the script says the fit is on the 100 kHz trace first
Also drops the comparison with our own exact coefficient from slide 3's script,
from the Q and A and from the backup slide, which now shows only the note's two
Methods and their 1.7% difference.

Co-Authored-By: Claude Opus 5 (1M context) <noreply@anthropic.com>
Claude-Session: https://claude.ai/code/session_017642NhrahqPyV2kbDPpL5m
</commit_message>
<xml_diff>
--- a/snolab/collection_efficiency/presentation/SNOLAB_R4_collection_efficiency_20260910.pptx
+++ b/snolab/collection_efficiency/presentation/SNOLAB_R4_collection_efficiency_20260910.pptx
@@ -799,7 +799,7 @@
           <a:lstStyle/>
           <a:p>
             <a:r>
-              <a:t>c2 = 2 Method 1 (used), 1 exact, -1 Method 2. Relative to exact: +0.58%, -1.15%.</a:t>
+              <a:t>c2 = 2 is Method 1 (used here), c2 = -1 is Method 2; 1.7% apart in energy.</a:t>
             </a:r>
           </a:p>
         </p:txBody>
@@ -5507,7 +5507,7 @@
                 </a:solidFill>
                 <a:latin typeface="Arial"/>
               </a:rPr>
-              <a:t>Backup — the three versions of the power formula</a:t>
+              <a:t>Backup — the two Methods of the CDMS note</a:t>
             </a:r>
           </a:p>
         </p:txBody>
@@ -5623,7 +5623,7 @@
                 </a:solidFill>
                 <a:latin typeface="Arial"/>
               </a:rPr>
-              <a:t>δP = I₀(R_L − R₀)·δI + c₂·R_L·(δI)²     with c₂ = 2 (Method 1, used here), 1 (exact small-signal), −1 (Method 2)</a:t>
+              <a:t>δP = I₀(R_L − R₀)·δI + c₂·R_L·(δI)²     with c₂ = 2 (Method 1, used here) and c₂ = −1 (Method 2)</a:t>
             </a:r>
           </a:p>
           <a:p>
@@ -5639,7 +5639,7 @@
                 </a:solidFill>
                 <a:latin typeface="Arial"/>
               </a:rPr>
-              <a:t>Relative to the exact form: Method 1 +0.58 %, Method 2 −1.15 % in energy — far below the 15 % single-channel width and the PDS2 bracket.</a:t>
+              <a:t>The two differ only in the quadratic term: 1.7 % in energy (PBS1, median of 15 events) — far below the 15 % single-channel width and the PDS2 bracket.</a:t>
             </a:r>
           </a:p>
           <a:p>
@@ -7241,69 +7241,14 @@
         </p:blipFill>
         <p:spPr>
           <a:xfrm>
-            <a:off x="898558" y="1143000"/>
-            <a:ext cx="10455844" cy="4526280"/>
+            <a:off x="502920" y="1406070"/>
+            <a:ext cx="11247120" cy="4868819"/>
           </a:xfrm>
           <a:prstGeom prst="rect">
             <a:avLst/>
           </a:prstGeom>
         </p:spPr>
       </p:pic>
-      <p:sp>
-        <p:nvSpPr>
-          <p:cNvPr id="6" name="TextBox 5"/>
-          <p:cNvSpPr txBox="1"/>
-          <p:nvPr/>
-        </p:nvSpPr>
-        <p:spPr>
-          <a:xfrm>
-            <a:off x="502920" y="5760720"/>
-            <a:ext cx="11247120" cy="914400"/>
-          </a:xfrm>
-          <a:prstGeom prst="rect">
-            <a:avLst/>
-          </a:prstGeom>
-          <a:noFill/>
-        </p:spPr>
-        <p:txBody>
-          <a:bodyPr wrap="square">
-            <a:spAutoFit/>
-          </a:bodyPr>
-          <a:lstStyle/>
-          <a:p>
-            <a:pPr>
-              <a:spcAft>
-                <a:spcPts val="800"/>
-              </a:spcAft>
-            </a:pPr>
-            <a:r>
-              <a:rPr sz="1500" b="0" i="0">
-                <a:solidFill>
-                  <a:srgbClr val="333333"/>
-                </a:solidFill>
-                <a:latin typeface="Arial"/>
-              </a:rPr>
-              <a:t>Yellow band: 98 samples sit within 10 % of the peak. The largest of them is the largest noise excursion.</a:t>
-            </a:r>
-          </a:p>
-          <a:p>
-            <a:pPr>
-              <a:spcAft>
-                <a:spcPts val="800"/>
-              </a:spcAft>
-            </a:pPr>
-            <a:r>
-              <a:rPr sz="1500" b="1" i="0">
-                <a:solidFill>
-                  <a:srgbClr val="C0392B"/>
-                </a:solidFill>
-                <a:latin typeface="Arial"/>
-              </a:rPr>
-              <a:t>Largest raw sample 885 ADC, fit 717 ADC: the maximum reads 23 % high. Filtering helps; the fit removes it.</a:t>
-            </a:r>
-          </a:p>
-        </p:txBody>
-      </p:sp>
     </p:spTree>
   </p:cSld>
   <p:clrMapOvr>

</xml_diff>

<commit_message>
snolab: per-channel energy table on slide 8, legend off the trace on the main figure
- slide 8 gains a table of the 11 channel energies of event 30646, grouped by
  face: side 1 2062 eV (60 %), side 2 1357 eV (40 %), total 3419 eV = 33.0 %;
  parsed from the result text file, with the missing PFS2 noted
- the main figure's legend moves above the axes so it no longer covers the trace
- the table header reads 'height from', since the rows are four ways of taking
  the same pulse height
- slide 7 retitled 'Why we integrate the fit, not the raw data'

Co-Authored-By: Claude Opus 5 (1M context) <noreply@anthropic.com>
Claude-Session: https://claude.ai/code/session_017642NhrahqPyV2kbDPpL5m
</commit_message>
<xml_diff>
--- a/snolab/collection_efficiency/presentation/SNOLAB_R4_collection_efficiency_20260910.pptx
+++ b/snolab/collection_efficiency/presentation/SNOLAB_R4_collection_efficiency_20260910.pptx
@@ -7241,8 +7241,8 @@
         </p:blipFill>
         <p:spPr>
           <a:xfrm>
-            <a:off x="502920" y="1406070"/>
-            <a:ext cx="11247120" cy="4868819"/>
+            <a:off x="502920" y="1272881"/>
+            <a:ext cx="11247120" cy="5135198"/>
           </a:xfrm>
           <a:prstGeom prst="rect">
             <a:avLst/>
@@ -7394,8 +7394,8 @@
         </p:blipFill>
         <p:spPr>
           <a:xfrm>
-            <a:off x="1752489" y="1143000"/>
-            <a:ext cx="8747982" cy="3657599"/>
+            <a:off x="1487227" y="1143000"/>
+            <a:ext cx="9278505" cy="3657599"/>
           </a:xfrm>
           <a:prstGeom prst="rect">
             <a:avLst/>
@@ -7520,7 +7520,7 @@
                 </a:solidFill>
                 <a:latin typeface="Arial"/>
               </a:rPr>
-              <a:t>Why the fitted pulse is integrated, and not the data</a:t>
+              <a:t>Why we integrate the fit, not the raw data</a:t>
             </a:r>
           </a:p>
         </p:txBody>
@@ -7837,24 +7837,48 @@
         </p:blipFill>
         <p:spPr>
           <a:xfrm>
-            <a:off x="1978226" y="1143000"/>
-            <a:ext cx="8296507" cy="4251960"/>
+            <a:off x="502920" y="1323022"/>
+            <a:ext cx="7772400" cy="3983355"/>
           </a:xfrm>
           <a:prstGeom prst="rect">
             <a:avLst/>
           </a:prstGeom>
         </p:spPr>
       </p:pic>
-      <p:sp>
-        <p:nvSpPr>
-          <p:cNvPr id="6" name="TextBox 5"/>
+      <p:pic>
+        <p:nvPicPr>
+          <p:cNvPr id="6" name="Picture 5" descr="chan_table_en.png"/>
+          <p:cNvPicPr>
+            <a:picLocks noChangeAspect="1"/>
+          </p:cNvPicPr>
+          <p:nvPr/>
+        </p:nvPicPr>
+        <p:blipFill>
+          <a:blip r:embed="rId4"/>
+          <a:stretch>
+            <a:fillRect/>
+          </a:stretch>
+        </p:blipFill>
+        <p:spPr>
+          <a:xfrm>
+            <a:off x="8458200" y="1608151"/>
+            <a:ext cx="3291840" cy="4007457"/>
+          </a:xfrm>
+          <a:prstGeom prst="rect">
+            <a:avLst/>
+          </a:prstGeom>
+        </p:spPr>
+      </p:pic>
+      <p:sp>
+        <p:nvSpPr>
+          <p:cNvPr id="7" name="TextBox 6"/>
           <p:cNvSpPr txBox="1"/>
           <p:nvPr/>
         </p:nvSpPr>
         <p:spPr>
           <a:xfrm>
-            <a:off x="502920" y="5486400"/>
-            <a:ext cx="11247120" cy="1005840"/>
+            <a:off x="502920" y="5577840"/>
+            <a:ext cx="7863840" cy="1005840"/>
           </a:xfrm>
           <a:prstGeom prst="rect">
             <a:avLst/>
@@ -7873,13 +7897,13 @@
               </a:spcAft>
             </a:pPr>
             <a:r>
-              <a:rPr sz="1500" b="0" i="0">
+              <a:rPr sz="1400" b="0" i="0">
                 <a:solidFill>
                   <a:srgbClr val="333333"/>
                 </a:solidFill>
                 <a:latin typeface="Arial"/>
               </a:rPr>
-              <a:t>The channels share the energy unevenly (PES1 489 eV, PES2 195 eV): the event sat closer to one side.</a:t>
+              <a:t>The channels do not share the energy equally: 60 % of it lands on side 1, and PES1 alone has 489 eV against 195 eV in PES2.</a:t>
             </a:r>
           </a:p>
           <a:p>
@@ -7889,7 +7913,7 @@
               </a:spcAft>
             </a:pPr>
             <a:r>
-              <a:rPr sz="1500" b="1" i="0">
+              <a:rPr sz="1400" b="1" i="0">
                 <a:solidFill>
                   <a:srgbClr val="C0392B"/>
                 </a:solidFill>

</xml_diff>

<commit_message>
snolab: slide 3 names the symbols and cites where the two Methods come from
I0, R0 and R_L = R_p + R_sh are defined on the slide, and a small line gives the
sources: the CDMS wiki page, Kurinsky's thesis appendix D for Method 1, Watkins'
note for Method 2, the note discussing their difference, and Irwin & Hilton for
the TES equations. Script updated; the channel table's note no longer ends in a
bracket that could be clipped.

Co-Authored-By: Claude Opus 5 (1M context) <noreply@anthropic.com>
Claude-Session: https://claude.ai/code/session_017642NhrahqPyV2kbDPpL5m
</commit_message>
<xml_diff>
--- a/snolab/collection_efficiency/presentation/SNOLAB_R4_collection_efficiency_20260910.pptx
+++ b/snolab/collection_efficiency/presentation/SNOLAB_R4_collection_efficiency_20260910.pptx
@@ -6821,8 +6821,8 @@
         </p:blipFill>
         <p:spPr>
           <a:xfrm>
-            <a:off x="997889" y="1143000"/>
-            <a:ext cx="10257182" cy="3931920"/>
+            <a:off x="1892410" y="1143000"/>
+            <a:ext cx="8468139" cy="3246120"/>
           </a:xfrm>
           <a:prstGeom prst="rect">
             <a:avLst/>
@@ -6837,8 +6837,8 @@
         </p:nvSpPr>
         <p:spPr>
           <a:xfrm>
-            <a:off x="502920" y="5120640"/>
-            <a:ext cx="11247120" cy="1463040"/>
+            <a:off x="502920" y="4526280"/>
+            <a:ext cx="11247120" cy="1280160"/>
           </a:xfrm>
           <a:prstGeom prst="rect">
             <a:avLst/>
@@ -6857,7 +6857,7 @@
               </a:spcAft>
             </a:pPr>
             <a:r>
-              <a:rPr sz="1500" b="0" i="0">
+              <a:rPr sz="1300" b="0" i="0">
                 <a:solidFill>
                   <a:srgbClr val="333333"/>
                 </a:solidFill>
@@ -6873,13 +6873,63 @@
               </a:spcAft>
             </a:pPr>
             <a:r>
-              <a:rPr sz="1500" b="0" i="0">
+              <a:rPr sz="1300" b="0" i="0">
                 <a:solidFill>
                   <a:srgbClr val="333333"/>
                 </a:solidFill>
                 <a:latin typeface="Arial"/>
               </a:rPr>
-              <a:t>The note also gives Method 2. In our sign convention it reads δP = I₀(R_L − R₀)·δI − R_L·(δI)²: the same linear term, only the quadratic term differs, and it gives 1.7 % less energy (PBS1, median of 15 events).</a:t>
+              <a:t>I₀: TES current at the bias point · R₀: TES resistance at the bias point · R_L = R_p + R_sh: load resistance (R_p parasitic, R_sh shunt) · δI: change in current, from the trace</a:t>
+            </a:r>
+          </a:p>
+          <a:p>
+            <a:pPr>
+              <a:spcAft>
+                <a:spcPts val="800"/>
+              </a:spcAft>
+            </a:pPr>
+            <a:r>
+              <a:rPr sz="1300" b="0" i="0">
+                <a:solidFill>
+                  <a:srgbClr val="333333"/>
+                </a:solidFill>
+                <a:latin typeface="Arial"/>
+              </a:rPr>
+              <a:t>The note also gives Method 2: δP = I₀(R_L − R₀)·δI − R_L·(δI)² in our sign convention — same linear term, only the quadratic term differs, 1.7 % less energy (PBS1, median of 15 events).</a:t>
+            </a:r>
+          </a:p>
+        </p:txBody>
+      </p:sp>
+      <p:sp>
+        <p:nvSpPr>
+          <p:cNvPr id="7" name="TextBox 6"/>
+          <p:cNvSpPr txBox="1"/>
+          <p:nvPr/>
+        </p:nvSpPr>
+        <p:spPr>
+          <a:xfrm>
+            <a:off x="502920" y="5760720"/>
+            <a:ext cx="11247120" cy="822960"/>
+          </a:xfrm>
+          <a:prstGeom prst="rect">
+            <a:avLst/>
+          </a:prstGeom>
+          <a:noFill/>
+        </p:spPr>
+        <p:txBody>
+          <a:bodyPr wrap="square">
+            <a:spAutoFit/>
+          </a:bodyPr>
+          <a:lstStyle/>
+          <a:p>
+            <a:r>
+              <a:rPr sz="950" b="0" i="1">
+                <a:solidFill>
+                  <a:srgbClr val="666666"/>
+                </a:solidFill>
+                <a:latin typeface="Arial"/>
+              </a:rPr>
+              <a:t>Sources — CDMS wiki, "Collection Efficiency Analysis" (both Methods and the procedure);  Method 1 derived in N. Kurinsky, PhD thesis, appendix D (slac.stanford.edu/exp/cdms/ScienceResults/Theses/kurinsky.pdf);  Method 2 in S. Watkins, "energy_absorbed_deriv_v3.pdf" on the SLAC confluence page "Internal Documentation: PD2 DM Search v2";  the difference between the two is discussed in "Power_derivation.pdf" on confluence;  the TES equations: Irwin &amp; Hilton, Transition-Edge Sensors, Topics in Applied Physics 99 (2005), pp. 74-75 and 87-88.</a:t>
             </a:r>
           </a:p>
         </p:txBody>

</xml_diff>

<commit_message>
snolab: one short source line on slide 3, just the wiki link
Co-Authored-By: Claude Opus 5 (1M context) <noreply@anthropic.com>
Claude-Session: https://claude.ai/code/session_017642NhrahqPyV2kbDPpL5m
</commit_message>
<xml_diff>
--- a/snolab/collection_efficiency/presentation/SNOLAB_R4_collection_efficiency_20260910.pptx
+++ b/snolab/collection_efficiency/presentation/SNOLAB_R4_collection_efficiency_20260910.pptx
@@ -6908,7 +6908,7 @@
         </p:nvSpPr>
         <p:spPr>
           <a:xfrm>
-            <a:off x="502920" y="5760720"/>
+            <a:off x="502920" y="5806440"/>
             <a:ext cx="11247120" cy="822960"/>
           </a:xfrm>
           <a:prstGeom prst="rect">
@@ -6923,13 +6923,13 @@
           <a:lstStyle/>
           <a:p>
             <a:r>
-              <a:rPr sz="950" b="0" i="1">
+              <a:rPr sz="1100" b="0" i="1">
                 <a:solidFill>
                   <a:srgbClr val="666666"/>
                 </a:solidFill>
                 <a:latin typeface="Arial"/>
               </a:rPr>
-              <a:t>Sources — CDMS wiki, "Collection Efficiency Analysis" (both Methods and the procedure);  Method 1 derived in N. Kurinsky, PhD thesis, appendix D (slac.stanford.edu/exp/cdms/ScienceResults/Theses/kurinsky.pdf);  Method 2 in S. Watkins, "energy_absorbed_deriv_v3.pdf" on the SLAC confluence page "Internal Documentation: PD2 DM Search v2";  the difference between the two is discussed in "Power_derivation.pdf" on confluence;  the TES equations: Irwin &amp; Hilton, Transition-Edge Sensors, Topics in Applied Physics 99 (2005), pp. 74-75 and 87-88.</a:t>
+              <a:t>Source:  CDMS wiki, Collection Efficiency Analysis   —   confluence.slac.stanford.edu/spaces/CDMS/pages/542577254</a:t>
             </a:r>
           </a:p>
         </p:txBody>

</xml_diff>

<commit_message>
snolab: shorter summary slide and summary script
Four short lines on the slide and three sentences in the script; the widths and
the quadratic term are already covered on slides 6, 9 and 10. Slide 11 is
retimed to 35 s, so the talk is about 725 s.

Co-Authored-By: Claude Opus 5 (1M context) <noreply@anthropic.com>
Claude-Session: https://claude.ai/code/session_017642NhrahqPyV2kbDPpL5m
</commit_message>
<xml_diff>
--- a/snolab/collection_efficiency/presentation/SNOLAB_R4_collection_efficiency_20260910.pptx
+++ b/snolab/collection_efficiency/presentation/SNOLAB_R4_collection_efficiency_20260910.pptx
@@ -5212,8 +5212,8 @@
         </p:nvSpPr>
         <p:spPr>
           <a:xfrm>
-            <a:off x="502920" y="1325880"/>
-            <a:ext cx="11247120" cy="5029200"/>
+            <a:off x="502920" y="1463040"/>
+            <a:ext cx="11247120" cy="4206240"/>
           </a:xfrm>
           <a:prstGeom prst="rect">
             <a:avLst/>
@@ -5232,13 +5232,13 @@
               </a:spcAft>
             </a:pPr>
             <a:r>
-              <a:rPr sz="1700" b="0" i="0">
+              <a:rPr sz="1900" b="0" i="0">
                 <a:solidFill>
                   <a:srgbClr val="333333"/>
                 </a:solidFill>
                 <a:latin typeface="Arial"/>
               </a:rPr>
-              <a:t>A current pulse becomes a power pulse through the TES equations; the area under the power is the energy. The quadratic term is 2 %.</a:t>
+              <a:t>The current pulse becomes a power pulse through the TES equations; the area under the power is the energy.</a:t>
             </a:r>
           </a:p>
           <a:p>
@@ -5248,13 +5248,13 @@
               </a:spcAft>
             </a:pPr>
             <a:r>
-              <a:rPr sz="1700" b="0" i="0">
+              <a:rPr sz="1900" b="0" i="0">
                 <a:solidFill>
                   <a:srgbClr val="333333"/>
                 </a:solidFill>
                 <a:latin typeface="Arial"/>
               </a:rPr>
-              <a:t>The energy comes from the fitted pulse, integrated from −∞ to +∞: no bias from the noisy maximum, no drift.</a:t>
+              <a:t>The energy is taken from the fitted pulse, so the noise at the peak and the baseline drift do not enter.</a:t>
             </a:r>
           </a:p>
           <a:p>
@@ -5264,13 +5264,13 @@
               </a:spcAft>
             </a:pPr>
             <a:r>
-              <a:rPr sz="1700" b="0" i="0">
-                <a:solidFill>
-                  <a:srgbClr val="333333"/>
+              <a:rPr sz="1900" b="1" i="0">
+                <a:solidFill>
+                  <a:srgbClr val="C0392B"/>
                 </a:solidFill>
                 <a:latin typeface="Arial"/>
               </a:rPr>
-              <a:t>One channel: 15 % wide and lopsided (position). Ten channels summed: 7.5 % and symmetric.</a:t>
+              <a:t>Z7 absorbs 32 ± 1 % of a 10.37 keV event in its TESs.   The CDMS note reports 26–41 % on the R37 CUTE tower.</a:t>
             </a:r>
           </a:p>
           <a:p>
@@ -5280,29 +5280,13 @@
               </a:spcAft>
             </a:pPr>
             <a:r>
-              <a:rPr sz="1700" b="1" i="0">
-                <a:solidFill>
-                  <a:srgbClr val="C0392B"/>
+              <a:rPr sz="1900" b="0" i="0">
+                <a:solidFill>
+                  <a:srgbClr val="333333"/>
                 </a:solidFill>
                 <a:latin typeface="Arial"/>
               </a:rPr>
-              <a:t>Z7 absorbs 32 ± 1 % of a 10.37 keV event in its TESs. The CDMS note on the R37 CUTE tower reports 26–41 %.</a:t>
-            </a:r>
-          </a:p>
-          <a:p>
-            <a:pPr>
-              <a:spcAft>
-                <a:spcPts val="800"/>
-              </a:spcAft>
-            </a:pPr>
-            <a:r>
-              <a:rPr sz="1700" b="0" i="0">
-                <a:solidFill>
-                  <a:srgbClr val="333333"/>
-                </a:solidFill>
-                <a:latin typeface="Arial"/>
-              </a:rPr>
-              <a:t>Open: Z7 only · the HV bias of Z7 is not established (0 V assumed) · no dI/dV, so the inductor term is dropped · PDS2 is the ± 1 % · 12.5 % of events fit in no channel and are not in the histograms.</a:t>
+              <a:t>Open: Z7 only · the bias of Z7 is not established (0 V assumed) · no dI/dV · PDS2 is the ± 1 % · 12.5 % of events fit in no channel.</a:t>
             </a:r>
           </a:p>
         </p:txBody>

</xml_diff>

<commit_message>
snolab: shorter script for slides 5, 6 and 10, and a legend table on slide 6
- the 1.9 percent peak share is gone from the slides, the figure and the script
- slide 6 shows the power panel as a taller figure with a legend table beside it
- slides 5, 6 and 10 are spoken in a few sentences each, pointing at the figure
- timings: 70 / 55 / 80 s, so the talk is about 630 s of speech

Co-Authored-By: Claude Opus 5 (1M context) <noreply@anthropic.com>
Claude-Session: https://claude.ai/code/session_017642NhrahqPyV2kbDPpL5m
</commit_message>
<xml_diff>
--- a/snolab/collection_efficiency/presentation/SNOLAB_R4_collection_efficiency_20260910.pptx
+++ b/snolab/collection_efficiency/presentation/SNOLAB_R4_collection_efficiency_20260910.pptx
@@ -1495,7 +1495,7 @@
           <a:lstStyle/>
           <a:p>
             <a:r>
-              <a:t>Red: power from the fitted current, two terms added. Blue dashed: linear term alone. Purple dotted: quadratic term x20. Peak 104.6 fW = 102.6 + 2.0: quadratic 1.9% of peak, 1.3% of energy. Shaded area 305.2 eV, 99% inside this window. Bottom line: the bias point that fixes the coefficients.</a:t>
+              <a:t>Red: power from the fitted current, two terms added. Blue dashed: linear term alone. Purple dotted: quadratic term x20. Peak 104.6 fW = 102.6 + 2.0: the quadratic term is 1.3% of the energy. Shaded area 305.2 eV, 99% inside this window. Bottom line: the bias point that fixes the coefficients.</a:t>
             </a:r>
           </a:p>
         </p:txBody>
@@ -7414,7 +7414,7 @@
       </p:sp>
       <p:pic>
         <p:nvPicPr>
-          <p:cNvPr id="5" name="Picture 4" descr="peak_bottom.png"/>
+          <p:cNvPr id="5" name="Picture 4" descr="power_panel.png"/>
           <p:cNvPicPr>
             <a:picLocks noChangeAspect="1"/>
           </p:cNvPicPr>
@@ -7428,85 +7428,38 @@
         </p:blipFill>
         <p:spPr>
           <a:xfrm>
-            <a:off x="1487227" y="1143000"/>
-            <a:ext cx="9278505" cy="3657599"/>
+            <a:off x="916417" y="1143000"/>
+            <a:ext cx="6031005" cy="5257800"/>
           </a:xfrm>
           <a:prstGeom prst="rect">
             <a:avLst/>
           </a:prstGeom>
         </p:spPr>
       </p:pic>
-      <p:sp>
-        <p:nvSpPr>
-          <p:cNvPr id="6" name="TextBox 5"/>
-          <p:cNvSpPr txBox="1"/>
+      <p:pic>
+        <p:nvPicPr>
+          <p:cNvPr id="6" name="Picture 5" descr="power_legend_en.png"/>
+          <p:cNvPicPr>
+            <a:picLocks noChangeAspect="1"/>
+          </p:cNvPicPr>
           <p:nvPr/>
-        </p:nvSpPr>
-        <p:spPr>
-          <a:xfrm>
-            <a:off x="502920" y="4937760"/>
-            <a:ext cx="11247120" cy="1645920"/>
-          </a:xfrm>
-          <a:prstGeom prst="rect">
-            <a:avLst/>
-          </a:prstGeom>
-          <a:noFill/>
-        </p:spPr>
-        <p:txBody>
-          <a:bodyPr wrap="square">
-            <a:spAutoFit/>
-          </a:bodyPr>
-          <a:lstStyle/>
-          <a:p>
-            <a:pPr>
-              <a:spcAft>
-                <a:spcPts val="800"/>
-              </a:spcAft>
-            </a:pPr>
-            <a:r>
-              <a:rPr sz="1500" b="0" i="0">
-                <a:solidFill>
-                  <a:srgbClr val="333333"/>
-                </a:solidFill>
-                <a:latin typeface="Arial"/>
-              </a:rPr>
-              <a:t>Red: the fitted current put through the formula. Blue dashed: the linear term alone. Purple: the quadratic term, ×20.</a:t>
-            </a:r>
-          </a:p>
-          <a:p>
-            <a:pPr>
-              <a:spcAft>
-                <a:spcPts val="800"/>
-              </a:spcAft>
-            </a:pPr>
-            <a:r>
-              <a:rPr sz="1500" b="1" i="0">
-                <a:solidFill>
-                  <a:srgbClr val="C0392B"/>
-                </a:solidFill>
-                <a:latin typeface="Arial"/>
-              </a:rPr>
-              <a:t>The quadratic term is 1.9 % of the peak — the power pulse has the shape of the current pulse.</a:t>
-            </a:r>
-          </a:p>
-          <a:p>
-            <a:pPr>
-              <a:spcAft>
-                <a:spcPts val="800"/>
-              </a:spcAft>
-            </a:pPr>
-            <a:r>
-              <a:rPr sz="1500" b="1" i="0">
-                <a:solidFill>
-                  <a:srgbClr val="C0392B"/>
-                </a:solidFill>
-                <a:latin typeface="Arial"/>
-              </a:rPr>
-              <a:t>The shaded area is the energy this channel absorbed: 305 eV.</a:t>
-            </a:r>
-          </a:p>
-        </p:txBody>
-      </p:sp>
+        </p:nvPicPr>
+        <p:blipFill>
+          <a:blip r:embed="rId4"/>
+          <a:stretch>
+            <a:fillRect/>
+          </a:stretch>
+        </p:blipFill>
+        <p:spPr>
+          <a:xfrm>
+            <a:off x="7458892" y="1920240"/>
+            <a:ext cx="4284616" cy="3749039"/>
+          </a:xfrm>
+          <a:prstGeom prst="rect">
+            <a:avLst/>
+          </a:prstGeom>
+        </p:spPr>
+      </p:pic>
     </p:spTree>
   </p:cSld>
   <p:clrMapOvr>

</xml_diff>

<commit_message>
snolab: report the 10-channel sum, 30.5 % with sigma/mu 7.5 %, PDS2 left out
Prof. Liu's decision: the events on which PDS2 fits are the ones near it,
so the 11-channel subsample depends on position and the 32 +- 1 % bracket
is withdrawn. The uncertainty is sigma/mu of the 10-channel Gaussian fit.
Sum histogram drops the 11-channel curve; decks, script and notes follow.

Co-Authored-By: Claude Opus 5 (1M context) <noreply@anthropic.com>
Claude-Session: https://claude.ai/code/session_017642NhrahqPyV2kbDPpL5m
</commit_message>
<xml_diff>
--- a/snolab/collection_efficiency/presentation/SNOLAB_R4_collection_efficiency_20260910.pptx
+++ b/snolab/collection_efficiency/presentation/SNOLAB_R4_collection_efficiency_20260910.pptx
@@ -589,7 +589,7 @@
           <a:lstStyle/>
           <a:p>
             <a:r>
-              <a:t>Grey: ten channels that fit ≥ 95% of events, 1827 events, 3162 eV = 30.5%, width 7.5% — the position dependence cancels in the sum. PDS2 fits only 42% (the swing) and on those events the other ten channels are 4.8% low, so its share is a bracket: 31.5 to 32.9%. Red line 10.37 keV.</a:t>
+              <a:t>Grey: ten channels that fit ≥ 95% of events, 1827 events, 3162 eV = 30.5%, width 7.5% — the position dependence cancels in the sum. Uncertainty = sigma/mu of the Gaussian fit, 7.5% (Prof. Liu). PDS2 fits only 42%, and those are events near it, so it is left out. Red line 10.37 keV.</a:t>
             </a:r>
           </a:p>
         </p:txBody>
@@ -659,7 +659,7 @@
           <a:lstStyle/>
           <a:p>
             <a:r>
-              <a:t>Chain: current -&gt; power -&gt; energy -&gt; sum -&gt; 32 ± 1%. R37 CUTE note: 26-41%. Open: Z7 only; HV bias unknown (0 V assumed); no dIdV, inductor term dropped; PDS2; 12.5% of events fit nowhere.</a:t>
+              <a:t>Chain: current -&gt; power -&gt; energy -&gt; sum over 10 channels -&gt; 30.5% (sigma/mu 7.5%). R37 CUTE note: 26-41%. Open: Z7 only; HV bias unknown (0 V assumed); no dIdV, inductor term dropped; PDS2; 12.5% of events fit nowhere.</a:t>
             </a:r>
           </a:p>
         </p:txBody>
@@ -4871,7 +4871,7 @@
                 </a:solidFill>
                 <a:latin typeface="Arial"/>
               </a:rPr>
-              <a:t>Summed over the channels: 32 ± 1 %</a:t>
+              <a:t>Summed over the channels: 30.5 %</a:t>
             </a:r>
           </a:p>
           <a:p>
@@ -4980,8 +4980,8 @@
         </p:blipFill>
         <p:spPr>
           <a:xfrm>
-            <a:off x="502920" y="1267932"/>
-            <a:ext cx="8046720" cy="5145096"/>
+            <a:off x="502920" y="1173806"/>
+            <a:ext cx="8046719" cy="5333348"/>
           </a:xfrm>
           <a:prstGeom prst="rect">
             <a:avLst/>
@@ -5038,7 +5038,7 @@
                 </a:solidFill>
                 <a:latin typeface="Arial"/>
               </a:rPr>
-              <a:t>PDS2 fits only 42 % of the events (that slow swing), and those events are not typical; its share can only be bracketed.</a:t>
+              <a:t>PDS2 is left out: only 42 % of its events can be fitted, and those are the events that happened near it.</a:t>
             </a:r>
           </a:p>
           <a:p>
@@ -5054,7 +5054,8 @@
                 </a:solidFill>
                 <a:latin typeface="Arial"/>
               </a:rPr>
-              <a:t>Full efficiency 31.5–32.9 %:  32 ± 1 %.</a:t>
+              <a:t>Collection efficiency:
+30.5 % ± 2.3 %  (σ/μ = 7.5 %).</a:t>
             </a:r>
           </a:p>
           <a:p>
@@ -5270,7 +5271,7 @@
                 </a:solidFill>
                 <a:latin typeface="Arial"/>
               </a:rPr>
-              <a:t>Z7 absorbs 32 ± 1 % of a 10.37 keV event in its TESs.   The CDMS note reports 26–41 % on the R37 CUTE tower.</a:t>
+              <a:t>Z7 absorbs 30.5 % ± 2.3 % (σ/μ = 7.5 %) of a 10.37 keV event in its TESs, summed over 10 channels.   The CDMS note reports 26–41 % on the R37 CUTE tower.</a:t>
             </a:r>
           </a:p>
           <a:p>
@@ -5286,7 +5287,7 @@
                 </a:solidFill>
                 <a:latin typeface="Arial"/>
               </a:rPr>
-              <a:t>Open: Z7 only · the bias of Z7 is not established (0 V assumed) · no dI/dV · PDS2 is the ± 1 % · 12.5 % of events fit in no channel.</a:t>
+              <a:t>Open: Z7 only · the bias of Z7 is not established (0 V assumed) · no dI/dV · PDS2 not included · 12.5 % of events fit in no channel.</a:t>
             </a:r>
           </a:p>
         </p:txBody>
@@ -5623,7 +5624,7 @@
                 </a:solidFill>
                 <a:latin typeface="Arial"/>
               </a:rPr>
-              <a:t>The two differ only in the quadratic term: 1.7 % in energy (PBS1, median of 15 events) — far below the 15 % single-channel width and the PDS2 bracket.</a:t>
+              <a:t>The two differ only in the quadratic term: 1.7 % in energy (PBS1, median of 15 events) — far below the 15 % single-channel width and the 7.5 % width of the sum.</a:t>
             </a:r>
           </a:p>
           <a:p>

</xml_diff>